<commit_message>
Added Yash part - Reliability and Scalability qualities - final version pending
</commit_message>
<xml_diff>
--- a/M2/Presentation_Qualities.pptx
+++ b/M2/Presentation_Qualities.pptx
@@ -5,7 +5,7 @@
     <p:sldMasterId id="2147483648" r:id="rId1"/>
   </p:sldMasterIdLst>
   <p:notesMasterIdLst>
-    <p:notesMasterId r:id="rId15"/>
+    <p:notesMasterId r:id="rId19"/>
   </p:notesMasterIdLst>
   <p:sldIdLst>
     <p:sldId id="256" r:id="rId2"/>
@@ -21,6 +21,10 @@
     <p:sldId id="267" r:id="rId12"/>
     <p:sldId id="268" r:id="rId13"/>
     <p:sldId id="269" r:id="rId14"/>
+    <p:sldId id="271" r:id="rId15"/>
+    <p:sldId id="272" r:id="rId16"/>
+    <p:sldId id="273" r:id="rId17"/>
+    <p:sldId id="274" r:id="rId18"/>
   </p:sldIdLst>
   <p:sldSz cx="12192000" cy="6858000"/>
   <p:notesSz cx="6858000" cy="9144000"/>
@@ -705,7 +709,7 @@
           <a:p>
             <a:fld id="{FC1B7745-5391-477F-8AE8-1136866A9302}" type="datetimeFigureOut">
               <a:rPr lang="es-ES" smtClean="0"/>
-              <a:t>04/01/2026</a:t>
+              <a:t>4/1/26</a:t>
             </a:fld>
             <a:endParaRPr lang="es-ES"/>
           </a:p>
@@ -1203,7 +1207,7 @@
           <a:p>
             <a:fld id="{6A3C2F7B-537C-4500-BF1F-DDEBE70AF5A2}" type="datetimeFigureOut">
               <a:rPr lang="es-ES" smtClean="0"/>
-              <a:t>04/01/2026</a:t>
+              <a:t>4/1/26</a:t>
             </a:fld>
             <a:endParaRPr lang="es-ES"/>
           </a:p>
@@ -1401,7 +1405,7 @@
           <a:p>
             <a:fld id="{6A3C2F7B-537C-4500-BF1F-DDEBE70AF5A2}" type="datetimeFigureOut">
               <a:rPr lang="es-ES" smtClean="0"/>
-              <a:t>04/01/2026</a:t>
+              <a:t>4/1/26</a:t>
             </a:fld>
             <a:endParaRPr lang="es-ES"/>
           </a:p>
@@ -1609,7 +1613,7 @@
           <a:p>
             <a:fld id="{6A3C2F7B-537C-4500-BF1F-DDEBE70AF5A2}" type="datetimeFigureOut">
               <a:rPr lang="es-ES" smtClean="0"/>
-              <a:t>04/01/2026</a:t>
+              <a:t>4/1/26</a:t>
             </a:fld>
             <a:endParaRPr lang="es-ES"/>
           </a:p>
@@ -1807,7 +1811,7 @@
           <a:p>
             <a:fld id="{6A3C2F7B-537C-4500-BF1F-DDEBE70AF5A2}" type="datetimeFigureOut">
               <a:rPr lang="es-ES" smtClean="0"/>
-              <a:t>04/01/2026</a:t>
+              <a:t>4/1/26</a:t>
             </a:fld>
             <a:endParaRPr lang="es-ES"/>
           </a:p>
@@ -2082,7 +2086,7 @@
           <a:p>
             <a:fld id="{6A3C2F7B-537C-4500-BF1F-DDEBE70AF5A2}" type="datetimeFigureOut">
               <a:rPr lang="es-ES" smtClean="0"/>
-              <a:t>04/01/2026</a:t>
+              <a:t>4/1/26</a:t>
             </a:fld>
             <a:endParaRPr lang="es-ES"/>
           </a:p>
@@ -2347,7 +2351,7 @@
           <a:p>
             <a:fld id="{6A3C2F7B-537C-4500-BF1F-DDEBE70AF5A2}" type="datetimeFigureOut">
               <a:rPr lang="es-ES" smtClean="0"/>
-              <a:t>04/01/2026</a:t>
+              <a:t>4/1/26</a:t>
             </a:fld>
             <a:endParaRPr lang="es-ES"/>
           </a:p>
@@ -2759,7 +2763,7 @@
           <a:p>
             <a:fld id="{6A3C2F7B-537C-4500-BF1F-DDEBE70AF5A2}" type="datetimeFigureOut">
               <a:rPr lang="es-ES" smtClean="0"/>
-              <a:t>04/01/2026</a:t>
+              <a:t>4/1/26</a:t>
             </a:fld>
             <a:endParaRPr lang="es-ES"/>
           </a:p>
@@ -2900,7 +2904,7 @@
           <a:p>
             <a:fld id="{6A3C2F7B-537C-4500-BF1F-DDEBE70AF5A2}" type="datetimeFigureOut">
               <a:rPr lang="es-ES" smtClean="0"/>
-              <a:t>04/01/2026</a:t>
+              <a:t>4/1/26</a:t>
             </a:fld>
             <a:endParaRPr lang="es-ES"/>
           </a:p>
@@ -3013,7 +3017,7 @@
           <a:p>
             <a:fld id="{6A3C2F7B-537C-4500-BF1F-DDEBE70AF5A2}" type="datetimeFigureOut">
               <a:rPr lang="es-ES" smtClean="0"/>
-              <a:t>04/01/2026</a:t>
+              <a:t>4/1/26</a:t>
             </a:fld>
             <a:endParaRPr lang="es-ES"/>
           </a:p>
@@ -3324,7 +3328,7 @@
           <a:p>
             <a:fld id="{6A3C2F7B-537C-4500-BF1F-DDEBE70AF5A2}" type="datetimeFigureOut">
               <a:rPr lang="es-ES" smtClean="0"/>
-              <a:t>04/01/2026</a:t>
+              <a:t>4/1/26</a:t>
             </a:fld>
             <a:endParaRPr lang="es-ES"/>
           </a:p>
@@ -3612,7 +3616,7 @@
           <a:p>
             <a:fld id="{6A3C2F7B-537C-4500-BF1F-DDEBE70AF5A2}" type="datetimeFigureOut">
               <a:rPr lang="es-ES" smtClean="0"/>
-              <a:t>04/01/2026</a:t>
+              <a:t>4/1/26</a:t>
             </a:fld>
             <a:endParaRPr lang="es-ES"/>
           </a:p>
@@ -3853,7 +3857,7 @@
           <a:p>
             <a:fld id="{6A3C2F7B-537C-4500-BF1F-DDEBE70AF5A2}" type="datetimeFigureOut">
               <a:rPr lang="es-ES" smtClean="0"/>
-              <a:t>04/01/2026</a:t>
+              <a:t>4/1/26</a:t>
             </a:fld>
             <a:endParaRPr lang="es-ES"/>
           </a:p>
@@ -4765,6 +4769,1121 @@
 </p:sld>
 </file>
 
+<file path=ppt/slides/slide14.xml><?xml version="1.0" encoding="utf-8"?>
+<p:sld xmlns:a="http://schemas.openxmlformats.org/drawingml/2006/main" xmlns:r="http://schemas.openxmlformats.org/officeDocument/2006/relationships" xmlns:p="http://schemas.openxmlformats.org/presentationml/2006/main">
+  <p:cSld>
+    <p:spTree>
+      <p:nvGrpSpPr>
+        <p:cNvPr id="1" name=""/>
+        <p:cNvGrpSpPr/>
+        <p:nvPr/>
+      </p:nvGrpSpPr>
+      <p:grpSpPr>
+        <a:xfrm>
+          <a:off x="0" y="0"/>
+          <a:ext cx="0" cy="0"/>
+          <a:chOff x="0" y="0"/>
+          <a:chExt cx="0" cy="0"/>
+        </a:xfrm>
+      </p:grpSpPr>
+      <p:sp>
+        <p:nvSpPr>
+          <p:cNvPr id="2" name="Title 1">
+            <a:extLst>
+              <a:ext uri="{FF2B5EF4-FFF2-40B4-BE49-F238E27FC236}">
+                <a16:creationId xmlns:a16="http://schemas.microsoft.com/office/drawing/2014/main" id="{BBF5A8BF-6192-B19B-A2C6-CDA80A202DF4}"/>
+              </a:ext>
+            </a:extLst>
+          </p:cNvPr>
+          <p:cNvSpPr>
+            <a:spLocks noGrp="1"/>
+          </p:cNvSpPr>
+          <p:nvPr>
+            <p:ph type="title"/>
+          </p:nvPr>
+        </p:nvSpPr>
+        <p:spPr>
+          <a:xfrm>
+            <a:off x="838200" y="371904"/>
+            <a:ext cx="10515600" cy="1325563"/>
+          </a:xfrm>
+        </p:spPr>
+        <p:txBody>
+          <a:bodyPr/>
+          <a:lstStyle/>
+          <a:p>
+            <a:r>
+              <a:rPr lang="es-ES" dirty="0"/>
+              <a:t>RELIABILITY PROBLEM</a:t>
+            </a:r>
+            <a:endParaRPr lang="en-US" dirty="0"/>
+          </a:p>
+        </p:txBody>
+      </p:sp>
+      <p:sp>
+        <p:nvSpPr>
+          <p:cNvPr id="3" name="Content Placeholder 2">
+            <a:extLst>
+              <a:ext uri="{FF2B5EF4-FFF2-40B4-BE49-F238E27FC236}">
+                <a16:creationId xmlns:a16="http://schemas.microsoft.com/office/drawing/2014/main" id="{D4E7DA52-6770-12C8-9262-6A9C1DD7109B}"/>
+              </a:ext>
+            </a:extLst>
+          </p:cNvPr>
+          <p:cNvSpPr>
+            <a:spLocks noGrp="1"/>
+          </p:cNvSpPr>
+          <p:nvPr>
+            <p:ph idx="1"/>
+          </p:nvPr>
+        </p:nvSpPr>
+        <p:spPr>
+          <a:xfrm>
+            <a:off x="838200" y="1410227"/>
+            <a:ext cx="6872416" cy="2676118"/>
+          </a:xfrm>
+        </p:spPr>
+        <p:txBody>
+          <a:bodyPr>
+            <a:normAutofit/>
+          </a:bodyPr>
+          <a:lstStyle/>
+          <a:p>
+            <a:pPr marL="0" indent="0">
+              <a:buNone/>
+            </a:pPr>
+            <a:r>
+              <a:rPr lang="en-IN" sz="1400" dirty="0"/>
+              <a:t>During peak usage (e.g. after grade publication or before exam registration deadlines), external systems such as the </a:t>
+            </a:r>
+            <a:r>
+              <a:rPr lang="en-IN" sz="1400" b="1" dirty="0"/>
+              <a:t>Student Information System (SIS)</a:t>
+            </a:r>
+            <a:r>
+              <a:rPr lang="en-IN" sz="1400" dirty="0"/>
+              <a:t> or the </a:t>
+            </a:r>
+            <a:r>
+              <a:rPr lang="en-IN" sz="1400" b="1" dirty="0"/>
+              <a:t>Timetable Service</a:t>
+            </a:r>
+            <a:r>
+              <a:rPr lang="en-IN" sz="1400" dirty="0"/>
+              <a:t> may become temporarily unavailable or respond slowly.</a:t>
+            </a:r>
+            <a:br>
+              <a:rPr lang="en-IN" sz="1400" dirty="0"/>
+            </a:br>
+            <a:r>
+              <a:rPr lang="en-IN" sz="1400" dirty="0"/>
+              <a:t>When this happens, core EXA functionality (registration, result viewing, or grading workflows) may fail or hang due to synchronous dependencies on these external services.</a:t>
+            </a:r>
+          </a:p>
+          <a:p>
+            <a:endParaRPr lang="en-US" sz="1400" dirty="0"/>
+          </a:p>
+        </p:txBody>
+      </p:sp>
+      <p:sp>
+        <p:nvSpPr>
+          <p:cNvPr id="4" name="Content Placeholder 2">
+            <a:extLst>
+              <a:ext uri="{FF2B5EF4-FFF2-40B4-BE49-F238E27FC236}">
+                <a16:creationId xmlns:a16="http://schemas.microsoft.com/office/drawing/2014/main" id="{76EA7DAE-2384-CF0F-BD90-CCE4EE120430}"/>
+              </a:ext>
+            </a:extLst>
+          </p:cNvPr>
+          <p:cNvSpPr txBox="1">
+            <a:spLocks/>
+          </p:cNvSpPr>
+          <p:nvPr/>
+        </p:nvSpPr>
+        <p:spPr>
+          <a:xfrm>
+            <a:off x="838200" y="2748286"/>
+            <a:ext cx="6872416" cy="3985654"/>
+          </a:xfrm>
+          <a:prstGeom prst="rect">
+            <a:avLst/>
+          </a:prstGeom>
+        </p:spPr>
+        <p:txBody>
+          <a:bodyPr vert="horz" lIns="91440" tIns="45720" rIns="91440" bIns="45720" rtlCol="0">
+            <a:normAutofit/>
+          </a:bodyPr>
+          <a:lstStyle>
+            <a:lvl1pPr marL="228600" indent="-228600" algn="l" defTabSz="914400" rtl="0" eaLnBrk="1" latinLnBrk="0" hangingPunct="1">
+              <a:lnSpc>
+                <a:spcPct val="90000"/>
+              </a:lnSpc>
+              <a:spcBef>
+                <a:spcPts val="1000"/>
+              </a:spcBef>
+              <a:buFont typeface="Arial" panose="020B0604020202020204" pitchFamily="34" charset="0"/>
+              <a:buChar char="•"/>
+              <a:defRPr sz="2800" kern="1200">
+                <a:solidFill>
+                  <a:schemeClr val="tx1"/>
+                </a:solidFill>
+                <a:latin typeface="+mn-lt"/>
+                <a:ea typeface="+mn-ea"/>
+                <a:cs typeface="+mn-cs"/>
+              </a:defRPr>
+            </a:lvl1pPr>
+            <a:lvl2pPr marL="685800" indent="-228600" algn="l" defTabSz="914400" rtl="0" eaLnBrk="1" latinLnBrk="0" hangingPunct="1">
+              <a:lnSpc>
+                <a:spcPct val="90000"/>
+              </a:lnSpc>
+              <a:spcBef>
+                <a:spcPts val="500"/>
+              </a:spcBef>
+              <a:buFont typeface="Arial" panose="020B0604020202020204" pitchFamily="34" charset="0"/>
+              <a:buChar char="•"/>
+              <a:defRPr sz="2400" kern="1200">
+                <a:solidFill>
+                  <a:schemeClr val="tx1"/>
+                </a:solidFill>
+                <a:latin typeface="+mn-lt"/>
+                <a:ea typeface="+mn-ea"/>
+                <a:cs typeface="+mn-cs"/>
+              </a:defRPr>
+            </a:lvl2pPr>
+            <a:lvl3pPr marL="1143000" indent="-228600" algn="l" defTabSz="914400" rtl="0" eaLnBrk="1" latinLnBrk="0" hangingPunct="1">
+              <a:lnSpc>
+                <a:spcPct val="90000"/>
+              </a:lnSpc>
+              <a:spcBef>
+                <a:spcPts val="500"/>
+              </a:spcBef>
+              <a:buFont typeface="Arial" panose="020B0604020202020204" pitchFamily="34" charset="0"/>
+              <a:buChar char="•"/>
+              <a:defRPr sz="2000" kern="1200">
+                <a:solidFill>
+                  <a:schemeClr val="tx1"/>
+                </a:solidFill>
+                <a:latin typeface="+mn-lt"/>
+                <a:ea typeface="+mn-ea"/>
+                <a:cs typeface="+mn-cs"/>
+              </a:defRPr>
+            </a:lvl3pPr>
+            <a:lvl4pPr marL="1600200" indent="-228600" algn="l" defTabSz="914400" rtl="0" eaLnBrk="1" latinLnBrk="0" hangingPunct="1">
+              <a:lnSpc>
+                <a:spcPct val="90000"/>
+              </a:lnSpc>
+              <a:spcBef>
+                <a:spcPts val="500"/>
+              </a:spcBef>
+              <a:buFont typeface="Arial" panose="020B0604020202020204" pitchFamily="34" charset="0"/>
+              <a:buChar char="•"/>
+              <a:defRPr sz="1800" kern="1200">
+                <a:solidFill>
+                  <a:schemeClr val="tx1"/>
+                </a:solidFill>
+                <a:latin typeface="+mn-lt"/>
+                <a:ea typeface="+mn-ea"/>
+                <a:cs typeface="+mn-cs"/>
+              </a:defRPr>
+            </a:lvl4pPr>
+            <a:lvl5pPr marL="2057400" indent="-228600" algn="l" defTabSz="914400" rtl="0" eaLnBrk="1" latinLnBrk="0" hangingPunct="1">
+              <a:lnSpc>
+                <a:spcPct val="90000"/>
+              </a:lnSpc>
+              <a:spcBef>
+                <a:spcPts val="500"/>
+              </a:spcBef>
+              <a:buFont typeface="Arial" panose="020B0604020202020204" pitchFamily="34" charset="0"/>
+              <a:buChar char="•"/>
+              <a:defRPr sz="1800" kern="1200">
+                <a:solidFill>
+                  <a:schemeClr val="tx1"/>
+                </a:solidFill>
+                <a:latin typeface="+mn-lt"/>
+                <a:ea typeface="+mn-ea"/>
+                <a:cs typeface="+mn-cs"/>
+              </a:defRPr>
+            </a:lvl5pPr>
+            <a:lvl6pPr marL="2514600" indent="-228600" algn="l" defTabSz="914400" rtl="0" eaLnBrk="1" latinLnBrk="0" hangingPunct="1">
+              <a:lnSpc>
+                <a:spcPct val="90000"/>
+              </a:lnSpc>
+              <a:spcBef>
+                <a:spcPts val="500"/>
+              </a:spcBef>
+              <a:buFont typeface="Arial" panose="020B0604020202020204" pitchFamily="34" charset="0"/>
+              <a:buChar char="•"/>
+              <a:defRPr sz="1800" kern="1200">
+                <a:solidFill>
+                  <a:schemeClr val="tx1"/>
+                </a:solidFill>
+                <a:latin typeface="+mn-lt"/>
+                <a:ea typeface="+mn-ea"/>
+                <a:cs typeface="+mn-cs"/>
+              </a:defRPr>
+            </a:lvl6pPr>
+            <a:lvl7pPr marL="2971800" indent="-228600" algn="l" defTabSz="914400" rtl="0" eaLnBrk="1" latinLnBrk="0" hangingPunct="1">
+              <a:lnSpc>
+                <a:spcPct val="90000"/>
+              </a:lnSpc>
+              <a:spcBef>
+                <a:spcPts val="500"/>
+              </a:spcBef>
+              <a:buFont typeface="Arial" panose="020B0604020202020204" pitchFamily="34" charset="0"/>
+              <a:buChar char="•"/>
+              <a:defRPr sz="1800" kern="1200">
+                <a:solidFill>
+                  <a:schemeClr val="tx1"/>
+                </a:solidFill>
+                <a:latin typeface="+mn-lt"/>
+                <a:ea typeface="+mn-ea"/>
+                <a:cs typeface="+mn-cs"/>
+              </a:defRPr>
+            </a:lvl7pPr>
+            <a:lvl8pPr marL="3429000" indent="-228600" algn="l" defTabSz="914400" rtl="0" eaLnBrk="1" latinLnBrk="0" hangingPunct="1">
+              <a:lnSpc>
+                <a:spcPct val="90000"/>
+              </a:lnSpc>
+              <a:spcBef>
+                <a:spcPts val="500"/>
+              </a:spcBef>
+              <a:buFont typeface="Arial" panose="020B0604020202020204" pitchFamily="34" charset="0"/>
+              <a:buChar char="•"/>
+              <a:defRPr sz="1800" kern="1200">
+                <a:solidFill>
+                  <a:schemeClr val="tx1"/>
+                </a:solidFill>
+                <a:latin typeface="+mn-lt"/>
+                <a:ea typeface="+mn-ea"/>
+                <a:cs typeface="+mn-cs"/>
+              </a:defRPr>
+            </a:lvl8pPr>
+            <a:lvl9pPr marL="3886200" indent="-228600" algn="l" defTabSz="914400" rtl="0" eaLnBrk="1" latinLnBrk="0" hangingPunct="1">
+              <a:lnSpc>
+                <a:spcPct val="90000"/>
+              </a:lnSpc>
+              <a:spcBef>
+                <a:spcPts val="500"/>
+              </a:spcBef>
+              <a:buFont typeface="Arial" panose="020B0604020202020204" pitchFamily="34" charset="0"/>
+              <a:buChar char="•"/>
+              <a:defRPr sz="1800" kern="1200">
+                <a:solidFill>
+                  <a:schemeClr val="tx1"/>
+                </a:solidFill>
+                <a:latin typeface="+mn-lt"/>
+                <a:ea typeface="+mn-ea"/>
+                <a:cs typeface="+mn-cs"/>
+              </a:defRPr>
+            </a:lvl9pPr>
+          </a:lstStyle>
+          <a:p>
+            <a:r>
+              <a:rPr lang="en-IN" sz="1400" b="1" dirty="0"/>
+              <a:t>Involved Users:</a:t>
+            </a:r>
+            <a:br>
+              <a:rPr lang="en-IN" sz="1400" dirty="0"/>
+            </a:br>
+            <a:r>
+              <a:rPr lang="en-IN" sz="1400" dirty="0"/>
+              <a:t>Student, Teacher</a:t>
+            </a:r>
+          </a:p>
+          <a:p>
+            <a:r>
+              <a:rPr lang="en-IN" sz="1400" b="1" dirty="0"/>
+              <a:t>Affected System Parts:</a:t>
+            </a:r>
+            <a:br>
+              <a:rPr lang="en-IN" sz="1400" dirty="0"/>
+            </a:br>
+            <a:r>
+              <a:rPr lang="en-IN" sz="1400" b="1" i="1" u="sng" dirty="0"/>
+              <a:t>1. In Backend API:</a:t>
+            </a:r>
+          </a:p>
+          <a:p>
+            <a:pPr>
+              <a:buFont typeface="Arial" panose="020B0604020202020204" pitchFamily="34" charset="0"/>
+              <a:buChar char="•"/>
+            </a:pPr>
+            <a:r>
+              <a:rPr lang="en-IN" sz="1400" dirty="0"/>
+              <a:t>Integration Adapter</a:t>
+            </a:r>
+          </a:p>
+          <a:p>
+            <a:pPr>
+              <a:buFont typeface="Arial" panose="020B0604020202020204" pitchFamily="34" charset="0"/>
+              <a:buChar char="•"/>
+            </a:pPr>
+            <a:r>
+              <a:rPr lang="en-IN" sz="1400" dirty="0"/>
+              <a:t>Registration Management</a:t>
+            </a:r>
+          </a:p>
+          <a:p>
+            <a:pPr>
+              <a:buFont typeface="Arial" panose="020B0604020202020204" pitchFamily="34" charset="0"/>
+              <a:buChar char="•"/>
+            </a:pPr>
+            <a:r>
+              <a:rPr lang="en-IN" sz="1400" dirty="0"/>
+              <a:t>Grading Management</a:t>
+            </a:r>
+          </a:p>
+          <a:p>
+            <a:pPr>
+              <a:buFont typeface="Arial" panose="020B0604020202020204" pitchFamily="34" charset="0"/>
+              <a:buChar char="•"/>
+            </a:pPr>
+            <a:r>
+              <a:rPr lang="en-IN" sz="1400" dirty="0"/>
+              <a:t>Result Viewing</a:t>
+            </a:r>
+          </a:p>
+          <a:p>
+            <a:pPr marL="0" indent="0">
+              <a:buNone/>
+            </a:pPr>
+            <a:r>
+              <a:rPr lang="en-IN" sz="1400" dirty="0"/>
+              <a:t>       </a:t>
+            </a:r>
+            <a:r>
+              <a:rPr lang="en-IN" sz="1400" b="1" i="1" u="sng" dirty="0"/>
+              <a:t>2. In External Systems:</a:t>
+            </a:r>
+          </a:p>
+          <a:p>
+            <a:pPr>
+              <a:buFont typeface="Arial" panose="020B0604020202020204" pitchFamily="34" charset="0"/>
+              <a:buChar char="•"/>
+            </a:pPr>
+            <a:r>
+              <a:rPr lang="en-IN" sz="1400" dirty="0"/>
+              <a:t>Student Information System (SIS)</a:t>
+            </a:r>
+          </a:p>
+          <a:p>
+            <a:pPr>
+              <a:buFont typeface="Arial" panose="020B0604020202020204" pitchFamily="34" charset="0"/>
+              <a:buChar char="•"/>
+            </a:pPr>
+            <a:r>
+              <a:rPr lang="en-IN" sz="1400" dirty="0"/>
+              <a:t>Timetable Service</a:t>
+            </a:r>
+          </a:p>
+          <a:p>
+            <a:r>
+              <a:rPr lang="en-IN" sz="1400" dirty="0"/>
+              <a:t>The current architecture allows failures in external systems to propagate into EXA, reducing overall system reliability and potentially blocking critical academic processes.</a:t>
+            </a:r>
+          </a:p>
+        </p:txBody>
+      </p:sp>
+    </p:spTree>
+    <p:extLst>
+      <p:ext uri="{BB962C8B-B14F-4D97-AF65-F5344CB8AC3E}">
+        <p14:creationId xmlns:p14="http://schemas.microsoft.com/office/powerpoint/2010/main" val="1850926752"/>
+      </p:ext>
+    </p:extLst>
+  </p:cSld>
+  <p:clrMapOvr>
+    <a:masterClrMapping/>
+  </p:clrMapOvr>
+</p:sld>
+</file>
+
+<file path=ppt/slides/slide15.xml><?xml version="1.0" encoding="utf-8"?>
+<p:sld xmlns:a="http://schemas.openxmlformats.org/drawingml/2006/main" xmlns:r="http://schemas.openxmlformats.org/officeDocument/2006/relationships" xmlns:p="http://schemas.openxmlformats.org/presentationml/2006/main">
+  <p:cSld>
+    <p:spTree>
+      <p:nvGrpSpPr>
+        <p:cNvPr id="1" name=""/>
+        <p:cNvGrpSpPr/>
+        <p:nvPr/>
+      </p:nvGrpSpPr>
+      <p:grpSpPr>
+        <a:xfrm>
+          <a:off x="0" y="0"/>
+          <a:ext cx="0" cy="0"/>
+          <a:chOff x="0" y="0"/>
+          <a:chExt cx="0" cy="0"/>
+        </a:xfrm>
+      </p:grpSpPr>
+      <p:sp>
+        <p:nvSpPr>
+          <p:cNvPr id="2" name="Title 1">
+            <a:extLst>
+              <a:ext uri="{FF2B5EF4-FFF2-40B4-BE49-F238E27FC236}">
+                <a16:creationId xmlns:a16="http://schemas.microsoft.com/office/drawing/2014/main" id="{7861492E-D05F-0551-FB12-98F52F4AA679}"/>
+              </a:ext>
+            </a:extLst>
+          </p:cNvPr>
+          <p:cNvSpPr>
+            <a:spLocks noGrp="1"/>
+          </p:cNvSpPr>
+          <p:nvPr>
+            <p:ph type="title"/>
+          </p:nvPr>
+        </p:nvSpPr>
+        <p:spPr/>
+        <p:txBody>
+          <a:bodyPr/>
+          <a:lstStyle/>
+          <a:p>
+            <a:r>
+              <a:rPr lang="en-US" dirty="0"/>
+              <a:t>RELIABILITY PROBLEM - SOLUTION</a:t>
+            </a:r>
+          </a:p>
+        </p:txBody>
+      </p:sp>
+      <p:sp>
+        <p:nvSpPr>
+          <p:cNvPr id="3" name="Content Placeholder 2">
+            <a:extLst>
+              <a:ext uri="{FF2B5EF4-FFF2-40B4-BE49-F238E27FC236}">
+                <a16:creationId xmlns:a16="http://schemas.microsoft.com/office/drawing/2014/main" id="{986C3049-3CFB-C0C6-6DEA-D54AF5767D8C}"/>
+              </a:ext>
+            </a:extLst>
+          </p:cNvPr>
+          <p:cNvSpPr>
+            <a:spLocks noGrp="1"/>
+          </p:cNvSpPr>
+          <p:nvPr>
+            <p:ph idx="1"/>
+          </p:nvPr>
+        </p:nvSpPr>
+        <p:spPr>
+          <a:xfrm>
+            <a:off x="838200" y="1576301"/>
+            <a:ext cx="10515600" cy="4916574"/>
+          </a:xfrm>
+        </p:spPr>
+        <p:txBody>
+          <a:bodyPr>
+            <a:normAutofit/>
+          </a:bodyPr>
+          <a:lstStyle/>
+          <a:p>
+            <a:pPr>
+              <a:buFont typeface="Arial" panose="020B0604020202020204" pitchFamily="34" charset="0"/>
+              <a:buChar char="•"/>
+            </a:pPr>
+            <a:r>
+              <a:rPr lang="en-IN" sz="1600" dirty="0"/>
+              <a:t>The solution introduces </a:t>
+            </a:r>
+            <a:r>
+              <a:rPr lang="en-IN" sz="1600" b="1" dirty="0"/>
+              <a:t>fault-tolerance mechanisms</a:t>
+            </a:r>
+            <a:r>
+              <a:rPr lang="en-IN" sz="1600" dirty="0"/>
+              <a:t> at the Integration Adapter level. All communication with external systems is guarded by :</a:t>
+            </a:r>
+          </a:p>
+          <a:p>
+            <a:pPr marL="742950" lvl="1" indent="-285750">
+              <a:buFont typeface="Arial" panose="020B0604020202020204" pitchFamily="34" charset="0"/>
+              <a:buChar char="•"/>
+            </a:pPr>
+            <a:r>
+              <a:rPr lang="en-IN" sz="1600" dirty="0"/>
+              <a:t>timeouts</a:t>
+            </a:r>
+          </a:p>
+          <a:p>
+            <a:pPr marL="742950" lvl="1" indent="-285750">
+              <a:buFont typeface="Arial" panose="020B0604020202020204" pitchFamily="34" charset="0"/>
+              <a:buChar char="•"/>
+            </a:pPr>
+            <a:r>
+              <a:rPr lang="en-IN" sz="1600" dirty="0"/>
+              <a:t>retries with backoff</a:t>
+            </a:r>
+          </a:p>
+          <a:p>
+            <a:pPr marL="742950" lvl="1" indent="-285750">
+              <a:buFont typeface="Arial" panose="020B0604020202020204" pitchFamily="34" charset="0"/>
+              <a:buChar char="•"/>
+            </a:pPr>
+            <a:r>
+              <a:rPr lang="en-IN" sz="1600" dirty="0"/>
+              <a:t>circuit breakers</a:t>
+            </a:r>
+          </a:p>
+          <a:p>
+            <a:pPr>
+              <a:buFontTx/>
+              <a:buChar char="-"/>
+            </a:pPr>
+            <a:r>
+              <a:rPr lang="en-IN" sz="1600" dirty="0"/>
+              <a:t>If an external system is unavailable, the Integration Adapter either:</a:t>
+            </a:r>
+          </a:p>
+          <a:p>
+            <a:pPr>
+              <a:buFontTx/>
+              <a:buChar char="-"/>
+            </a:pPr>
+            <a:r>
+              <a:rPr lang="en-IN" sz="1600" dirty="0"/>
+              <a:t>returns cached or last-known-valid data where possible or fails fast and allows the calling business component to continue in a degraded but controlled mode.</a:t>
+            </a:r>
+          </a:p>
+          <a:p>
+            <a:pPr>
+              <a:buFontTx/>
+              <a:buChar char="-"/>
+            </a:pPr>
+            <a:r>
+              <a:rPr lang="en-IN" sz="1600" dirty="0"/>
+              <a:t>This prevents cascading failures, ensures that EXA remains operational for core use cases, and significantly improves system reliability even when external dependencies are unstable.</a:t>
+            </a:r>
+          </a:p>
+          <a:p>
+            <a:pPr marL="0" indent="0">
+              <a:buNone/>
+            </a:pPr>
+            <a:r>
+              <a:rPr lang="en-IN" sz="1600" b="1" u="sng" dirty="0"/>
+              <a:t>Result : </a:t>
+            </a:r>
+          </a:p>
+          <a:p>
+            <a:pPr>
+              <a:buFont typeface="Arial" panose="020B0604020202020204" pitchFamily="34" charset="0"/>
+              <a:buChar char="•"/>
+            </a:pPr>
+            <a:r>
+              <a:rPr lang="en-IN" sz="1600" dirty="0"/>
+              <a:t>External system outages are </a:t>
+            </a:r>
+            <a:r>
+              <a:rPr lang="en-IN" sz="1600" b="1" dirty="0"/>
+              <a:t>isolated</a:t>
+            </a:r>
+            <a:r>
+              <a:rPr lang="en-IN" sz="1600" dirty="0"/>
+              <a:t> from the rest of EXA.</a:t>
+            </a:r>
+          </a:p>
+          <a:p>
+            <a:pPr>
+              <a:buFont typeface="Arial" panose="020B0604020202020204" pitchFamily="34" charset="0"/>
+              <a:buChar char="•"/>
+            </a:pPr>
+            <a:r>
+              <a:rPr lang="en-IN" sz="1600" dirty="0"/>
+              <a:t>Core functionality continues to operate in a </a:t>
+            </a:r>
+            <a:r>
+              <a:rPr lang="en-IN" sz="1600" b="1" dirty="0"/>
+              <a:t>controlled or degraded mode</a:t>
+            </a:r>
+            <a:r>
+              <a:rPr lang="en-IN" sz="1600" dirty="0"/>
+              <a:t>.</a:t>
+            </a:r>
+          </a:p>
+          <a:p>
+            <a:pPr>
+              <a:buFont typeface="Arial" panose="020B0604020202020204" pitchFamily="34" charset="0"/>
+              <a:buChar char="•"/>
+            </a:pPr>
+            <a:r>
+              <a:rPr lang="en-IN" sz="1600" dirty="0"/>
+              <a:t>The system remains reliable even when external dependencies are unstable.</a:t>
+            </a:r>
+          </a:p>
+          <a:p>
+            <a:endParaRPr lang="en-US" sz="1600" dirty="0"/>
+          </a:p>
+        </p:txBody>
+      </p:sp>
+    </p:spTree>
+    <p:extLst>
+      <p:ext uri="{BB962C8B-B14F-4D97-AF65-F5344CB8AC3E}">
+        <p14:creationId xmlns:p14="http://schemas.microsoft.com/office/powerpoint/2010/main" val="2424220181"/>
+      </p:ext>
+    </p:extLst>
+  </p:cSld>
+  <p:clrMapOvr>
+    <a:masterClrMapping/>
+  </p:clrMapOvr>
+</p:sld>
+</file>
+
+<file path=ppt/slides/slide16.xml><?xml version="1.0" encoding="utf-8"?>
+<p:sld xmlns:a="http://schemas.openxmlformats.org/drawingml/2006/main" xmlns:r="http://schemas.openxmlformats.org/officeDocument/2006/relationships" xmlns:p="http://schemas.openxmlformats.org/presentationml/2006/main">
+  <p:cSld>
+    <p:spTree>
+      <p:nvGrpSpPr>
+        <p:cNvPr id="1" name="">
+          <a:extLst>
+            <a:ext uri="{FF2B5EF4-FFF2-40B4-BE49-F238E27FC236}">
+              <a16:creationId xmlns:a16="http://schemas.microsoft.com/office/drawing/2014/main" id="{BED39D40-5BA7-2569-F1BD-6849E1830767}"/>
+            </a:ext>
+          </a:extLst>
+        </p:cNvPr>
+        <p:cNvGrpSpPr/>
+        <p:nvPr/>
+      </p:nvGrpSpPr>
+      <p:grpSpPr>
+        <a:xfrm>
+          <a:off x="0" y="0"/>
+          <a:ext cx="0" cy="0"/>
+          <a:chOff x="0" y="0"/>
+          <a:chExt cx="0" cy="0"/>
+        </a:xfrm>
+      </p:grpSpPr>
+      <p:sp>
+        <p:nvSpPr>
+          <p:cNvPr id="2" name="Title 1">
+            <a:extLst>
+              <a:ext uri="{FF2B5EF4-FFF2-40B4-BE49-F238E27FC236}">
+                <a16:creationId xmlns:a16="http://schemas.microsoft.com/office/drawing/2014/main" id="{4DB2F9C2-E074-AF8A-1377-DA20DFE3BF74}"/>
+              </a:ext>
+            </a:extLst>
+          </p:cNvPr>
+          <p:cNvSpPr>
+            <a:spLocks noGrp="1"/>
+          </p:cNvSpPr>
+          <p:nvPr>
+            <p:ph type="title"/>
+          </p:nvPr>
+        </p:nvSpPr>
+        <p:spPr/>
+        <p:txBody>
+          <a:bodyPr/>
+          <a:lstStyle/>
+          <a:p>
+            <a:r>
+              <a:rPr lang="en-US" dirty="0"/>
+              <a:t>SCALABILITY PROBLEM</a:t>
+            </a:r>
+          </a:p>
+        </p:txBody>
+      </p:sp>
+      <p:sp>
+        <p:nvSpPr>
+          <p:cNvPr id="3" name="Content Placeholder 2">
+            <a:extLst>
+              <a:ext uri="{FF2B5EF4-FFF2-40B4-BE49-F238E27FC236}">
+                <a16:creationId xmlns:a16="http://schemas.microsoft.com/office/drawing/2014/main" id="{507A19C4-06C0-422C-043A-49388C722F15}"/>
+              </a:ext>
+            </a:extLst>
+          </p:cNvPr>
+          <p:cNvSpPr>
+            <a:spLocks noGrp="1"/>
+          </p:cNvSpPr>
+          <p:nvPr>
+            <p:ph idx="1"/>
+          </p:nvPr>
+        </p:nvSpPr>
+        <p:spPr>
+          <a:xfrm>
+            <a:off x="838200" y="1576301"/>
+            <a:ext cx="5822092" cy="4916574"/>
+          </a:xfrm>
+        </p:spPr>
+        <p:txBody>
+          <a:bodyPr>
+            <a:normAutofit/>
+          </a:bodyPr>
+          <a:lstStyle/>
+          <a:p>
+            <a:pPr marL="0" indent="0">
+              <a:buNone/>
+            </a:pPr>
+            <a:r>
+              <a:rPr lang="en-IN" sz="1400" dirty="0"/>
+              <a:t>At predictable times such as the beginning of the semester or during exam registration openings, </a:t>
+            </a:r>
+            <a:r>
+              <a:rPr lang="en-IN" sz="1400" b="1" dirty="0"/>
+              <a:t>hundreds or thousands of students</a:t>
+            </a:r>
+            <a:r>
+              <a:rPr lang="en-IN" sz="1400" dirty="0"/>
+              <a:t> may simultaneously attempt to register for exam terms or view schedules.</a:t>
+            </a:r>
+            <a:br>
+              <a:rPr lang="en-IN" sz="1400" dirty="0"/>
+            </a:br>
+            <a:r>
+              <a:rPr lang="en-IN" sz="1400" dirty="0"/>
+              <a:t>This leads to sudden spikes in load on the Backend API, particularly on registration-related components and database access.</a:t>
+            </a:r>
+          </a:p>
+          <a:p>
+            <a:r>
+              <a:rPr lang="en-IN" sz="1400" b="1" dirty="0"/>
+              <a:t>Involved Users:</a:t>
+            </a:r>
+            <a:br>
+              <a:rPr lang="en-IN" sz="1400" dirty="0"/>
+            </a:br>
+            <a:r>
+              <a:rPr lang="en-IN" sz="1400" dirty="0"/>
+              <a:t>Student</a:t>
+            </a:r>
+          </a:p>
+          <a:p>
+            <a:r>
+              <a:rPr lang="en-IN" sz="1400" b="1" dirty="0"/>
+              <a:t>Affected System Parts:</a:t>
+            </a:r>
+            <a:br>
+              <a:rPr lang="en-IN" sz="1400" dirty="0"/>
+            </a:br>
+            <a:r>
+              <a:rPr lang="en-IN" sz="1400" b="1" i="1" u="sng" dirty="0"/>
+              <a:t>1. In Backend API:</a:t>
+            </a:r>
+          </a:p>
+          <a:p>
+            <a:pPr>
+              <a:buFont typeface="Arial" panose="020B0604020202020204" pitchFamily="34" charset="0"/>
+              <a:buChar char="•"/>
+            </a:pPr>
+            <a:r>
+              <a:rPr lang="en-IN" sz="1400" dirty="0"/>
+              <a:t>Registration Management</a:t>
+            </a:r>
+          </a:p>
+          <a:p>
+            <a:pPr>
+              <a:buFont typeface="Arial" panose="020B0604020202020204" pitchFamily="34" charset="0"/>
+              <a:buChar char="•"/>
+            </a:pPr>
+            <a:r>
+              <a:rPr lang="en-IN" sz="1400" dirty="0"/>
+              <a:t>Persistence Adapter</a:t>
+            </a:r>
+          </a:p>
+          <a:p>
+            <a:pPr>
+              <a:buFont typeface="Arial" panose="020B0604020202020204" pitchFamily="34" charset="0"/>
+              <a:buChar char="•"/>
+            </a:pPr>
+            <a:r>
+              <a:rPr lang="en-IN" sz="1400" dirty="0"/>
+              <a:t>Database</a:t>
+            </a:r>
+          </a:p>
+          <a:p>
+            <a:pPr marL="0" indent="0">
+              <a:buNone/>
+            </a:pPr>
+            <a:r>
+              <a:rPr lang="en-IN" sz="1400" dirty="0"/>
+              <a:t>        </a:t>
+            </a:r>
+            <a:r>
+              <a:rPr lang="en-IN" sz="1400" b="1" i="1" u="sng" dirty="0"/>
+              <a:t>2 .In Infrastructure:</a:t>
+            </a:r>
+          </a:p>
+          <a:p>
+            <a:pPr>
+              <a:buFont typeface="Arial" panose="020B0604020202020204" pitchFamily="34" charset="0"/>
+              <a:buChar char="•"/>
+            </a:pPr>
+            <a:r>
+              <a:rPr lang="en-IN" sz="1400" dirty="0"/>
+              <a:t>Backend API container</a:t>
+            </a:r>
+          </a:p>
+          <a:p>
+            <a:r>
+              <a:rPr lang="en-IN" sz="1400" dirty="0"/>
+              <a:t>The current architecture risks performance degradation or request failures under high concurrent load if backend components cannot scale quickly enough.</a:t>
+            </a:r>
+          </a:p>
+        </p:txBody>
+      </p:sp>
+    </p:spTree>
+    <p:extLst>
+      <p:ext uri="{BB962C8B-B14F-4D97-AF65-F5344CB8AC3E}">
+        <p14:creationId xmlns:p14="http://schemas.microsoft.com/office/powerpoint/2010/main" val="4207599846"/>
+      </p:ext>
+    </p:extLst>
+  </p:cSld>
+  <p:clrMapOvr>
+    <a:masterClrMapping/>
+  </p:clrMapOvr>
+</p:sld>
+</file>
+
+<file path=ppt/slides/slide17.xml><?xml version="1.0" encoding="utf-8"?>
+<p:sld xmlns:a="http://schemas.openxmlformats.org/drawingml/2006/main" xmlns:r="http://schemas.openxmlformats.org/officeDocument/2006/relationships" xmlns:p="http://schemas.openxmlformats.org/presentationml/2006/main">
+  <p:cSld>
+    <p:spTree>
+      <p:nvGrpSpPr>
+        <p:cNvPr id="1" name="">
+          <a:extLst>
+            <a:ext uri="{FF2B5EF4-FFF2-40B4-BE49-F238E27FC236}">
+              <a16:creationId xmlns:a16="http://schemas.microsoft.com/office/drawing/2014/main" id="{34589FD4-F64C-5040-48BE-90CE4AED2200}"/>
+            </a:ext>
+          </a:extLst>
+        </p:cNvPr>
+        <p:cNvGrpSpPr/>
+        <p:nvPr/>
+      </p:nvGrpSpPr>
+      <p:grpSpPr>
+        <a:xfrm>
+          <a:off x="0" y="0"/>
+          <a:ext cx="0" cy="0"/>
+          <a:chOff x="0" y="0"/>
+          <a:chExt cx="0" cy="0"/>
+        </a:xfrm>
+      </p:grpSpPr>
+      <p:sp>
+        <p:nvSpPr>
+          <p:cNvPr id="2" name="Title 1">
+            <a:extLst>
+              <a:ext uri="{FF2B5EF4-FFF2-40B4-BE49-F238E27FC236}">
+                <a16:creationId xmlns:a16="http://schemas.microsoft.com/office/drawing/2014/main" id="{9B3E253C-2669-E61B-5E0B-3E768F7A81C7}"/>
+              </a:ext>
+            </a:extLst>
+          </p:cNvPr>
+          <p:cNvSpPr>
+            <a:spLocks noGrp="1"/>
+          </p:cNvSpPr>
+          <p:nvPr>
+            <p:ph type="title"/>
+          </p:nvPr>
+        </p:nvSpPr>
+        <p:spPr/>
+        <p:txBody>
+          <a:bodyPr/>
+          <a:lstStyle/>
+          <a:p>
+            <a:r>
+              <a:rPr lang="en-US" dirty="0"/>
+              <a:t>SCALABILITY PROBLEM - SOLUTION</a:t>
+            </a:r>
+          </a:p>
+        </p:txBody>
+      </p:sp>
+      <p:sp>
+        <p:nvSpPr>
+          <p:cNvPr id="3" name="Content Placeholder 2">
+            <a:extLst>
+              <a:ext uri="{FF2B5EF4-FFF2-40B4-BE49-F238E27FC236}">
+                <a16:creationId xmlns:a16="http://schemas.microsoft.com/office/drawing/2014/main" id="{54DA6D41-842D-DABC-4394-97E36FBBDAC3}"/>
+              </a:ext>
+            </a:extLst>
+          </p:cNvPr>
+          <p:cNvSpPr>
+            <a:spLocks noGrp="1"/>
+          </p:cNvSpPr>
+          <p:nvPr>
+            <p:ph idx="1"/>
+          </p:nvPr>
+        </p:nvSpPr>
+        <p:spPr>
+          <a:xfrm>
+            <a:off x="838200" y="1576301"/>
+            <a:ext cx="6711778" cy="4916574"/>
+          </a:xfrm>
+        </p:spPr>
+        <p:txBody>
+          <a:bodyPr>
+            <a:noAutofit/>
+          </a:bodyPr>
+          <a:lstStyle/>
+          <a:p>
+            <a:r>
+              <a:rPr lang="en-IN" sz="1400" dirty="0"/>
+              <a:t>The solution leverages </a:t>
+            </a:r>
+            <a:r>
+              <a:rPr lang="en-IN" sz="1400" b="1" dirty="0"/>
+              <a:t>horizontal scalability</a:t>
+            </a:r>
+            <a:r>
+              <a:rPr lang="en-IN" sz="1400" dirty="0"/>
+              <a:t> of the Backend API container.</a:t>
+            </a:r>
+            <a:br>
+              <a:rPr lang="en-IN" sz="1400" dirty="0"/>
+            </a:br>
+            <a:r>
+              <a:rPr lang="en-IN" sz="1400" dirty="0"/>
+              <a:t>The Registration Management component is designed to be stateless, allowing multiple instances to be deployed behind a load balancer.</a:t>
+            </a:r>
+          </a:p>
+          <a:p>
+            <a:r>
+              <a:rPr lang="en-IN" sz="1400" dirty="0"/>
+              <a:t>Database access is optimized through connection pooling and efficient transaction handling, while predictable peak periods are handled by </a:t>
+            </a:r>
+            <a:r>
+              <a:rPr lang="en-IN" sz="1400" b="1" dirty="0"/>
+              <a:t>pre-scaling</a:t>
+            </a:r>
+            <a:r>
+              <a:rPr lang="en-IN" sz="1400" dirty="0"/>
+              <a:t> backend instances ahead of time.</a:t>
+            </a:r>
+          </a:p>
+          <a:p>
+            <a:pPr marL="0" indent="0">
+              <a:buNone/>
+            </a:pPr>
+            <a:endParaRPr lang="en-IN" sz="1400" dirty="0"/>
+          </a:p>
+          <a:p>
+            <a:pPr marL="0" indent="0">
+              <a:buNone/>
+            </a:pPr>
+            <a:r>
+              <a:rPr lang="en-IN" sz="1400" dirty="0"/>
+              <a:t>Design backend components (especially </a:t>
+            </a:r>
+            <a:r>
+              <a:rPr lang="en-IN" sz="1400" b="1" dirty="0"/>
+              <a:t>Registration Management</a:t>
+            </a:r>
+            <a:r>
+              <a:rPr lang="en-IN" sz="1400" dirty="0"/>
+              <a:t>) to be </a:t>
+            </a:r>
+            <a:r>
+              <a:rPr lang="en-IN" sz="1400" b="1" dirty="0"/>
+              <a:t>stateless</a:t>
+            </a:r>
+            <a:r>
+              <a:rPr lang="en-IN" sz="1400" dirty="0"/>
+              <a:t>.</a:t>
+            </a:r>
+          </a:p>
+          <a:p>
+            <a:pPr>
+              <a:buFont typeface="Arial" panose="020B0604020202020204" pitchFamily="34" charset="0"/>
+              <a:buChar char="•"/>
+            </a:pPr>
+            <a:r>
+              <a:rPr lang="en-IN" sz="1400" dirty="0"/>
+              <a:t>Deploy the </a:t>
+            </a:r>
+            <a:r>
+              <a:rPr lang="en-IN" sz="1400" b="1" dirty="0"/>
+              <a:t>Backend API</a:t>
+            </a:r>
+            <a:r>
+              <a:rPr lang="en-IN" sz="1400" dirty="0"/>
+              <a:t> as multiple instances behind a load balancer.</a:t>
+            </a:r>
+          </a:p>
+          <a:p>
+            <a:pPr>
+              <a:buFont typeface="Arial" panose="020B0604020202020204" pitchFamily="34" charset="0"/>
+              <a:buChar char="•"/>
+            </a:pPr>
+            <a:r>
+              <a:rPr lang="en-IN" sz="1400" dirty="0"/>
+              <a:t>Use:</a:t>
+            </a:r>
+          </a:p>
+          <a:p>
+            <a:pPr marL="742950" lvl="1" indent="-285750">
+              <a:buFont typeface="Arial" panose="020B0604020202020204" pitchFamily="34" charset="0"/>
+              <a:buChar char="•"/>
+            </a:pPr>
+            <a:r>
+              <a:rPr lang="en-IN" sz="1400" dirty="0"/>
+              <a:t>horizontal scaling</a:t>
+            </a:r>
+          </a:p>
+          <a:p>
+            <a:pPr marL="742950" lvl="1" indent="-285750">
+              <a:buFont typeface="Arial" panose="020B0604020202020204" pitchFamily="34" charset="0"/>
+              <a:buChar char="•"/>
+            </a:pPr>
+            <a:r>
+              <a:rPr lang="en-IN" sz="1400" dirty="0"/>
+              <a:t>connection pooling</a:t>
+            </a:r>
+          </a:p>
+          <a:p>
+            <a:pPr marL="742950" lvl="1" indent="-285750">
+              <a:buFont typeface="Arial" panose="020B0604020202020204" pitchFamily="34" charset="0"/>
+              <a:buChar char="•"/>
+            </a:pPr>
+            <a:r>
+              <a:rPr lang="en-IN" sz="1400" dirty="0"/>
+              <a:t>pre-scaling during known peak periods</a:t>
+            </a:r>
+          </a:p>
+          <a:p>
+            <a:r>
+              <a:rPr lang="en-IN" sz="1400" b="1" dirty="0"/>
+              <a:t>Result</a:t>
+            </a:r>
+          </a:p>
+          <a:p>
+            <a:pPr>
+              <a:buFont typeface="Arial" panose="020B0604020202020204" pitchFamily="34" charset="0"/>
+              <a:buChar char="•"/>
+            </a:pPr>
+            <a:r>
+              <a:rPr lang="en-IN" sz="1400" dirty="0"/>
+              <a:t>The system can handle </a:t>
+            </a:r>
+            <a:r>
+              <a:rPr lang="en-IN" sz="1400" b="1" dirty="0"/>
+              <a:t>large bursts of concurrent requests</a:t>
+            </a:r>
+            <a:r>
+              <a:rPr lang="en-IN" sz="1400" dirty="0"/>
+              <a:t>.</a:t>
+            </a:r>
+          </a:p>
+          <a:p>
+            <a:pPr>
+              <a:buFont typeface="Arial" panose="020B0604020202020204" pitchFamily="34" charset="0"/>
+              <a:buChar char="•"/>
+            </a:pPr>
+            <a:r>
+              <a:rPr lang="en-IN" sz="1400" dirty="0"/>
+              <a:t>Performance remains stable during peak usage.</a:t>
+            </a:r>
+          </a:p>
+          <a:p>
+            <a:pPr>
+              <a:buFont typeface="Arial" panose="020B0604020202020204" pitchFamily="34" charset="0"/>
+              <a:buChar char="•"/>
+            </a:pPr>
+            <a:r>
+              <a:rPr lang="en-IN" sz="1400" dirty="0"/>
+              <a:t>Scalability requirements are met without architectural complexity.</a:t>
+            </a:r>
+          </a:p>
+          <a:p>
+            <a:endParaRPr lang="en-IN" sz="1400" dirty="0"/>
+          </a:p>
+        </p:txBody>
+      </p:sp>
+    </p:spTree>
+    <p:extLst>
+      <p:ext uri="{BB962C8B-B14F-4D97-AF65-F5344CB8AC3E}">
+        <p14:creationId xmlns:p14="http://schemas.microsoft.com/office/powerpoint/2010/main" val="3582287329"/>
+      </p:ext>
+    </p:extLst>
+  </p:cSld>
+  <p:clrMapOvr>
+    <a:masterClrMapping/>
+  </p:clrMapOvr>
+</p:sld>
+</file>
+
 <file path=ppt/slides/slide2.xml><?xml version="1.0" encoding="utf-8"?>
 <p:sld xmlns:a="http://schemas.openxmlformats.org/drawingml/2006/main" xmlns:r="http://schemas.openxmlformats.org/officeDocument/2006/relationships" xmlns:p="http://schemas.openxmlformats.org/presentationml/2006/main">
   <p:cSld>
@@ -4922,93 +6041,93 @@
           <a:custGeom>
             <a:avLst/>
             <a:gdLst>
-              <a:gd name="csX0" fmla="*/ 0 w 4243589"/>
-              <a:gd name="csY0" fmla="*/ 0 h 18288"/>
-              <a:gd name="csX1" fmla="*/ 478919 w 4243589"/>
-              <a:gd name="csY1" fmla="*/ 0 h 18288"/>
-              <a:gd name="csX2" fmla="*/ 957839 w 4243589"/>
-              <a:gd name="csY2" fmla="*/ 0 h 18288"/>
-              <a:gd name="csX3" fmla="*/ 1521630 w 4243589"/>
-              <a:gd name="csY3" fmla="*/ 0 h 18288"/>
-              <a:gd name="csX4" fmla="*/ 2212729 w 4243589"/>
-              <a:gd name="csY4" fmla="*/ 0 h 18288"/>
-              <a:gd name="csX5" fmla="*/ 2734084 w 4243589"/>
-              <a:gd name="csY5" fmla="*/ 0 h 18288"/>
-              <a:gd name="csX6" fmla="*/ 3255439 w 4243589"/>
-              <a:gd name="csY6" fmla="*/ 0 h 18288"/>
-              <a:gd name="csX7" fmla="*/ 4243589 w 4243589"/>
-              <a:gd name="csY7" fmla="*/ 0 h 18288"/>
-              <a:gd name="csX8" fmla="*/ 4243589 w 4243589"/>
-              <a:gd name="csY8" fmla="*/ 18288 h 18288"/>
-              <a:gd name="csX9" fmla="*/ 3594926 w 4243589"/>
-              <a:gd name="csY9" fmla="*/ 18288 h 18288"/>
-              <a:gd name="csX10" fmla="*/ 3073571 w 4243589"/>
-              <a:gd name="csY10" fmla="*/ 18288 h 18288"/>
-              <a:gd name="csX11" fmla="*/ 2552216 w 4243589"/>
-              <a:gd name="csY11" fmla="*/ 18288 h 18288"/>
-              <a:gd name="csX12" fmla="*/ 1903553 w 4243589"/>
-              <a:gd name="csY12" fmla="*/ 18288 h 18288"/>
-              <a:gd name="csX13" fmla="*/ 1212454 w 4243589"/>
-              <a:gd name="csY13" fmla="*/ 18288 h 18288"/>
-              <a:gd name="csX14" fmla="*/ 733535 w 4243589"/>
-              <a:gd name="csY14" fmla="*/ 18288 h 18288"/>
-              <a:gd name="csX15" fmla="*/ 0 w 4243589"/>
-              <a:gd name="csY15" fmla="*/ 18288 h 18288"/>
-              <a:gd name="csX16" fmla="*/ 0 w 4243589"/>
-              <a:gd name="csY16" fmla="*/ 0 h 18288"/>
+              <a:gd name="connsiteX0" fmla="*/ 0 w 4243589"/>
+              <a:gd name="connsiteY0" fmla="*/ 0 h 18288"/>
+              <a:gd name="connsiteX1" fmla="*/ 478919 w 4243589"/>
+              <a:gd name="connsiteY1" fmla="*/ 0 h 18288"/>
+              <a:gd name="connsiteX2" fmla="*/ 957839 w 4243589"/>
+              <a:gd name="connsiteY2" fmla="*/ 0 h 18288"/>
+              <a:gd name="connsiteX3" fmla="*/ 1521630 w 4243589"/>
+              <a:gd name="connsiteY3" fmla="*/ 0 h 18288"/>
+              <a:gd name="connsiteX4" fmla="*/ 2212729 w 4243589"/>
+              <a:gd name="connsiteY4" fmla="*/ 0 h 18288"/>
+              <a:gd name="connsiteX5" fmla="*/ 2734084 w 4243589"/>
+              <a:gd name="connsiteY5" fmla="*/ 0 h 18288"/>
+              <a:gd name="connsiteX6" fmla="*/ 3255439 w 4243589"/>
+              <a:gd name="connsiteY6" fmla="*/ 0 h 18288"/>
+              <a:gd name="connsiteX7" fmla="*/ 4243589 w 4243589"/>
+              <a:gd name="connsiteY7" fmla="*/ 0 h 18288"/>
+              <a:gd name="connsiteX8" fmla="*/ 4243589 w 4243589"/>
+              <a:gd name="connsiteY8" fmla="*/ 18288 h 18288"/>
+              <a:gd name="connsiteX9" fmla="*/ 3594926 w 4243589"/>
+              <a:gd name="connsiteY9" fmla="*/ 18288 h 18288"/>
+              <a:gd name="connsiteX10" fmla="*/ 3073571 w 4243589"/>
+              <a:gd name="connsiteY10" fmla="*/ 18288 h 18288"/>
+              <a:gd name="connsiteX11" fmla="*/ 2552216 w 4243589"/>
+              <a:gd name="connsiteY11" fmla="*/ 18288 h 18288"/>
+              <a:gd name="connsiteX12" fmla="*/ 1903553 w 4243589"/>
+              <a:gd name="connsiteY12" fmla="*/ 18288 h 18288"/>
+              <a:gd name="connsiteX13" fmla="*/ 1212454 w 4243589"/>
+              <a:gd name="connsiteY13" fmla="*/ 18288 h 18288"/>
+              <a:gd name="connsiteX14" fmla="*/ 733535 w 4243589"/>
+              <a:gd name="connsiteY14" fmla="*/ 18288 h 18288"/>
+              <a:gd name="connsiteX15" fmla="*/ 0 w 4243589"/>
+              <a:gd name="connsiteY15" fmla="*/ 18288 h 18288"/>
+              <a:gd name="connsiteX16" fmla="*/ 0 w 4243589"/>
+              <a:gd name="connsiteY16" fmla="*/ 0 h 18288"/>
             </a:gdLst>
             <a:ahLst/>
             <a:cxnLst>
               <a:cxn ang="0">
-                <a:pos x="csX0" y="csY0"/>
+                <a:pos x="connsiteX0" y="connsiteY0"/>
               </a:cxn>
               <a:cxn ang="0">
-                <a:pos x="csX1" y="csY1"/>
+                <a:pos x="connsiteX1" y="connsiteY1"/>
               </a:cxn>
               <a:cxn ang="0">
-                <a:pos x="csX2" y="csY2"/>
+                <a:pos x="connsiteX2" y="connsiteY2"/>
               </a:cxn>
               <a:cxn ang="0">
-                <a:pos x="csX3" y="csY3"/>
+                <a:pos x="connsiteX3" y="connsiteY3"/>
               </a:cxn>
               <a:cxn ang="0">
-                <a:pos x="csX4" y="csY4"/>
+                <a:pos x="connsiteX4" y="connsiteY4"/>
               </a:cxn>
               <a:cxn ang="0">
-                <a:pos x="csX5" y="csY5"/>
+                <a:pos x="connsiteX5" y="connsiteY5"/>
               </a:cxn>
               <a:cxn ang="0">
-                <a:pos x="csX6" y="csY6"/>
+                <a:pos x="connsiteX6" y="connsiteY6"/>
               </a:cxn>
               <a:cxn ang="0">
-                <a:pos x="csX7" y="csY7"/>
+                <a:pos x="connsiteX7" y="connsiteY7"/>
               </a:cxn>
               <a:cxn ang="0">
-                <a:pos x="csX8" y="csY8"/>
+                <a:pos x="connsiteX8" y="connsiteY8"/>
               </a:cxn>
               <a:cxn ang="0">
-                <a:pos x="csX9" y="csY9"/>
+                <a:pos x="connsiteX9" y="connsiteY9"/>
               </a:cxn>
               <a:cxn ang="0">
-                <a:pos x="csX10" y="csY10"/>
+                <a:pos x="connsiteX10" y="connsiteY10"/>
               </a:cxn>
               <a:cxn ang="0">
-                <a:pos x="csX11" y="csY11"/>
+                <a:pos x="connsiteX11" y="connsiteY11"/>
               </a:cxn>
               <a:cxn ang="0">
-                <a:pos x="csX12" y="csY12"/>
+                <a:pos x="connsiteX12" y="connsiteY12"/>
               </a:cxn>
               <a:cxn ang="0">
-                <a:pos x="csX13" y="csY13"/>
+                <a:pos x="connsiteX13" y="connsiteY13"/>
               </a:cxn>
               <a:cxn ang="0">
-                <a:pos x="csX14" y="csY14"/>
+                <a:pos x="connsiteX14" y="connsiteY14"/>
               </a:cxn>
               <a:cxn ang="0">
-                <a:pos x="csX15" y="csY15"/>
+                <a:pos x="connsiteX15" y="connsiteY15"/>
               </a:cxn>
               <a:cxn ang="0">
-                <a:pos x="csX16" y="csY16"/>
+                <a:pos x="connsiteX16" y="connsiteY16"/>
               </a:cxn>
             </a:cxnLst>
             <a:rect l="l" t="t" r="r" b="b"/>
@@ -5572,68 +6691,68 @@
           <a:custGeom>
             <a:avLst/>
             <a:gdLst>
-              <a:gd name="csX0" fmla="*/ 0 w 3255095"/>
-              <a:gd name="csY0" fmla="*/ 0 h 18288"/>
-              <a:gd name="csX1" fmla="*/ 618468 w 3255095"/>
-              <a:gd name="csY1" fmla="*/ 0 h 18288"/>
-              <a:gd name="csX2" fmla="*/ 1269487 w 3255095"/>
-              <a:gd name="csY2" fmla="*/ 0 h 18288"/>
-              <a:gd name="csX3" fmla="*/ 1953057 w 3255095"/>
-              <a:gd name="csY3" fmla="*/ 0 h 18288"/>
-              <a:gd name="csX4" fmla="*/ 2636627 w 3255095"/>
-              <a:gd name="csY4" fmla="*/ 0 h 18288"/>
-              <a:gd name="csX5" fmla="*/ 3255095 w 3255095"/>
-              <a:gd name="csY5" fmla="*/ 0 h 18288"/>
-              <a:gd name="csX6" fmla="*/ 3255095 w 3255095"/>
-              <a:gd name="csY6" fmla="*/ 18288 h 18288"/>
-              <a:gd name="csX7" fmla="*/ 2538974 w 3255095"/>
-              <a:gd name="csY7" fmla="*/ 18288 h 18288"/>
-              <a:gd name="csX8" fmla="*/ 1822853 w 3255095"/>
-              <a:gd name="csY8" fmla="*/ 18288 h 18288"/>
-              <a:gd name="csX9" fmla="*/ 1171834 w 3255095"/>
-              <a:gd name="csY9" fmla="*/ 18288 h 18288"/>
-              <a:gd name="csX10" fmla="*/ 0 w 3255095"/>
-              <a:gd name="csY10" fmla="*/ 18288 h 18288"/>
-              <a:gd name="csX11" fmla="*/ 0 w 3255095"/>
-              <a:gd name="csY11" fmla="*/ 0 h 18288"/>
+              <a:gd name="connsiteX0" fmla="*/ 0 w 3255095"/>
+              <a:gd name="connsiteY0" fmla="*/ 0 h 18288"/>
+              <a:gd name="connsiteX1" fmla="*/ 618468 w 3255095"/>
+              <a:gd name="connsiteY1" fmla="*/ 0 h 18288"/>
+              <a:gd name="connsiteX2" fmla="*/ 1269487 w 3255095"/>
+              <a:gd name="connsiteY2" fmla="*/ 0 h 18288"/>
+              <a:gd name="connsiteX3" fmla="*/ 1953057 w 3255095"/>
+              <a:gd name="connsiteY3" fmla="*/ 0 h 18288"/>
+              <a:gd name="connsiteX4" fmla="*/ 2636627 w 3255095"/>
+              <a:gd name="connsiteY4" fmla="*/ 0 h 18288"/>
+              <a:gd name="connsiteX5" fmla="*/ 3255095 w 3255095"/>
+              <a:gd name="connsiteY5" fmla="*/ 0 h 18288"/>
+              <a:gd name="connsiteX6" fmla="*/ 3255095 w 3255095"/>
+              <a:gd name="connsiteY6" fmla="*/ 18288 h 18288"/>
+              <a:gd name="connsiteX7" fmla="*/ 2538974 w 3255095"/>
+              <a:gd name="connsiteY7" fmla="*/ 18288 h 18288"/>
+              <a:gd name="connsiteX8" fmla="*/ 1822853 w 3255095"/>
+              <a:gd name="connsiteY8" fmla="*/ 18288 h 18288"/>
+              <a:gd name="connsiteX9" fmla="*/ 1171834 w 3255095"/>
+              <a:gd name="connsiteY9" fmla="*/ 18288 h 18288"/>
+              <a:gd name="connsiteX10" fmla="*/ 0 w 3255095"/>
+              <a:gd name="connsiteY10" fmla="*/ 18288 h 18288"/>
+              <a:gd name="connsiteX11" fmla="*/ 0 w 3255095"/>
+              <a:gd name="connsiteY11" fmla="*/ 0 h 18288"/>
             </a:gdLst>
             <a:ahLst/>
             <a:cxnLst>
               <a:cxn ang="0">
-                <a:pos x="csX0" y="csY0"/>
+                <a:pos x="connsiteX0" y="connsiteY0"/>
               </a:cxn>
               <a:cxn ang="0">
-                <a:pos x="csX1" y="csY1"/>
+                <a:pos x="connsiteX1" y="connsiteY1"/>
               </a:cxn>
               <a:cxn ang="0">
-                <a:pos x="csX2" y="csY2"/>
+                <a:pos x="connsiteX2" y="connsiteY2"/>
               </a:cxn>
               <a:cxn ang="0">
-                <a:pos x="csX3" y="csY3"/>
+                <a:pos x="connsiteX3" y="connsiteY3"/>
               </a:cxn>
               <a:cxn ang="0">
-                <a:pos x="csX4" y="csY4"/>
+                <a:pos x="connsiteX4" y="connsiteY4"/>
               </a:cxn>
               <a:cxn ang="0">
-                <a:pos x="csX5" y="csY5"/>
+                <a:pos x="connsiteX5" y="connsiteY5"/>
               </a:cxn>
               <a:cxn ang="0">
-                <a:pos x="csX6" y="csY6"/>
+                <a:pos x="connsiteX6" y="connsiteY6"/>
               </a:cxn>
               <a:cxn ang="0">
-                <a:pos x="csX7" y="csY7"/>
+                <a:pos x="connsiteX7" y="connsiteY7"/>
               </a:cxn>
               <a:cxn ang="0">
-                <a:pos x="csX8" y="csY8"/>
+                <a:pos x="connsiteX8" y="connsiteY8"/>
               </a:cxn>
               <a:cxn ang="0">
-                <a:pos x="csX9" y="csY9"/>
+                <a:pos x="connsiteX9" y="connsiteY9"/>
               </a:cxn>
               <a:cxn ang="0">
-                <a:pos x="csX10" y="csY10"/>
+                <a:pos x="connsiteX10" y="connsiteY10"/>
               </a:cxn>
               <a:cxn ang="0">
-                <a:pos x="csX11" y="csY11"/>
+                <a:pos x="connsiteX11" y="connsiteY11"/>
               </a:cxn>
             </a:cxnLst>
             <a:rect l="l" t="t" r="r" b="b"/>
@@ -6065,68 +7184,68 @@
           <a:custGeom>
             <a:avLst/>
             <a:gdLst>
-              <a:gd name="csX0" fmla="*/ 0 w 3255095"/>
-              <a:gd name="csY0" fmla="*/ 0 h 18288"/>
-              <a:gd name="csX1" fmla="*/ 618468 w 3255095"/>
-              <a:gd name="csY1" fmla="*/ 0 h 18288"/>
-              <a:gd name="csX2" fmla="*/ 1269487 w 3255095"/>
-              <a:gd name="csY2" fmla="*/ 0 h 18288"/>
-              <a:gd name="csX3" fmla="*/ 1953057 w 3255095"/>
-              <a:gd name="csY3" fmla="*/ 0 h 18288"/>
-              <a:gd name="csX4" fmla="*/ 2636627 w 3255095"/>
-              <a:gd name="csY4" fmla="*/ 0 h 18288"/>
-              <a:gd name="csX5" fmla="*/ 3255095 w 3255095"/>
-              <a:gd name="csY5" fmla="*/ 0 h 18288"/>
-              <a:gd name="csX6" fmla="*/ 3255095 w 3255095"/>
-              <a:gd name="csY6" fmla="*/ 18288 h 18288"/>
-              <a:gd name="csX7" fmla="*/ 2538974 w 3255095"/>
-              <a:gd name="csY7" fmla="*/ 18288 h 18288"/>
-              <a:gd name="csX8" fmla="*/ 1822853 w 3255095"/>
-              <a:gd name="csY8" fmla="*/ 18288 h 18288"/>
-              <a:gd name="csX9" fmla="*/ 1171834 w 3255095"/>
-              <a:gd name="csY9" fmla="*/ 18288 h 18288"/>
-              <a:gd name="csX10" fmla="*/ 0 w 3255095"/>
-              <a:gd name="csY10" fmla="*/ 18288 h 18288"/>
-              <a:gd name="csX11" fmla="*/ 0 w 3255095"/>
-              <a:gd name="csY11" fmla="*/ 0 h 18288"/>
+              <a:gd name="connsiteX0" fmla="*/ 0 w 3255095"/>
+              <a:gd name="connsiteY0" fmla="*/ 0 h 18288"/>
+              <a:gd name="connsiteX1" fmla="*/ 618468 w 3255095"/>
+              <a:gd name="connsiteY1" fmla="*/ 0 h 18288"/>
+              <a:gd name="connsiteX2" fmla="*/ 1269487 w 3255095"/>
+              <a:gd name="connsiteY2" fmla="*/ 0 h 18288"/>
+              <a:gd name="connsiteX3" fmla="*/ 1953057 w 3255095"/>
+              <a:gd name="connsiteY3" fmla="*/ 0 h 18288"/>
+              <a:gd name="connsiteX4" fmla="*/ 2636627 w 3255095"/>
+              <a:gd name="connsiteY4" fmla="*/ 0 h 18288"/>
+              <a:gd name="connsiteX5" fmla="*/ 3255095 w 3255095"/>
+              <a:gd name="connsiteY5" fmla="*/ 0 h 18288"/>
+              <a:gd name="connsiteX6" fmla="*/ 3255095 w 3255095"/>
+              <a:gd name="connsiteY6" fmla="*/ 18288 h 18288"/>
+              <a:gd name="connsiteX7" fmla="*/ 2538974 w 3255095"/>
+              <a:gd name="connsiteY7" fmla="*/ 18288 h 18288"/>
+              <a:gd name="connsiteX8" fmla="*/ 1822853 w 3255095"/>
+              <a:gd name="connsiteY8" fmla="*/ 18288 h 18288"/>
+              <a:gd name="connsiteX9" fmla="*/ 1171834 w 3255095"/>
+              <a:gd name="connsiteY9" fmla="*/ 18288 h 18288"/>
+              <a:gd name="connsiteX10" fmla="*/ 0 w 3255095"/>
+              <a:gd name="connsiteY10" fmla="*/ 18288 h 18288"/>
+              <a:gd name="connsiteX11" fmla="*/ 0 w 3255095"/>
+              <a:gd name="connsiteY11" fmla="*/ 0 h 18288"/>
             </a:gdLst>
             <a:ahLst/>
             <a:cxnLst>
               <a:cxn ang="0">
-                <a:pos x="csX0" y="csY0"/>
+                <a:pos x="connsiteX0" y="connsiteY0"/>
               </a:cxn>
               <a:cxn ang="0">
-                <a:pos x="csX1" y="csY1"/>
+                <a:pos x="connsiteX1" y="connsiteY1"/>
               </a:cxn>
               <a:cxn ang="0">
-                <a:pos x="csX2" y="csY2"/>
+                <a:pos x="connsiteX2" y="connsiteY2"/>
               </a:cxn>
               <a:cxn ang="0">
-                <a:pos x="csX3" y="csY3"/>
+                <a:pos x="connsiteX3" y="connsiteY3"/>
               </a:cxn>
               <a:cxn ang="0">
-                <a:pos x="csX4" y="csY4"/>
+                <a:pos x="connsiteX4" y="connsiteY4"/>
               </a:cxn>
               <a:cxn ang="0">
-                <a:pos x="csX5" y="csY5"/>
+                <a:pos x="connsiteX5" y="connsiteY5"/>
               </a:cxn>
               <a:cxn ang="0">
-                <a:pos x="csX6" y="csY6"/>
+                <a:pos x="connsiteX6" y="connsiteY6"/>
               </a:cxn>
               <a:cxn ang="0">
-                <a:pos x="csX7" y="csY7"/>
+                <a:pos x="connsiteX7" y="connsiteY7"/>
               </a:cxn>
               <a:cxn ang="0">
-                <a:pos x="csX8" y="csY8"/>
+                <a:pos x="connsiteX8" y="connsiteY8"/>
               </a:cxn>
               <a:cxn ang="0">
-                <a:pos x="csX9" y="csY9"/>
+                <a:pos x="connsiteX9" y="connsiteY9"/>
               </a:cxn>
               <a:cxn ang="0">
-                <a:pos x="csX10" y="csY10"/>
+                <a:pos x="connsiteX10" y="connsiteY10"/>
               </a:cxn>
               <a:cxn ang="0">
-                <a:pos x="csX11" y="csY11"/>
+                <a:pos x="connsiteX11" y="connsiteY11"/>
               </a:cxn>
             </a:cxnLst>
             <a:rect l="l" t="t" r="r" b="b"/>
@@ -6559,68 +7678,68 @@
           <a:custGeom>
             <a:avLst/>
             <a:gdLst>
-              <a:gd name="csX0" fmla="*/ 0 w 3255095"/>
-              <a:gd name="csY0" fmla="*/ 0 h 18288"/>
-              <a:gd name="csX1" fmla="*/ 618468 w 3255095"/>
-              <a:gd name="csY1" fmla="*/ 0 h 18288"/>
-              <a:gd name="csX2" fmla="*/ 1269487 w 3255095"/>
-              <a:gd name="csY2" fmla="*/ 0 h 18288"/>
-              <a:gd name="csX3" fmla="*/ 1953057 w 3255095"/>
-              <a:gd name="csY3" fmla="*/ 0 h 18288"/>
-              <a:gd name="csX4" fmla="*/ 2636627 w 3255095"/>
-              <a:gd name="csY4" fmla="*/ 0 h 18288"/>
-              <a:gd name="csX5" fmla="*/ 3255095 w 3255095"/>
-              <a:gd name="csY5" fmla="*/ 0 h 18288"/>
-              <a:gd name="csX6" fmla="*/ 3255095 w 3255095"/>
-              <a:gd name="csY6" fmla="*/ 18288 h 18288"/>
-              <a:gd name="csX7" fmla="*/ 2538974 w 3255095"/>
-              <a:gd name="csY7" fmla="*/ 18288 h 18288"/>
-              <a:gd name="csX8" fmla="*/ 1822853 w 3255095"/>
-              <a:gd name="csY8" fmla="*/ 18288 h 18288"/>
-              <a:gd name="csX9" fmla="*/ 1171834 w 3255095"/>
-              <a:gd name="csY9" fmla="*/ 18288 h 18288"/>
-              <a:gd name="csX10" fmla="*/ 0 w 3255095"/>
-              <a:gd name="csY10" fmla="*/ 18288 h 18288"/>
-              <a:gd name="csX11" fmla="*/ 0 w 3255095"/>
-              <a:gd name="csY11" fmla="*/ 0 h 18288"/>
+              <a:gd name="connsiteX0" fmla="*/ 0 w 3255095"/>
+              <a:gd name="connsiteY0" fmla="*/ 0 h 18288"/>
+              <a:gd name="connsiteX1" fmla="*/ 618468 w 3255095"/>
+              <a:gd name="connsiteY1" fmla="*/ 0 h 18288"/>
+              <a:gd name="connsiteX2" fmla="*/ 1269487 w 3255095"/>
+              <a:gd name="connsiteY2" fmla="*/ 0 h 18288"/>
+              <a:gd name="connsiteX3" fmla="*/ 1953057 w 3255095"/>
+              <a:gd name="connsiteY3" fmla="*/ 0 h 18288"/>
+              <a:gd name="connsiteX4" fmla="*/ 2636627 w 3255095"/>
+              <a:gd name="connsiteY4" fmla="*/ 0 h 18288"/>
+              <a:gd name="connsiteX5" fmla="*/ 3255095 w 3255095"/>
+              <a:gd name="connsiteY5" fmla="*/ 0 h 18288"/>
+              <a:gd name="connsiteX6" fmla="*/ 3255095 w 3255095"/>
+              <a:gd name="connsiteY6" fmla="*/ 18288 h 18288"/>
+              <a:gd name="connsiteX7" fmla="*/ 2538974 w 3255095"/>
+              <a:gd name="connsiteY7" fmla="*/ 18288 h 18288"/>
+              <a:gd name="connsiteX8" fmla="*/ 1822853 w 3255095"/>
+              <a:gd name="connsiteY8" fmla="*/ 18288 h 18288"/>
+              <a:gd name="connsiteX9" fmla="*/ 1171834 w 3255095"/>
+              <a:gd name="connsiteY9" fmla="*/ 18288 h 18288"/>
+              <a:gd name="connsiteX10" fmla="*/ 0 w 3255095"/>
+              <a:gd name="connsiteY10" fmla="*/ 18288 h 18288"/>
+              <a:gd name="connsiteX11" fmla="*/ 0 w 3255095"/>
+              <a:gd name="connsiteY11" fmla="*/ 0 h 18288"/>
             </a:gdLst>
             <a:ahLst/>
             <a:cxnLst>
               <a:cxn ang="0">
-                <a:pos x="csX0" y="csY0"/>
+                <a:pos x="connsiteX0" y="connsiteY0"/>
               </a:cxn>
               <a:cxn ang="0">
-                <a:pos x="csX1" y="csY1"/>
+                <a:pos x="connsiteX1" y="connsiteY1"/>
               </a:cxn>
               <a:cxn ang="0">
-                <a:pos x="csX2" y="csY2"/>
+                <a:pos x="connsiteX2" y="connsiteY2"/>
               </a:cxn>
               <a:cxn ang="0">
-                <a:pos x="csX3" y="csY3"/>
+                <a:pos x="connsiteX3" y="connsiteY3"/>
               </a:cxn>
               <a:cxn ang="0">
-                <a:pos x="csX4" y="csY4"/>
+                <a:pos x="connsiteX4" y="connsiteY4"/>
               </a:cxn>
               <a:cxn ang="0">
-                <a:pos x="csX5" y="csY5"/>
+                <a:pos x="connsiteX5" y="connsiteY5"/>
               </a:cxn>
               <a:cxn ang="0">
-                <a:pos x="csX6" y="csY6"/>
+                <a:pos x="connsiteX6" y="connsiteY6"/>
               </a:cxn>
               <a:cxn ang="0">
-                <a:pos x="csX7" y="csY7"/>
+                <a:pos x="connsiteX7" y="connsiteY7"/>
               </a:cxn>
               <a:cxn ang="0">
-                <a:pos x="csX8" y="csY8"/>
+                <a:pos x="connsiteX8" y="connsiteY8"/>
               </a:cxn>
               <a:cxn ang="0">
-                <a:pos x="csX9" y="csY9"/>
+                <a:pos x="connsiteX9" y="connsiteY9"/>
               </a:cxn>
               <a:cxn ang="0">
-                <a:pos x="csX10" y="csY10"/>
+                <a:pos x="connsiteX10" y="connsiteY10"/>
               </a:cxn>
               <a:cxn ang="0">
-                <a:pos x="csX11" y="csY11"/>
+                <a:pos x="connsiteX11" y="connsiteY11"/>
               </a:cxn>
             </a:cxnLst>
             <a:rect l="l" t="t" r="r" b="b"/>
@@ -7310,68 +8429,68 @@
           <a:custGeom>
             <a:avLst/>
             <a:gdLst>
-              <a:gd name="csX0" fmla="*/ 0 w 3255095"/>
-              <a:gd name="csY0" fmla="*/ 0 h 18288"/>
-              <a:gd name="csX1" fmla="*/ 618468 w 3255095"/>
-              <a:gd name="csY1" fmla="*/ 0 h 18288"/>
-              <a:gd name="csX2" fmla="*/ 1269487 w 3255095"/>
-              <a:gd name="csY2" fmla="*/ 0 h 18288"/>
-              <a:gd name="csX3" fmla="*/ 1953057 w 3255095"/>
-              <a:gd name="csY3" fmla="*/ 0 h 18288"/>
-              <a:gd name="csX4" fmla="*/ 2636627 w 3255095"/>
-              <a:gd name="csY4" fmla="*/ 0 h 18288"/>
-              <a:gd name="csX5" fmla="*/ 3255095 w 3255095"/>
-              <a:gd name="csY5" fmla="*/ 0 h 18288"/>
-              <a:gd name="csX6" fmla="*/ 3255095 w 3255095"/>
-              <a:gd name="csY6" fmla="*/ 18288 h 18288"/>
-              <a:gd name="csX7" fmla="*/ 2538974 w 3255095"/>
-              <a:gd name="csY7" fmla="*/ 18288 h 18288"/>
-              <a:gd name="csX8" fmla="*/ 1822853 w 3255095"/>
-              <a:gd name="csY8" fmla="*/ 18288 h 18288"/>
-              <a:gd name="csX9" fmla="*/ 1171834 w 3255095"/>
-              <a:gd name="csY9" fmla="*/ 18288 h 18288"/>
-              <a:gd name="csX10" fmla="*/ 0 w 3255095"/>
-              <a:gd name="csY10" fmla="*/ 18288 h 18288"/>
-              <a:gd name="csX11" fmla="*/ 0 w 3255095"/>
-              <a:gd name="csY11" fmla="*/ 0 h 18288"/>
+              <a:gd name="connsiteX0" fmla="*/ 0 w 3255095"/>
+              <a:gd name="connsiteY0" fmla="*/ 0 h 18288"/>
+              <a:gd name="connsiteX1" fmla="*/ 618468 w 3255095"/>
+              <a:gd name="connsiteY1" fmla="*/ 0 h 18288"/>
+              <a:gd name="connsiteX2" fmla="*/ 1269487 w 3255095"/>
+              <a:gd name="connsiteY2" fmla="*/ 0 h 18288"/>
+              <a:gd name="connsiteX3" fmla="*/ 1953057 w 3255095"/>
+              <a:gd name="connsiteY3" fmla="*/ 0 h 18288"/>
+              <a:gd name="connsiteX4" fmla="*/ 2636627 w 3255095"/>
+              <a:gd name="connsiteY4" fmla="*/ 0 h 18288"/>
+              <a:gd name="connsiteX5" fmla="*/ 3255095 w 3255095"/>
+              <a:gd name="connsiteY5" fmla="*/ 0 h 18288"/>
+              <a:gd name="connsiteX6" fmla="*/ 3255095 w 3255095"/>
+              <a:gd name="connsiteY6" fmla="*/ 18288 h 18288"/>
+              <a:gd name="connsiteX7" fmla="*/ 2538974 w 3255095"/>
+              <a:gd name="connsiteY7" fmla="*/ 18288 h 18288"/>
+              <a:gd name="connsiteX8" fmla="*/ 1822853 w 3255095"/>
+              <a:gd name="connsiteY8" fmla="*/ 18288 h 18288"/>
+              <a:gd name="connsiteX9" fmla="*/ 1171834 w 3255095"/>
+              <a:gd name="connsiteY9" fmla="*/ 18288 h 18288"/>
+              <a:gd name="connsiteX10" fmla="*/ 0 w 3255095"/>
+              <a:gd name="connsiteY10" fmla="*/ 18288 h 18288"/>
+              <a:gd name="connsiteX11" fmla="*/ 0 w 3255095"/>
+              <a:gd name="connsiteY11" fmla="*/ 0 h 18288"/>
             </a:gdLst>
             <a:ahLst/>
             <a:cxnLst>
               <a:cxn ang="0">
-                <a:pos x="csX0" y="csY0"/>
+                <a:pos x="connsiteX0" y="connsiteY0"/>
               </a:cxn>
               <a:cxn ang="0">
-                <a:pos x="csX1" y="csY1"/>
+                <a:pos x="connsiteX1" y="connsiteY1"/>
               </a:cxn>
               <a:cxn ang="0">
-                <a:pos x="csX2" y="csY2"/>
+                <a:pos x="connsiteX2" y="connsiteY2"/>
               </a:cxn>
               <a:cxn ang="0">
-                <a:pos x="csX3" y="csY3"/>
+                <a:pos x="connsiteX3" y="connsiteY3"/>
               </a:cxn>
               <a:cxn ang="0">
-                <a:pos x="csX4" y="csY4"/>
+                <a:pos x="connsiteX4" y="connsiteY4"/>
               </a:cxn>
               <a:cxn ang="0">
-                <a:pos x="csX5" y="csY5"/>
+                <a:pos x="connsiteX5" y="connsiteY5"/>
               </a:cxn>
               <a:cxn ang="0">
-                <a:pos x="csX6" y="csY6"/>
+                <a:pos x="connsiteX6" y="connsiteY6"/>
               </a:cxn>
               <a:cxn ang="0">
-                <a:pos x="csX7" y="csY7"/>
+                <a:pos x="connsiteX7" y="connsiteY7"/>
               </a:cxn>
               <a:cxn ang="0">
-                <a:pos x="csX8" y="csY8"/>
+                <a:pos x="connsiteX8" y="connsiteY8"/>
               </a:cxn>
               <a:cxn ang="0">
-                <a:pos x="csX9" y="csY9"/>
+                <a:pos x="connsiteX9" y="connsiteY9"/>
               </a:cxn>
               <a:cxn ang="0">
-                <a:pos x="csX10" y="csY10"/>
+                <a:pos x="connsiteX10" y="connsiteY10"/>
               </a:cxn>
               <a:cxn ang="0">
-                <a:pos x="csX11" y="csY11"/>
+                <a:pos x="connsiteX11" y="connsiteY11"/>
               </a:cxn>
             </a:cxnLst>
             <a:rect l="l" t="t" r="r" b="b"/>

</xml_diff>

<commit_message>
Add slides for security scenario
</commit_message>
<xml_diff>
--- a/M2/Presentation_Qualities.pptx
+++ b/M2/Presentation_Qualities.pptx
@@ -5,7 +5,7 @@
     <p:sldMasterId id="2147483648" r:id="rId1"/>
   </p:sldMasterIdLst>
   <p:notesMasterIdLst>
-    <p:notesMasterId r:id="rId20"/>
+    <p:notesMasterId r:id="rId21"/>
   </p:notesMasterIdLst>
   <p:sldIdLst>
     <p:sldId id="256" r:id="rId2"/>
@@ -26,6 +26,7 @@
     <p:sldId id="272" r:id="rId17"/>
     <p:sldId id="273" r:id="rId18"/>
     <p:sldId id="274" r:id="rId19"/>
+    <p:sldId id="276" r:id="rId20"/>
   </p:sldIdLst>
   <p:sldSz cx="12192000" cy="6858000"/>
   <p:notesSz cx="6858000" cy="9144000"/>
@@ -710,7 +711,7 @@
           <a:p>
             <a:fld id="{FC1B7745-5391-477F-8AE8-1136866A9302}" type="datetimeFigureOut">
               <a:rPr lang="es-ES" smtClean="0"/>
-              <a:t>4/1/26</a:t>
+              <a:t>05/01/2026</a:t>
             </a:fld>
             <a:endParaRPr lang="es-ES"/>
           </a:p>
@@ -1208,7 +1209,7 @@
           <a:p>
             <a:fld id="{6A3C2F7B-537C-4500-BF1F-DDEBE70AF5A2}" type="datetimeFigureOut">
               <a:rPr lang="es-ES" smtClean="0"/>
-              <a:t>4/1/26</a:t>
+              <a:t>05/01/2026</a:t>
             </a:fld>
             <a:endParaRPr lang="es-ES"/>
           </a:p>
@@ -1406,7 +1407,7 @@
           <a:p>
             <a:fld id="{6A3C2F7B-537C-4500-BF1F-DDEBE70AF5A2}" type="datetimeFigureOut">
               <a:rPr lang="es-ES" smtClean="0"/>
-              <a:t>4/1/26</a:t>
+              <a:t>05/01/2026</a:t>
             </a:fld>
             <a:endParaRPr lang="es-ES"/>
           </a:p>
@@ -1614,7 +1615,7 @@
           <a:p>
             <a:fld id="{6A3C2F7B-537C-4500-BF1F-DDEBE70AF5A2}" type="datetimeFigureOut">
               <a:rPr lang="es-ES" smtClean="0"/>
-              <a:t>4/1/26</a:t>
+              <a:t>05/01/2026</a:t>
             </a:fld>
             <a:endParaRPr lang="es-ES"/>
           </a:p>
@@ -1812,7 +1813,7 @@
           <a:p>
             <a:fld id="{6A3C2F7B-537C-4500-BF1F-DDEBE70AF5A2}" type="datetimeFigureOut">
               <a:rPr lang="es-ES" smtClean="0"/>
-              <a:t>4/1/26</a:t>
+              <a:t>05/01/2026</a:t>
             </a:fld>
             <a:endParaRPr lang="es-ES"/>
           </a:p>
@@ -2087,7 +2088,7 @@
           <a:p>
             <a:fld id="{6A3C2F7B-537C-4500-BF1F-DDEBE70AF5A2}" type="datetimeFigureOut">
               <a:rPr lang="es-ES" smtClean="0"/>
-              <a:t>4/1/26</a:t>
+              <a:t>05/01/2026</a:t>
             </a:fld>
             <a:endParaRPr lang="es-ES"/>
           </a:p>
@@ -2352,7 +2353,7 @@
           <a:p>
             <a:fld id="{6A3C2F7B-537C-4500-BF1F-DDEBE70AF5A2}" type="datetimeFigureOut">
               <a:rPr lang="es-ES" smtClean="0"/>
-              <a:t>4/1/26</a:t>
+              <a:t>05/01/2026</a:t>
             </a:fld>
             <a:endParaRPr lang="es-ES"/>
           </a:p>
@@ -2764,7 +2765,7 @@
           <a:p>
             <a:fld id="{6A3C2F7B-537C-4500-BF1F-DDEBE70AF5A2}" type="datetimeFigureOut">
               <a:rPr lang="es-ES" smtClean="0"/>
-              <a:t>4/1/26</a:t>
+              <a:t>05/01/2026</a:t>
             </a:fld>
             <a:endParaRPr lang="es-ES"/>
           </a:p>
@@ -2905,7 +2906,7 @@
           <a:p>
             <a:fld id="{6A3C2F7B-537C-4500-BF1F-DDEBE70AF5A2}" type="datetimeFigureOut">
               <a:rPr lang="es-ES" smtClean="0"/>
-              <a:t>4/1/26</a:t>
+              <a:t>05/01/2026</a:t>
             </a:fld>
             <a:endParaRPr lang="es-ES"/>
           </a:p>
@@ -3018,7 +3019,7 @@
           <a:p>
             <a:fld id="{6A3C2F7B-537C-4500-BF1F-DDEBE70AF5A2}" type="datetimeFigureOut">
               <a:rPr lang="es-ES" smtClean="0"/>
-              <a:t>4/1/26</a:t>
+              <a:t>05/01/2026</a:t>
             </a:fld>
             <a:endParaRPr lang="es-ES"/>
           </a:p>
@@ -3329,7 +3330,7 @@
           <a:p>
             <a:fld id="{6A3C2F7B-537C-4500-BF1F-DDEBE70AF5A2}" type="datetimeFigureOut">
               <a:rPr lang="es-ES" smtClean="0"/>
-              <a:t>4/1/26</a:t>
+              <a:t>05/01/2026</a:t>
             </a:fld>
             <a:endParaRPr lang="es-ES"/>
           </a:p>
@@ -3617,7 +3618,7 @@
           <a:p>
             <a:fld id="{6A3C2F7B-537C-4500-BF1F-DDEBE70AF5A2}" type="datetimeFigureOut">
               <a:rPr lang="es-ES" smtClean="0"/>
-              <a:t>4/1/26</a:t>
+              <a:t>05/01/2026</a:t>
             </a:fld>
             <a:endParaRPr lang="es-ES"/>
           </a:p>
@@ -3858,7 +3859,7 @@
           <a:p>
             <a:fld id="{6A3C2F7B-537C-4500-BF1F-DDEBE70AF5A2}" type="datetimeFigureOut">
               <a:rPr lang="es-ES" smtClean="0"/>
-              <a:t>4/1/26</a:t>
+              <a:t>05/01/2026</a:t>
             </a:fld>
             <a:endParaRPr lang="es-ES"/>
           </a:p>
@@ -6155,6 +6156,165 @@
 </p:sld>
 </file>
 
+<file path=ppt/slides/slide19.xml><?xml version="1.0" encoding="utf-8"?>
+<p:sld xmlns:a="http://schemas.openxmlformats.org/drawingml/2006/main" xmlns:r="http://schemas.openxmlformats.org/officeDocument/2006/relationships" xmlns:p="http://schemas.openxmlformats.org/presentationml/2006/main">
+  <p:cSld>
+    <p:spTree>
+      <p:nvGrpSpPr>
+        <p:cNvPr id="1" name="">
+          <a:extLst>
+            <a:ext uri="{FF2B5EF4-FFF2-40B4-BE49-F238E27FC236}">
+              <a16:creationId xmlns:a16="http://schemas.microsoft.com/office/drawing/2014/main" id="{4B94F80A-071C-338C-291F-2AD14EF3B1C7}"/>
+            </a:ext>
+          </a:extLst>
+        </p:cNvPr>
+        <p:cNvGrpSpPr/>
+        <p:nvPr/>
+      </p:nvGrpSpPr>
+      <p:grpSpPr>
+        <a:xfrm>
+          <a:off x="0" y="0"/>
+          <a:ext cx="0" cy="0"/>
+          <a:chOff x="0" y="0"/>
+          <a:chExt cx="0" cy="0"/>
+        </a:xfrm>
+      </p:grpSpPr>
+      <p:sp>
+        <p:nvSpPr>
+          <p:cNvPr id="2" name="Title 1">
+            <a:extLst>
+              <a:ext uri="{FF2B5EF4-FFF2-40B4-BE49-F238E27FC236}">
+                <a16:creationId xmlns:a16="http://schemas.microsoft.com/office/drawing/2014/main" id="{CE747146-4EA1-AA67-17BB-5CA0BD57D447}"/>
+              </a:ext>
+            </a:extLst>
+          </p:cNvPr>
+          <p:cNvSpPr>
+            <a:spLocks noGrp="1"/>
+          </p:cNvSpPr>
+          <p:nvPr>
+            <p:ph type="title"/>
+          </p:nvPr>
+        </p:nvSpPr>
+        <p:spPr/>
+        <p:txBody>
+          <a:bodyPr/>
+          <a:lstStyle/>
+          <a:p>
+            <a:r>
+              <a:rPr lang="en-001" dirty="0"/>
+              <a:t>SECURITY </a:t>
+            </a:r>
+            <a:r>
+              <a:rPr lang="en-US" dirty="0"/>
+              <a:t>PROBLEM</a:t>
+            </a:r>
+          </a:p>
+        </p:txBody>
+      </p:sp>
+      <p:sp>
+        <p:nvSpPr>
+          <p:cNvPr id="3" name="Content Placeholder 2">
+            <a:extLst>
+              <a:ext uri="{FF2B5EF4-FFF2-40B4-BE49-F238E27FC236}">
+                <a16:creationId xmlns:a16="http://schemas.microsoft.com/office/drawing/2014/main" id="{3275C814-2661-2F57-ADD4-4A961CB1C671}"/>
+              </a:ext>
+            </a:extLst>
+          </p:cNvPr>
+          <p:cNvSpPr>
+            <a:spLocks noGrp="1"/>
+          </p:cNvSpPr>
+          <p:nvPr>
+            <p:ph idx="1"/>
+          </p:nvPr>
+        </p:nvSpPr>
+        <p:spPr>
+          <a:xfrm>
+            <a:off x="838200" y="1576301"/>
+            <a:ext cx="5822092" cy="4916574"/>
+          </a:xfrm>
+        </p:spPr>
+        <p:txBody>
+          <a:bodyPr>
+            <a:normAutofit lnSpcReduction="10000"/>
+          </a:bodyPr>
+          <a:lstStyle/>
+          <a:p>
+            <a:pPr marL="0" indent="0">
+              <a:buNone/>
+            </a:pPr>
+            <a:r>
+              <a:rPr lang="en-US" sz="2400" dirty="0"/>
+              <a:t>An attacker sends a grade edit request to Grading Management component.</a:t>
+            </a:r>
+            <a:endParaRPr lang="en-001" sz="2400" dirty="0"/>
+          </a:p>
+          <a:p>
+            <a:pPr marL="0" indent="0">
+              <a:buNone/>
+            </a:pPr>
+            <a:endParaRPr lang="en-001" sz="2400" dirty="0"/>
+          </a:p>
+          <a:p>
+            <a:pPr marL="0" indent="0">
+              <a:buNone/>
+            </a:pPr>
+            <a:r>
+              <a:rPr lang="en-001" sz="3200" dirty="0"/>
+              <a:t>Solution:</a:t>
+            </a:r>
+          </a:p>
+          <a:p>
+            <a:pPr marL="0" indent="0">
+              <a:buNone/>
+            </a:pPr>
+            <a:endParaRPr lang="en-001" sz="2400" dirty="0"/>
+          </a:p>
+          <a:p>
+            <a:pPr marL="0" indent="0">
+              <a:buNone/>
+            </a:pPr>
+            <a:r>
+              <a:rPr lang="en-US" sz="2400" dirty="0"/>
+              <a:t>The request is detected, an attacker is not recognized as a teacher, notification is sent (or the grades data is restored).</a:t>
+            </a:r>
+            <a:endParaRPr lang="en-001" sz="2400" dirty="0"/>
+          </a:p>
+          <a:p>
+            <a:pPr marL="0" indent="0">
+              <a:buNone/>
+            </a:pPr>
+            <a:endParaRPr lang="en-001" sz="2400" dirty="0"/>
+          </a:p>
+          <a:p>
+            <a:pPr marL="0" indent="0">
+              <a:buNone/>
+            </a:pPr>
+            <a:endParaRPr lang="en-001" sz="2400" dirty="0"/>
+          </a:p>
+          <a:p>
+            <a:pPr marL="0" indent="0">
+              <a:buNone/>
+            </a:pPr>
+            <a:r>
+              <a:rPr lang="en-001" sz="2400" dirty="0"/>
+              <a:t>The current architecture does not require an update.</a:t>
+            </a:r>
+          </a:p>
+        </p:txBody>
+      </p:sp>
+    </p:spTree>
+    <p:extLst>
+      <p:ext uri="{BB962C8B-B14F-4D97-AF65-F5344CB8AC3E}">
+        <p14:creationId xmlns:p14="http://schemas.microsoft.com/office/powerpoint/2010/main" val="976070164"/>
+      </p:ext>
+    </p:extLst>
+  </p:cSld>
+  <p:clrMapOvr>
+    <a:masterClrMapping/>
+  </p:clrMapOvr>
+</p:sld>
+</file>
+
 <file path=ppt/slides/slide2.xml><?xml version="1.0" encoding="utf-8"?>
 <p:sld xmlns:a="http://schemas.openxmlformats.org/drawingml/2006/main" xmlns:r="http://schemas.openxmlformats.org/officeDocument/2006/relationships" xmlns:p="http://schemas.openxmlformats.org/presentationml/2006/main">
   <p:cSld>
@@ -6312,93 +6472,93 @@
           <a:custGeom>
             <a:avLst/>
             <a:gdLst>
-              <a:gd name="connsiteX0" fmla="*/ 0 w 4243589"/>
-              <a:gd name="connsiteY0" fmla="*/ 0 h 18288"/>
-              <a:gd name="connsiteX1" fmla="*/ 478919 w 4243589"/>
-              <a:gd name="connsiteY1" fmla="*/ 0 h 18288"/>
-              <a:gd name="connsiteX2" fmla="*/ 957839 w 4243589"/>
-              <a:gd name="connsiteY2" fmla="*/ 0 h 18288"/>
-              <a:gd name="connsiteX3" fmla="*/ 1521630 w 4243589"/>
-              <a:gd name="connsiteY3" fmla="*/ 0 h 18288"/>
-              <a:gd name="connsiteX4" fmla="*/ 2212729 w 4243589"/>
-              <a:gd name="connsiteY4" fmla="*/ 0 h 18288"/>
-              <a:gd name="connsiteX5" fmla="*/ 2734084 w 4243589"/>
-              <a:gd name="connsiteY5" fmla="*/ 0 h 18288"/>
-              <a:gd name="connsiteX6" fmla="*/ 3255439 w 4243589"/>
-              <a:gd name="connsiteY6" fmla="*/ 0 h 18288"/>
-              <a:gd name="connsiteX7" fmla="*/ 4243589 w 4243589"/>
-              <a:gd name="connsiteY7" fmla="*/ 0 h 18288"/>
-              <a:gd name="connsiteX8" fmla="*/ 4243589 w 4243589"/>
-              <a:gd name="connsiteY8" fmla="*/ 18288 h 18288"/>
-              <a:gd name="connsiteX9" fmla="*/ 3594926 w 4243589"/>
-              <a:gd name="connsiteY9" fmla="*/ 18288 h 18288"/>
-              <a:gd name="connsiteX10" fmla="*/ 3073571 w 4243589"/>
-              <a:gd name="connsiteY10" fmla="*/ 18288 h 18288"/>
-              <a:gd name="connsiteX11" fmla="*/ 2552216 w 4243589"/>
-              <a:gd name="connsiteY11" fmla="*/ 18288 h 18288"/>
-              <a:gd name="connsiteX12" fmla="*/ 1903553 w 4243589"/>
-              <a:gd name="connsiteY12" fmla="*/ 18288 h 18288"/>
-              <a:gd name="connsiteX13" fmla="*/ 1212454 w 4243589"/>
-              <a:gd name="connsiteY13" fmla="*/ 18288 h 18288"/>
-              <a:gd name="connsiteX14" fmla="*/ 733535 w 4243589"/>
-              <a:gd name="connsiteY14" fmla="*/ 18288 h 18288"/>
-              <a:gd name="connsiteX15" fmla="*/ 0 w 4243589"/>
-              <a:gd name="connsiteY15" fmla="*/ 18288 h 18288"/>
-              <a:gd name="connsiteX16" fmla="*/ 0 w 4243589"/>
-              <a:gd name="connsiteY16" fmla="*/ 0 h 18288"/>
+              <a:gd name="csX0" fmla="*/ 0 w 4243589"/>
+              <a:gd name="csY0" fmla="*/ 0 h 18288"/>
+              <a:gd name="csX1" fmla="*/ 478919 w 4243589"/>
+              <a:gd name="csY1" fmla="*/ 0 h 18288"/>
+              <a:gd name="csX2" fmla="*/ 957839 w 4243589"/>
+              <a:gd name="csY2" fmla="*/ 0 h 18288"/>
+              <a:gd name="csX3" fmla="*/ 1521630 w 4243589"/>
+              <a:gd name="csY3" fmla="*/ 0 h 18288"/>
+              <a:gd name="csX4" fmla="*/ 2212729 w 4243589"/>
+              <a:gd name="csY4" fmla="*/ 0 h 18288"/>
+              <a:gd name="csX5" fmla="*/ 2734084 w 4243589"/>
+              <a:gd name="csY5" fmla="*/ 0 h 18288"/>
+              <a:gd name="csX6" fmla="*/ 3255439 w 4243589"/>
+              <a:gd name="csY6" fmla="*/ 0 h 18288"/>
+              <a:gd name="csX7" fmla="*/ 4243589 w 4243589"/>
+              <a:gd name="csY7" fmla="*/ 0 h 18288"/>
+              <a:gd name="csX8" fmla="*/ 4243589 w 4243589"/>
+              <a:gd name="csY8" fmla="*/ 18288 h 18288"/>
+              <a:gd name="csX9" fmla="*/ 3594926 w 4243589"/>
+              <a:gd name="csY9" fmla="*/ 18288 h 18288"/>
+              <a:gd name="csX10" fmla="*/ 3073571 w 4243589"/>
+              <a:gd name="csY10" fmla="*/ 18288 h 18288"/>
+              <a:gd name="csX11" fmla="*/ 2552216 w 4243589"/>
+              <a:gd name="csY11" fmla="*/ 18288 h 18288"/>
+              <a:gd name="csX12" fmla="*/ 1903553 w 4243589"/>
+              <a:gd name="csY12" fmla="*/ 18288 h 18288"/>
+              <a:gd name="csX13" fmla="*/ 1212454 w 4243589"/>
+              <a:gd name="csY13" fmla="*/ 18288 h 18288"/>
+              <a:gd name="csX14" fmla="*/ 733535 w 4243589"/>
+              <a:gd name="csY14" fmla="*/ 18288 h 18288"/>
+              <a:gd name="csX15" fmla="*/ 0 w 4243589"/>
+              <a:gd name="csY15" fmla="*/ 18288 h 18288"/>
+              <a:gd name="csX16" fmla="*/ 0 w 4243589"/>
+              <a:gd name="csY16" fmla="*/ 0 h 18288"/>
             </a:gdLst>
             <a:ahLst/>
             <a:cxnLst>
               <a:cxn ang="0">
-                <a:pos x="connsiteX0" y="connsiteY0"/>
+                <a:pos x="csX0" y="csY0"/>
               </a:cxn>
               <a:cxn ang="0">
-                <a:pos x="connsiteX1" y="connsiteY1"/>
+                <a:pos x="csX1" y="csY1"/>
               </a:cxn>
               <a:cxn ang="0">
-                <a:pos x="connsiteX2" y="connsiteY2"/>
+                <a:pos x="csX2" y="csY2"/>
               </a:cxn>
               <a:cxn ang="0">
-                <a:pos x="connsiteX3" y="connsiteY3"/>
+                <a:pos x="csX3" y="csY3"/>
               </a:cxn>
               <a:cxn ang="0">
-                <a:pos x="connsiteX4" y="connsiteY4"/>
+                <a:pos x="csX4" y="csY4"/>
               </a:cxn>
               <a:cxn ang="0">
-                <a:pos x="connsiteX5" y="connsiteY5"/>
+                <a:pos x="csX5" y="csY5"/>
               </a:cxn>
               <a:cxn ang="0">
-                <a:pos x="connsiteX6" y="connsiteY6"/>
+                <a:pos x="csX6" y="csY6"/>
               </a:cxn>
               <a:cxn ang="0">
-                <a:pos x="connsiteX7" y="connsiteY7"/>
+                <a:pos x="csX7" y="csY7"/>
               </a:cxn>
               <a:cxn ang="0">
-                <a:pos x="connsiteX8" y="connsiteY8"/>
+                <a:pos x="csX8" y="csY8"/>
               </a:cxn>
               <a:cxn ang="0">
-                <a:pos x="connsiteX9" y="connsiteY9"/>
+                <a:pos x="csX9" y="csY9"/>
               </a:cxn>
               <a:cxn ang="0">
-                <a:pos x="connsiteX10" y="connsiteY10"/>
+                <a:pos x="csX10" y="csY10"/>
               </a:cxn>
               <a:cxn ang="0">
-                <a:pos x="connsiteX11" y="connsiteY11"/>
+                <a:pos x="csX11" y="csY11"/>
               </a:cxn>
               <a:cxn ang="0">
-                <a:pos x="connsiteX12" y="connsiteY12"/>
+                <a:pos x="csX12" y="csY12"/>
               </a:cxn>
               <a:cxn ang="0">
-                <a:pos x="connsiteX13" y="connsiteY13"/>
+                <a:pos x="csX13" y="csY13"/>
               </a:cxn>
               <a:cxn ang="0">
-                <a:pos x="connsiteX14" y="connsiteY14"/>
+                <a:pos x="csX14" y="csY14"/>
               </a:cxn>
               <a:cxn ang="0">
-                <a:pos x="connsiteX15" y="connsiteY15"/>
+                <a:pos x="csX15" y="csY15"/>
               </a:cxn>
               <a:cxn ang="0">
-                <a:pos x="connsiteX16" y="connsiteY16"/>
+                <a:pos x="csX16" y="csY16"/>
               </a:cxn>
             </a:cxnLst>
             <a:rect l="l" t="t" r="r" b="b"/>
@@ -6962,68 +7122,68 @@
           <a:custGeom>
             <a:avLst/>
             <a:gdLst>
-              <a:gd name="connsiteX0" fmla="*/ 0 w 3255095"/>
-              <a:gd name="connsiteY0" fmla="*/ 0 h 18288"/>
-              <a:gd name="connsiteX1" fmla="*/ 618468 w 3255095"/>
-              <a:gd name="connsiteY1" fmla="*/ 0 h 18288"/>
-              <a:gd name="connsiteX2" fmla="*/ 1269487 w 3255095"/>
-              <a:gd name="connsiteY2" fmla="*/ 0 h 18288"/>
-              <a:gd name="connsiteX3" fmla="*/ 1953057 w 3255095"/>
-              <a:gd name="connsiteY3" fmla="*/ 0 h 18288"/>
-              <a:gd name="connsiteX4" fmla="*/ 2636627 w 3255095"/>
-              <a:gd name="connsiteY4" fmla="*/ 0 h 18288"/>
-              <a:gd name="connsiteX5" fmla="*/ 3255095 w 3255095"/>
-              <a:gd name="connsiteY5" fmla="*/ 0 h 18288"/>
-              <a:gd name="connsiteX6" fmla="*/ 3255095 w 3255095"/>
-              <a:gd name="connsiteY6" fmla="*/ 18288 h 18288"/>
-              <a:gd name="connsiteX7" fmla="*/ 2538974 w 3255095"/>
-              <a:gd name="connsiteY7" fmla="*/ 18288 h 18288"/>
-              <a:gd name="connsiteX8" fmla="*/ 1822853 w 3255095"/>
-              <a:gd name="connsiteY8" fmla="*/ 18288 h 18288"/>
-              <a:gd name="connsiteX9" fmla="*/ 1171834 w 3255095"/>
-              <a:gd name="connsiteY9" fmla="*/ 18288 h 18288"/>
-              <a:gd name="connsiteX10" fmla="*/ 0 w 3255095"/>
-              <a:gd name="connsiteY10" fmla="*/ 18288 h 18288"/>
-              <a:gd name="connsiteX11" fmla="*/ 0 w 3255095"/>
-              <a:gd name="connsiteY11" fmla="*/ 0 h 18288"/>
+              <a:gd name="csX0" fmla="*/ 0 w 3255095"/>
+              <a:gd name="csY0" fmla="*/ 0 h 18288"/>
+              <a:gd name="csX1" fmla="*/ 618468 w 3255095"/>
+              <a:gd name="csY1" fmla="*/ 0 h 18288"/>
+              <a:gd name="csX2" fmla="*/ 1269487 w 3255095"/>
+              <a:gd name="csY2" fmla="*/ 0 h 18288"/>
+              <a:gd name="csX3" fmla="*/ 1953057 w 3255095"/>
+              <a:gd name="csY3" fmla="*/ 0 h 18288"/>
+              <a:gd name="csX4" fmla="*/ 2636627 w 3255095"/>
+              <a:gd name="csY4" fmla="*/ 0 h 18288"/>
+              <a:gd name="csX5" fmla="*/ 3255095 w 3255095"/>
+              <a:gd name="csY5" fmla="*/ 0 h 18288"/>
+              <a:gd name="csX6" fmla="*/ 3255095 w 3255095"/>
+              <a:gd name="csY6" fmla="*/ 18288 h 18288"/>
+              <a:gd name="csX7" fmla="*/ 2538974 w 3255095"/>
+              <a:gd name="csY7" fmla="*/ 18288 h 18288"/>
+              <a:gd name="csX8" fmla="*/ 1822853 w 3255095"/>
+              <a:gd name="csY8" fmla="*/ 18288 h 18288"/>
+              <a:gd name="csX9" fmla="*/ 1171834 w 3255095"/>
+              <a:gd name="csY9" fmla="*/ 18288 h 18288"/>
+              <a:gd name="csX10" fmla="*/ 0 w 3255095"/>
+              <a:gd name="csY10" fmla="*/ 18288 h 18288"/>
+              <a:gd name="csX11" fmla="*/ 0 w 3255095"/>
+              <a:gd name="csY11" fmla="*/ 0 h 18288"/>
             </a:gdLst>
             <a:ahLst/>
             <a:cxnLst>
               <a:cxn ang="0">
-                <a:pos x="connsiteX0" y="connsiteY0"/>
+                <a:pos x="csX0" y="csY0"/>
               </a:cxn>
               <a:cxn ang="0">
-                <a:pos x="connsiteX1" y="connsiteY1"/>
+                <a:pos x="csX1" y="csY1"/>
               </a:cxn>
               <a:cxn ang="0">
-                <a:pos x="connsiteX2" y="connsiteY2"/>
+                <a:pos x="csX2" y="csY2"/>
               </a:cxn>
               <a:cxn ang="0">
-                <a:pos x="connsiteX3" y="connsiteY3"/>
+                <a:pos x="csX3" y="csY3"/>
               </a:cxn>
               <a:cxn ang="0">
-                <a:pos x="connsiteX4" y="connsiteY4"/>
+                <a:pos x="csX4" y="csY4"/>
               </a:cxn>
               <a:cxn ang="0">
-                <a:pos x="connsiteX5" y="connsiteY5"/>
+                <a:pos x="csX5" y="csY5"/>
               </a:cxn>
               <a:cxn ang="0">
-                <a:pos x="connsiteX6" y="connsiteY6"/>
+                <a:pos x="csX6" y="csY6"/>
               </a:cxn>
               <a:cxn ang="0">
-                <a:pos x="connsiteX7" y="connsiteY7"/>
+                <a:pos x="csX7" y="csY7"/>
               </a:cxn>
               <a:cxn ang="0">
-                <a:pos x="connsiteX8" y="connsiteY8"/>
+                <a:pos x="csX8" y="csY8"/>
               </a:cxn>
               <a:cxn ang="0">
-                <a:pos x="connsiteX9" y="connsiteY9"/>
+                <a:pos x="csX9" y="csY9"/>
               </a:cxn>
               <a:cxn ang="0">
-                <a:pos x="connsiteX10" y="connsiteY10"/>
+                <a:pos x="csX10" y="csY10"/>
               </a:cxn>
               <a:cxn ang="0">
-                <a:pos x="connsiteX11" y="connsiteY11"/>
+                <a:pos x="csX11" y="csY11"/>
               </a:cxn>
             </a:cxnLst>
             <a:rect l="l" t="t" r="r" b="b"/>
@@ -7455,68 +7615,68 @@
           <a:custGeom>
             <a:avLst/>
             <a:gdLst>
-              <a:gd name="connsiteX0" fmla="*/ 0 w 3255095"/>
-              <a:gd name="connsiteY0" fmla="*/ 0 h 18288"/>
-              <a:gd name="connsiteX1" fmla="*/ 618468 w 3255095"/>
-              <a:gd name="connsiteY1" fmla="*/ 0 h 18288"/>
-              <a:gd name="connsiteX2" fmla="*/ 1269487 w 3255095"/>
-              <a:gd name="connsiteY2" fmla="*/ 0 h 18288"/>
-              <a:gd name="connsiteX3" fmla="*/ 1953057 w 3255095"/>
-              <a:gd name="connsiteY3" fmla="*/ 0 h 18288"/>
-              <a:gd name="connsiteX4" fmla="*/ 2636627 w 3255095"/>
-              <a:gd name="connsiteY4" fmla="*/ 0 h 18288"/>
-              <a:gd name="connsiteX5" fmla="*/ 3255095 w 3255095"/>
-              <a:gd name="connsiteY5" fmla="*/ 0 h 18288"/>
-              <a:gd name="connsiteX6" fmla="*/ 3255095 w 3255095"/>
-              <a:gd name="connsiteY6" fmla="*/ 18288 h 18288"/>
-              <a:gd name="connsiteX7" fmla="*/ 2538974 w 3255095"/>
-              <a:gd name="connsiteY7" fmla="*/ 18288 h 18288"/>
-              <a:gd name="connsiteX8" fmla="*/ 1822853 w 3255095"/>
-              <a:gd name="connsiteY8" fmla="*/ 18288 h 18288"/>
-              <a:gd name="connsiteX9" fmla="*/ 1171834 w 3255095"/>
-              <a:gd name="connsiteY9" fmla="*/ 18288 h 18288"/>
-              <a:gd name="connsiteX10" fmla="*/ 0 w 3255095"/>
-              <a:gd name="connsiteY10" fmla="*/ 18288 h 18288"/>
-              <a:gd name="connsiteX11" fmla="*/ 0 w 3255095"/>
-              <a:gd name="connsiteY11" fmla="*/ 0 h 18288"/>
+              <a:gd name="csX0" fmla="*/ 0 w 3255095"/>
+              <a:gd name="csY0" fmla="*/ 0 h 18288"/>
+              <a:gd name="csX1" fmla="*/ 618468 w 3255095"/>
+              <a:gd name="csY1" fmla="*/ 0 h 18288"/>
+              <a:gd name="csX2" fmla="*/ 1269487 w 3255095"/>
+              <a:gd name="csY2" fmla="*/ 0 h 18288"/>
+              <a:gd name="csX3" fmla="*/ 1953057 w 3255095"/>
+              <a:gd name="csY3" fmla="*/ 0 h 18288"/>
+              <a:gd name="csX4" fmla="*/ 2636627 w 3255095"/>
+              <a:gd name="csY4" fmla="*/ 0 h 18288"/>
+              <a:gd name="csX5" fmla="*/ 3255095 w 3255095"/>
+              <a:gd name="csY5" fmla="*/ 0 h 18288"/>
+              <a:gd name="csX6" fmla="*/ 3255095 w 3255095"/>
+              <a:gd name="csY6" fmla="*/ 18288 h 18288"/>
+              <a:gd name="csX7" fmla="*/ 2538974 w 3255095"/>
+              <a:gd name="csY7" fmla="*/ 18288 h 18288"/>
+              <a:gd name="csX8" fmla="*/ 1822853 w 3255095"/>
+              <a:gd name="csY8" fmla="*/ 18288 h 18288"/>
+              <a:gd name="csX9" fmla="*/ 1171834 w 3255095"/>
+              <a:gd name="csY9" fmla="*/ 18288 h 18288"/>
+              <a:gd name="csX10" fmla="*/ 0 w 3255095"/>
+              <a:gd name="csY10" fmla="*/ 18288 h 18288"/>
+              <a:gd name="csX11" fmla="*/ 0 w 3255095"/>
+              <a:gd name="csY11" fmla="*/ 0 h 18288"/>
             </a:gdLst>
             <a:ahLst/>
             <a:cxnLst>
               <a:cxn ang="0">
-                <a:pos x="connsiteX0" y="connsiteY0"/>
+                <a:pos x="csX0" y="csY0"/>
               </a:cxn>
               <a:cxn ang="0">
-                <a:pos x="connsiteX1" y="connsiteY1"/>
+                <a:pos x="csX1" y="csY1"/>
               </a:cxn>
               <a:cxn ang="0">
-                <a:pos x="connsiteX2" y="connsiteY2"/>
+                <a:pos x="csX2" y="csY2"/>
               </a:cxn>
               <a:cxn ang="0">
-                <a:pos x="connsiteX3" y="connsiteY3"/>
+                <a:pos x="csX3" y="csY3"/>
               </a:cxn>
               <a:cxn ang="0">
-                <a:pos x="connsiteX4" y="connsiteY4"/>
+                <a:pos x="csX4" y="csY4"/>
               </a:cxn>
               <a:cxn ang="0">
-                <a:pos x="connsiteX5" y="connsiteY5"/>
+                <a:pos x="csX5" y="csY5"/>
               </a:cxn>
               <a:cxn ang="0">
-                <a:pos x="connsiteX6" y="connsiteY6"/>
+                <a:pos x="csX6" y="csY6"/>
               </a:cxn>
               <a:cxn ang="0">
-                <a:pos x="connsiteX7" y="connsiteY7"/>
+                <a:pos x="csX7" y="csY7"/>
               </a:cxn>
               <a:cxn ang="0">
-                <a:pos x="connsiteX8" y="connsiteY8"/>
+                <a:pos x="csX8" y="csY8"/>
               </a:cxn>
               <a:cxn ang="0">
-                <a:pos x="connsiteX9" y="connsiteY9"/>
+                <a:pos x="csX9" y="csY9"/>
               </a:cxn>
               <a:cxn ang="0">
-                <a:pos x="connsiteX10" y="connsiteY10"/>
+                <a:pos x="csX10" y="csY10"/>
               </a:cxn>
               <a:cxn ang="0">
-                <a:pos x="connsiteX11" y="connsiteY11"/>
+                <a:pos x="csX11" y="csY11"/>
               </a:cxn>
             </a:cxnLst>
             <a:rect l="l" t="t" r="r" b="b"/>
@@ -7949,68 +8109,68 @@
           <a:custGeom>
             <a:avLst/>
             <a:gdLst>
-              <a:gd name="connsiteX0" fmla="*/ 0 w 3255095"/>
-              <a:gd name="connsiteY0" fmla="*/ 0 h 18288"/>
-              <a:gd name="connsiteX1" fmla="*/ 618468 w 3255095"/>
-              <a:gd name="connsiteY1" fmla="*/ 0 h 18288"/>
-              <a:gd name="connsiteX2" fmla="*/ 1269487 w 3255095"/>
-              <a:gd name="connsiteY2" fmla="*/ 0 h 18288"/>
-              <a:gd name="connsiteX3" fmla="*/ 1953057 w 3255095"/>
-              <a:gd name="connsiteY3" fmla="*/ 0 h 18288"/>
-              <a:gd name="connsiteX4" fmla="*/ 2636627 w 3255095"/>
-              <a:gd name="connsiteY4" fmla="*/ 0 h 18288"/>
-              <a:gd name="connsiteX5" fmla="*/ 3255095 w 3255095"/>
-              <a:gd name="connsiteY5" fmla="*/ 0 h 18288"/>
-              <a:gd name="connsiteX6" fmla="*/ 3255095 w 3255095"/>
-              <a:gd name="connsiteY6" fmla="*/ 18288 h 18288"/>
-              <a:gd name="connsiteX7" fmla="*/ 2538974 w 3255095"/>
-              <a:gd name="connsiteY7" fmla="*/ 18288 h 18288"/>
-              <a:gd name="connsiteX8" fmla="*/ 1822853 w 3255095"/>
-              <a:gd name="connsiteY8" fmla="*/ 18288 h 18288"/>
-              <a:gd name="connsiteX9" fmla="*/ 1171834 w 3255095"/>
-              <a:gd name="connsiteY9" fmla="*/ 18288 h 18288"/>
-              <a:gd name="connsiteX10" fmla="*/ 0 w 3255095"/>
-              <a:gd name="connsiteY10" fmla="*/ 18288 h 18288"/>
-              <a:gd name="connsiteX11" fmla="*/ 0 w 3255095"/>
-              <a:gd name="connsiteY11" fmla="*/ 0 h 18288"/>
+              <a:gd name="csX0" fmla="*/ 0 w 3255095"/>
+              <a:gd name="csY0" fmla="*/ 0 h 18288"/>
+              <a:gd name="csX1" fmla="*/ 618468 w 3255095"/>
+              <a:gd name="csY1" fmla="*/ 0 h 18288"/>
+              <a:gd name="csX2" fmla="*/ 1269487 w 3255095"/>
+              <a:gd name="csY2" fmla="*/ 0 h 18288"/>
+              <a:gd name="csX3" fmla="*/ 1953057 w 3255095"/>
+              <a:gd name="csY3" fmla="*/ 0 h 18288"/>
+              <a:gd name="csX4" fmla="*/ 2636627 w 3255095"/>
+              <a:gd name="csY4" fmla="*/ 0 h 18288"/>
+              <a:gd name="csX5" fmla="*/ 3255095 w 3255095"/>
+              <a:gd name="csY5" fmla="*/ 0 h 18288"/>
+              <a:gd name="csX6" fmla="*/ 3255095 w 3255095"/>
+              <a:gd name="csY6" fmla="*/ 18288 h 18288"/>
+              <a:gd name="csX7" fmla="*/ 2538974 w 3255095"/>
+              <a:gd name="csY7" fmla="*/ 18288 h 18288"/>
+              <a:gd name="csX8" fmla="*/ 1822853 w 3255095"/>
+              <a:gd name="csY8" fmla="*/ 18288 h 18288"/>
+              <a:gd name="csX9" fmla="*/ 1171834 w 3255095"/>
+              <a:gd name="csY9" fmla="*/ 18288 h 18288"/>
+              <a:gd name="csX10" fmla="*/ 0 w 3255095"/>
+              <a:gd name="csY10" fmla="*/ 18288 h 18288"/>
+              <a:gd name="csX11" fmla="*/ 0 w 3255095"/>
+              <a:gd name="csY11" fmla="*/ 0 h 18288"/>
             </a:gdLst>
             <a:ahLst/>
             <a:cxnLst>
               <a:cxn ang="0">
-                <a:pos x="connsiteX0" y="connsiteY0"/>
+                <a:pos x="csX0" y="csY0"/>
               </a:cxn>
               <a:cxn ang="0">
-                <a:pos x="connsiteX1" y="connsiteY1"/>
+                <a:pos x="csX1" y="csY1"/>
               </a:cxn>
               <a:cxn ang="0">
-                <a:pos x="connsiteX2" y="connsiteY2"/>
+                <a:pos x="csX2" y="csY2"/>
               </a:cxn>
               <a:cxn ang="0">
-                <a:pos x="connsiteX3" y="connsiteY3"/>
+                <a:pos x="csX3" y="csY3"/>
               </a:cxn>
               <a:cxn ang="0">
-                <a:pos x="connsiteX4" y="connsiteY4"/>
+                <a:pos x="csX4" y="csY4"/>
               </a:cxn>
               <a:cxn ang="0">
-                <a:pos x="connsiteX5" y="connsiteY5"/>
+                <a:pos x="csX5" y="csY5"/>
               </a:cxn>
               <a:cxn ang="0">
-                <a:pos x="connsiteX6" y="connsiteY6"/>
+                <a:pos x="csX6" y="csY6"/>
               </a:cxn>
               <a:cxn ang="0">
-                <a:pos x="connsiteX7" y="connsiteY7"/>
+                <a:pos x="csX7" y="csY7"/>
               </a:cxn>
               <a:cxn ang="0">
-                <a:pos x="connsiteX8" y="connsiteY8"/>
+                <a:pos x="csX8" y="csY8"/>
               </a:cxn>
               <a:cxn ang="0">
-                <a:pos x="connsiteX9" y="connsiteY9"/>
+                <a:pos x="csX9" y="csY9"/>
               </a:cxn>
               <a:cxn ang="0">
-                <a:pos x="connsiteX10" y="connsiteY10"/>
+                <a:pos x="csX10" y="csY10"/>
               </a:cxn>
               <a:cxn ang="0">
-                <a:pos x="connsiteX11" y="connsiteY11"/>
+                <a:pos x="csX11" y="csY11"/>
               </a:cxn>
             </a:cxnLst>
             <a:rect l="l" t="t" r="r" b="b"/>
@@ -8700,68 +8860,68 @@
           <a:custGeom>
             <a:avLst/>
             <a:gdLst>
-              <a:gd name="connsiteX0" fmla="*/ 0 w 3255095"/>
-              <a:gd name="connsiteY0" fmla="*/ 0 h 18288"/>
-              <a:gd name="connsiteX1" fmla="*/ 618468 w 3255095"/>
-              <a:gd name="connsiteY1" fmla="*/ 0 h 18288"/>
-              <a:gd name="connsiteX2" fmla="*/ 1269487 w 3255095"/>
-              <a:gd name="connsiteY2" fmla="*/ 0 h 18288"/>
-              <a:gd name="connsiteX3" fmla="*/ 1953057 w 3255095"/>
-              <a:gd name="connsiteY3" fmla="*/ 0 h 18288"/>
-              <a:gd name="connsiteX4" fmla="*/ 2636627 w 3255095"/>
-              <a:gd name="connsiteY4" fmla="*/ 0 h 18288"/>
-              <a:gd name="connsiteX5" fmla="*/ 3255095 w 3255095"/>
-              <a:gd name="connsiteY5" fmla="*/ 0 h 18288"/>
-              <a:gd name="connsiteX6" fmla="*/ 3255095 w 3255095"/>
-              <a:gd name="connsiteY6" fmla="*/ 18288 h 18288"/>
-              <a:gd name="connsiteX7" fmla="*/ 2538974 w 3255095"/>
-              <a:gd name="connsiteY7" fmla="*/ 18288 h 18288"/>
-              <a:gd name="connsiteX8" fmla="*/ 1822853 w 3255095"/>
-              <a:gd name="connsiteY8" fmla="*/ 18288 h 18288"/>
-              <a:gd name="connsiteX9" fmla="*/ 1171834 w 3255095"/>
-              <a:gd name="connsiteY9" fmla="*/ 18288 h 18288"/>
-              <a:gd name="connsiteX10" fmla="*/ 0 w 3255095"/>
-              <a:gd name="connsiteY10" fmla="*/ 18288 h 18288"/>
-              <a:gd name="connsiteX11" fmla="*/ 0 w 3255095"/>
-              <a:gd name="connsiteY11" fmla="*/ 0 h 18288"/>
+              <a:gd name="csX0" fmla="*/ 0 w 3255095"/>
+              <a:gd name="csY0" fmla="*/ 0 h 18288"/>
+              <a:gd name="csX1" fmla="*/ 618468 w 3255095"/>
+              <a:gd name="csY1" fmla="*/ 0 h 18288"/>
+              <a:gd name="csX2" fmla="*/ 1269487 w 3255095"/>
+              <a:gd name="csY2" fmla="*/ 0 h 18288"/>
+              <a:gd name="csX3" fmla="*/ 1953057 w 3255095"/>
+              <a:gd name="csY3" fmla="*/ 0 h 18288"/>
+              <a:gd name="csX4" fmla="*/ 2636627 w 3255095"/>
+              <a:gd name="csY4" fmla="*/ 0 h 18288"/>
+              <a:gd name="csX5" fmla="*/ 3255095 w 3255095"/>
+              <a:gd name="csY5" fmla="*/ 0 h 18288"/>
+              <a:gd name="csX6" fmla="*/ 3255095 w 3255095"/>
+              <a:gd name="csY6" fmla="*/ 18288 h 18288"/>
+              <a:gd name="csX7" fmla="*/ 2538974 w 3255095"/>
+              <a:gd name="csY7" fmla="*/ 18288 h 18288"/>
+              <a:gd name="csX8" fmla="*/ 1822853 w 3255095"/>
+              <a:gd name="csY8" fmla="*/ 18288 h 18288"/>
+              <a:gd name="csX9" fmla="*/ 1171834 w 3255095"/>
+              <a:gd name="csY9" fmla="*/ 18288 h 18288"/>
+              <a:gd name="csX10" fmla="*/ 0 w 3255095"/>
+              <a:gd name="csY10" fmla="*/ 18288 h 18288"/>
+              <a:gd name="csX11" fmla="*/ 0 w 3255095"/>
+              <a:gd name="csY11" fmla="*/ 0 h 18288"/>
             </a:gdLst>
             <a:ahLst/>
             <a:cxnLst>
               <a:cxn ang="0">
-                <a:pos x="connsiteX0" y="connsiteY0"/>
+                <a:pos x="csX0" y="csY0"/>
               </a:cxn>
               <a:cxn ang="0">
-                <a:pos x="connsiteX1" y="connsiteY1"/>
+                <a:pos x="csX1" y="csY1"/>
               </a:cxn>
               <a:cxn ang="0">
-                <a:pos x="connsiteX2" y="connsiteY2"/>
+                <a:pos x="csX2" y="csY2"/>
               </a:cxn>
               <a:cxn ang="0">
-                <a:pos x="connsiteX3" y="connsiteY3"/>
+                <a:pos x="csX3" y="csY3"/>
               </a:cxn>
               <a:cxn ang="0">
-                <a:pos x="connsiteX4" y="connsiteY4"/>
+                <a:pos x="csX4" y="csY4"/>
               </a:cxn>
               <a:cxn ang="0">
-                <a:pos x="connsiteX5" y="connsiteY5"/>
+                <a:pos x="csX5" y="csY5"/>
               </a:cxn>
               <a:cxn ang="0">
-                <a:pos x="connsiteX6" y="connsiteY6"/>
+                <a:pos x="csX6" y="csY6"/>
               </a:cxn>
               <a:cxn ang="0">
-                <a:pos x="connsiteX7" y="connsiteY7"/>
+                <a:pos x="csX7" y="csY7"/>
               </a:cxn>
               <a:cxn ang="0">
-                <a:pos x="connsiteX8" y="connsiteY8"/>
+                <a:pos x="csX8" y="csY8"/>
               </a:cxn>
               <a:cxn ang="0">
-                <a:pos x="connsiteX9" y="connsiteY9"/>
+                <a:pos x="csX9" y="csY9"/>
               </a:cxn>
               <a:cxn ang="0">
-                <a:pos x="connsiteX10" y="connsiteY10"/>
+                <a:pos x="csX10" y="csY10"/>
               </a:cxn>
               <a:cxn ang="0">
-                <a:pos x="connsiteX11" y="connsiteY11"/>
+                <a:pos x="csX11" y="csY11"/>
               </a:cxn>
             </a:cxnLst>
             <a:rect l="l" t="t" r="r" b="b"/>

</xml_diff>

<commit_message>
PPT Changes - Martin
</commit_message>
<xml_diff>
--- a/M2/Presentation_Qualities.pptx
+++ b/M2/Presentation_Qualities.pptx
@@ -7310,7 +7310,7 @@
             <a:pPr algn="l"/>
             <a:r>
               <a:rPr lang="en-US" b="1" dirty="0"/>
-              <a:t>Vlad</a:t>
+              <a:t>Vladislav</a:t>
             </a:r>
           </a:p>
           <a:p>
@@ -7434,7 +7434,7 @@
                   <a:schemeClr val="tx1"/>
                 </a:solidFill>
               </a:rPr>
-              <a:t>When a user makes a request, the system should respond within a maximum of 2 seconds during peak periods (5000 requests per second).</a:t>
+              <a:t>When a user makes a request, the system should respond within a maximum of 5 seconds during peak periods (5000 requests per second).</a:t>
             </a:r>
           </a:p>
           <a:p>
@@ -7789,7 +7789,7 @@
         <p:spPr>
           <a:xfrm>
             <a:off x="-26479" y="1349829"/>
-            <a:ext cx="12425847" cy="4898571"/>
+            <a:ext cx="12218479" cy="4898571"/>
           </a:xfrm>
         </p:spPr>
       </p:pic>
@@ -7872,14 +7872,13 @@
               </a:ext>
             </a:extLst>
           </a:blip>
-          <a:stretch>
-            <a:fillRect/>
-          </a:stretch>
+          <a:srcRect/>
+          <a:stretch/>
         </p:blipFill>
         <p:spPr>
           <a:xfrm>
-            <a:off x="92636" y="258896"/>
-            <a:ext cx="12006727" cy="6340207"/>
+            <a:off x="0" y="0"/>
+            <a:ext cx="12192000" cy="6858000"/>
           </a:xfrm>
         </p:spPr>
       </p:pic>
@@ -7962,14 +7961,13 @@
               </a:ext>
             </a:extLst>
           </a:blip>
-          <a:stretch>
-            <a:fillRect/>
-          </a:stretch>
+          <a:srcRect/>
+          <a:stretch/>
         </p:blipFill>
         <p:spPr>
           <a:xfrm>
-            <a:off x="2005069" y="46898"/>
-            <a:ext cx="7943162" cy="6764204"/>
+            <a:off x="0" y="0"/>
+            <a:ext cx="12192000" cy="6858000"/>
           </a:xfrm>
         </p:spPr>
       </p:pic>
@@ -9530,7 +9528,7 @@
         <p:spPr>
           <a:xfrm>
             <a:off x="433086" y="0"/>
-            <a:ext cx="10515600" cy="1325563"/>
+            <a:ext cx="5662913" cy="1325563"/>
           </a:xfrm>
         </p:spPr>
         <p:txBody>
@@ -11470,8 +11468,8 @@
         </p:nvSpPr>
         <p:spPr>
           <a:xfrm>
-            <a:off x="5105398" y="1115568"/>
-            <a:ext cx="6245352" cy="4626864"/>
+            <a:off x="5105398" y="1621410"/>
+            <a:ext cx="6245352" cy="4121022"/>
           </a:xfrm>
         </p:spPr>
         <p:txBody>
@@ -11488,7 +11486,7 @@
           <a:p>
             <a:r>
               <a:rPr lang="en-US" dirty="0"/>
-              <a:t>During testing only the adaptor (which only needs to be deployed once for all components in the backend API) and the module being tested need to be deployed. </a:t>
+              <a:t>During testing, only the adaptor (which only needs to be deployed once for all components in the backend API) and the module being tested need to be deployed as other modules and the database can be mocked in the integration and persistence adaptors. </a:t>
             </a:r>
           </a:p>
           <a:p>

</xml_diff>

<commit_message>
Yash Mange- final changes made
</commit_message>
<xml_diff>
--- a/M2/Presentation_Qualities.pptx
+++ b/M2/Presentation_Qualities.pptx
@@ -23,7 +23,7 @@
     <p:sldId id="284" r:id="rId14"/>
     <p:sldId id="285" r:id="rId15"/>
     <p:sldId id="259" r:id="rId16"/>
-    <p:sldId id="271" r:id="rId17"/>
+    <p:sldId id="286" r:id="rId17"/>
     <p:sldId id="275" r:id="rId18"/>
     <p:sldId id="272" r:id="rId19"/>
     <p:sldId id="273" r:id="rId20"/>
@@ -937,7 +937,7 @@
           <a:p>
             <a:fld id="{FC1B7745-5391-477F-8AE8-1136866A9302}" type="datetimeFigureOut">
               <a:rPr lang="es-ES" smtClean="0"/>
-              <a:t>05/01/2026</a:t>
+              <a:t>7/1/26</a:t>
             </a:fld>
             <a:endParaRPr lang="es-ES"/>
           </a:p>
@@ -1473,7 +1473,7 @@
           <a:p>
             <a:fld id="{6A3C2F7B-537C-4500-BF1F-DDEBE70AF5A2}" type="datetimeFigureOut">
               <a:rPr lang="es-ES" smtClean="0"/>
-              <a:t>05/01/2026</a:t>
+              <a:t>7/1/26</a:t>
             </a:fld>
             <a:endParaRPr lang="es-ES"/>
           </a:p>
@@ -1771,7 +1771,7 @@
           <a:p>
             <a:fld id="{6A3C2F7B-537C-4500-BF1F-DDEBE70AF5A2}" type="datetimeFigureOut">
               <a:rPr lang="es-ES" smtClean="0"/>
-              <a:t>05/01/2026</a:t>
+              <a:t>7/1/26</a:t>
             </a:fld>
             <a:endParaRPr lang="es-ES"/>
           </a:p>
@@ -1963,7 +1963,7 @@
           <a:p>
             <a:fld id="{6A3C2F7B-537C-4500-BF1F-DDEBE70AF5A2}" type="datetimeFigureOut">
               <a:rPr lang="es-ES" smtClean="0"/>
-              <a:t>05/01/2026</a:t>
+              <a:t>7/1/26</a:t>
             </a:fld>
             <a:endParaRPr lang="es-ES"/>
           </a:p>
@@ -2224,7 +2224,7 @@
           <a:p>
             <a:fld id="{6A3C2F7B-537C-4500-BF1F-DDEBE70AF5A2}" type="datetimeFigureOut">
               <a:rPr lang="es-ES" smtClean="0"/>
-              <a:t>05/01/2026</a:t>
+              <a:t>7/1/26</a:t>
             </a:fld>
             <a:endParaRPr lang="es-ES"/>
           </a:p>
@@ -2648,7 +2648,7 @@
           <a:p>
             <a:fld id="{6A3C2F7B-537C-4500-BF1F-DDEBE70AF5A2}" type="datetimeFigureOut">
               <a:rPr lang="es-ES" smtClean="0"/>
-              <a:t>05/01/2026</a:t>
+              <a:t>7/1/26</a:t>
             </a:fld>
             <a:endParaRPr lang="es-ES"/>
           </a:p>
@@ -3185,7 +3185,7 @@
           <a:p>
             <a:fld id="{6A3C2F7B-537C-4500-BF1F-DDEBE70AF5A2}" type="datetimeFigureOut">
               <a:rPr lang="es-ES" smtClean="0"/>
-              <a:t>05/01/2026</a:t>
+              <a:t>7/1/26</a:t>
             </a:fld>
             <a:endParaRPr lang="es-ES"/>
           </a:p>
@@ -4049,7 +4049,7 @@
           <a:p>
             <a:fld id="{6A3C2F7B-537C-4500-BF1F-DDEBE70AF5A2}" type="datetimeFigureOut">
               <a:rPr lang="es-ES" smtClean="0"/>
-              <a:t>05/01/2026</a:t>
+              <a:t>7/1/26</a:t>
             </a:fld>
             <a:endParaRPr lang="es-ES"/>
           </a:p>
@@ -4219,7 +4219,7 @@
           <a:p>
             <a:fld id="{6A3C2F7B-537C-4500-BF1F-DDEBE70AF5A2}" type="datetimeFigureOut">
               <a:rPr lang="es-ES" smtClean="0"/>
-              <a:t>05/01/2026</a:t>
+              <a:t>7/1/26</a:t>
             </a:fld>
             <a:endParaRPr lang="es-ES"/>
           </a:p>
@@ -4403,7 +4403,7 @@
           <a:p>
             <a:fld id="{6A3C2F7B-537C-4500-BF1F-DDEBE70AF5A2}" type="datetimeFigureOut">
               <a:rPr lang="es-ES" smtClean="0"/>
-              <a:t>05/01/2026</a:t>
+              <a:t>7/1/26</a:t>
             </a:fld>
             <a:endParaRPr lang="es-ES"/>
           </a:p>
@@ -4573,7 +4573,7 @@
           <a:p>
             <a:fld id="{6A3C2F7B-537C-4500-BF1F-DDEBE70AF5A2}" type="datetimeFigureOut">
               <a:rPr lang="es-ES" smtClean="0"/>
-              <a:t>05/01/2026</a:t>
+              <a:t>7/1/26</a:t>
             </a:fld>
             <a:endParaRPr lang="es-ES"/>
           </a:p>
@@ -4817,7 +4817,7 @@
           <a:p>
             <a:fld id="{6A3C2F7B-537C-4500-BF1F-DDEBE70AF5A2}" type="datetimeFigureOut">
               <a:rPr lang="es-ES" smtClean="0"/>
-              <a:t>05/01/2026</a:t>
+              <a:t>7/1/26</a:t>
             </a:fld>
             <a:endParaRPr lang="es-ES"/>
           </a:p>
@@ -5053,7 +5053,7 @@
           <a:p>
             <a:fld id="{6A3C2F7B-537C-4500-BF1F-DDEBE70AF5A2}" type="datetimeFigureOut">
               <a:rPr lang="es-ES" smtClean="0"/>
-              <a:t>05/01/2026</a:t>
+              <a:t>7/1/26</a:t>
             </a:fld>
             <a:endParaRPr lang="es-ES"/>
           </a:p>
@@ -5519,7 +5519,7 @@
           <a:p>
             <a:fld id="{6A3C2F7B-537C-4500-BF1F-DDEBE70AF5A2}" type="datetimeFigureOut">
               <a:rPr lang="es-ES" smtClean="0"/>
-              <a:t>05/01/2026</a:t>
+              <a:t>7/1/26</a:t>
             </a:fld>
             <a:endParaRPr lang="es-ES"/>
           </a:p>
@@ -5637,7 +5637,7 @@
           <a:p>
             <a:fld id="{6A3C2F7B-537C-4500-BF1F-DDEBE70AF5A2}" type="datetimeFigureOut">
               <a:rPr lang="es-ES" smtClean="0"/>
-              <a:t>05/01/2026</a:t>
+              <a:t>7/1/26</a:t>
             </a:fld>
             <a:endParaRPr lang="es-ES"/>
           </a:p>
@@ -5732,7 +5732,7 @@
           <a:p>
             <a:fld id="{6A3C2F7B-537C-4500-BF1F-DDEBE70AF5A2}" type="datetimeFigureOut">
               <a:rPr lang="es-ES" smtClean="0"/>
-              <a:t>05/01/2026</a:t>
+              <a:t>7/1/26</a:t>
             </a:fld>
             <a:endParaRPr lang="es-ES"/>
           </a:p>
@@ -5987,7 +5987,7 @@
           <a:p>
             <a:fld id="{6A3C2F7B-537C-4500-BF1F-DDEBE70AF5A2}" type="datetimeFigureOut">
               <a:rPr lang="es-ES" smtClean="0"/>
-              <a:t>05/01/2026</a:t>
+              <a:t>7/1/26</a:t>
             </a:fld>
             <a:endParaRPr lang="es-ES"/>
           </a:p>
@@ -6287,7 +6287,7 @@
           <a:p>
             <a:fld id="{6A3C2F7B-537C-4500-BF1F-DDEBE70AF5A2}" type="datetimeFigureOut">
               <a:rPr lang="es-ES" smtClean="0"/>
-              <a:t>05/01/2026</a:t>
+              <a:t>7/1/26</a:t>
             </a:fld>
             <a:endParaRPr lang="es-ES"/>
           </a:p>
@@ -6521,7 +6521,7 @@
           <a:p>
             <a:fld id="{6A3C2F7B-537C-4500-BF1F-DDEBE70AF5A2}" type="datetimeFigureOut">
               <a:rPr lang="es-ES" smtClean="0"/>
-              <a:t>05/01/2026</a:t>
+              <a:t>7/1/26</a:t>
             </a:fld>
             <a:endParaRPr lang="es-ES"/>
           </a:p>
@@ -8400,7 +8400,13 @@
   <p:cSld>
     <p:spTree>
       <p:nvGrpSpPr>
-        <p:cNvPr id="1" name=""/>
+        <p:cNvPr id="1" name="">
+          <a:extLst>
+            <a:ext uri="{FF2B5EF4-FFF2-40B4-BE49-F238E27FC236}">
+              <a16:creationId xmlns:a16="http://schemas.microsoft.com/office/drawing/2014/main" id="{7A5F8B78-5510-897D-3FBC-C33FE9968D77}"/>
+            </a:ext>
+          </a:extLst>
+        </p:cNvPr>
         <p:cNvGrpSpPr/>
         <p:nvPr/>
       </p:nvGrpSpPr>
@@ -8417,7 +8423,7 @@
           <p:cNvPr id="2" name="Title 1">
             <a:extLst>
               <a:ext uri="{FF2B5EF4-FFF2-40B4-BE49-F238E27FC236}">
-                <a16:creationId xmlns:a16="http://schemas.microsoft.com/office/drawing/2014/main" id="{BBF5A8BF-6192-B19B-A2C6-CDA80A202DF4}"/>
+                <a16:creationId xmlns:a16="http://schemas.microsoft.com/office/drawing/2014/main" id="{731BB516-E111-70A3-C2A7-05E08F3AF0AF}"/>
               </a:ext>
             </a:extLst>
           </p:cNvPr>
@@ -8430,7 +8436,7 @@
         </p:nvSpPr>
         <p:spPr>
           <a:xfrm>
-            <a:off x="838200" y="371904"/>
+            <a:off x="838200" y="104295"/>
             <a:ext cx="10515600" cy="1325563"/>
           </a:xfrm>
         </p:spPr>
@@ -8451,7 +8457,7 @@
           <p:cNvPr id="3" name="Content Placeholder 2">
             <a:extLst>
               <a:ext uri="{FF2B5EF4-FFF2-40B4-BE49-F238E27FC236}">
-                <a16:creationId xmlns:a16="http://schemas.microsoft.com/office/drawing/2014/main" id="{D4E7DA52-6770-12C8-9262-6A9C1DD7109B}"/>
+                <a16:creationId xmlns:a16="http://schemas.microsoft.com/office/drawing/2014/main" id="{737E8425-A7DA-2208-91E3-96D106CB6E12}"/>
               </a:ext>
             </a:extLst>
           </p:cNvPr>
@@ -8464,7 +8470,7 @@
         </p:nvSpPr>
         <p:spPr>
           <a:xfrm>
-            <a:off x="838200" y="1410227"/>
+            <a:off x="838200" y="1270527"/>
             <a:ext cx="10983686" cy="2676118"/>
           </a:xfrm>
         </p:spPr>
@@ -8474,344 +8480,621 @@
           </a:bodyPr>
           <a:lstStyle/>
           <a:p>
-            <a:pPr marL="0" indent="0">
+            <a:pPr marL="0" indent="0" algn="just">
               <a:buNone/>
             </a:pPr>
             <a:r>
-              <a:rPr lang="en-IN" sz="1400" dirty="0"/>
+              <a:rPr lang="en-IN" sz="1600" dirty="0">
+                <a:solidFill>
+                  <a:schemeClr val="tx1"/>
+                </a:solidFill>
+              </a:rPr>
               <a:t>During peak usage (e.g. after grade publication or before exam registration deadlines), external systems such as the </a:t>
             </a:r>
             <a:r>
-              <a:rPr lang="en-IN" sz="1400" b="1" dirty="0"/>
+              <a:rPr lang="en-IN" sz="1600" b="1" dirty="0">
+                <a:solidFill>
+                  <a:schemeClr val="tx1"/>
+                </a:solidFill>
+              </a:rPr>
               <a:t>Student Information System (SIS)</a:t>
             </a:r>
             <a:r>
-              <a:rPr lang="en-IN" sz="1400" dirty="0"/>
+              <a:rPr lang="en-IN" sz="1600" dirty="0">
+                <a:solidFill>
+                  <a:schemeClr val="tx1"/>
+                </a:solidFill>
+              </a:rPr>
               <a:t> or the </a:t>
             </a:r>
             <a:r>
-              <a:rPr lang="en-IN" sz="1400" b="1" dirty="0"/>
+              <a:rPr lang="en-IN" sz="1600" b="1" dirty="0">
+                <a:solidFill>
+                  <a:schemeClr val="tx1"/>
+                </a:solidFill>
+              </a:rPr>
               <a:t>Timetable Service</a:t>
             </a:r>
             <a:r>
-              <a:rPr lang="en-IN" sz="1400" dirty="0"/>
+              <a:rPr lang="en-IN" sz="1600" dirty="0">
+                <a:solidFill>
+                  <a:schemeClr val="tx1"/>
+                </a:solidFill>
+              </a:rPr>
               <a:t> may become temporarily unavailable or respond slowly.</a:t>
             </a:r>
             <a:br>
-              <a:rPr lang="en-IN" sz="1400" dirty="0"/>
+              <a:rPr lang="en-IN" sz="1600" dirty="0">
+                <a:solidFill>
+                  <a:schemeClr val="tx1"/>
+                </a:solidFill>
+              </a:rPr>
             </a:br>
             <a:r>
-              <a:rPr lang="en-IN" sz="1400" dirty="0"/>
+              <a:rPr lang="en-IN" sz="1600" dirty="0">
+                <a:solidFill>
+                  <a:schemeClr val="tx1"/>
+                </a:solidFill>
+              </a:rPr>
               <a:t>When this happens, core EXA functionality (registration, result viewing, or grading workflows) may fail or hang due to synchronous dependencies on these external services.</a:t>
             </a:r>
           </a:p>
           <a:p>
-            <a:endParaRPr lang="en-US" sz="1400" dirty="0"/>
-          </a:p>
-        </p:txBody>
-      </p:sp>
-      <p:sp>
-        <p:nvSpPr>
-          <p:cNvPr id="4" name="Content Placeholder 2">
+            <a:endParaRPr lang="en-US" sz="1600" dirty="0">
+              <a:solidFill>
+                <a:schemeClr val="tx1"/>
+              </a:solidFill>
+            </a:endParaRPr>
+          </a:p>
+        </p:txBody>
+      </p:sp>
+      <p:graphicFrame>
+        <p:nvGraphicFramePr>
+          <p:cNvPr id="5" name="Table 4">
             <a:extLst>
               <a:ext uri="{FF2B5EF4-FFF2-40B4-BE49-F238E27FC236}">
-                <a16:creationId xmlns:a16="http://schemas.microsoft.com/office/drawing/2014/main" id="{76EA7DAE-2384-CF0F-BD90-CCE4EE120430}"/>
+                <a16:creationId xmlns:a16="http://schemas.microsoft.com/office/drawing/2014/main" id="{A49937D7-AB74-7559-96AC-A2677F5E0901}"/>
               </a:ext>
             </a:extLst>
           </p:cNvPr>
-          <p:cNvSpPr txBox="1">
-            <a:spLocks/>
-          </p:cNvSpPr>
-          <p:nvPr/>
-        </p:nvSpPr>
-        <p:spPr>
-          <a:xfrm>
-            <a:off x="838200" y="2500442"/>
-            <a:ext cx="10515599" cy="3985654"/>
-          </a:xfrm>
-          <a:prstGeom prst="rect">
-            <a:avLst/>
-          </a:prstGeom>
-        </p:spPr>
-        <p:txBody>
-          <a:bodyPr vert="horz" lIns="91440" tIns="45720" rIns="91440" bIns="45720" rtlCol="0">
-            <a:normAutofit/>
-          </a:bodyPr>
-          <a:lstStyle>
-            <a:lvl1pPr marL="228600" indent="-228600" algn="l" defTabSz="914400" rtl="0" eaLnBrk="1" latinLnBrk="0" hangingPunct="1">
-              <a:lnSpc>
-                <a:spcPct val="90000"/>
-              </a:lnSpc>
-              <a:spcBef>
-                <a:spcPts val="1000"/>
-              </a:spcBef>
-              <a:buFont typeface="Arial" panose="020B0604020202020204" pitchFamily="34" charset="0"/>
-              <a:buChar char="•"/>
-              <a:defRPr sz="2800" kern="1200">
-                <a:solidFill>
-                  <a:schemeClr val="tx1"/>
-                </a:solidFill>
-                <a:latin typeface="+mn-lt"/>
-                <a:ea typeface="+mn-ea"/>
-                <a:cs typeface="+mn-cs"/>
-              </a:defRPr>
-            </a:lvl1pPr>
-            <a:lvl2pPr marL="685800" indent="-228600" algn="l" defTabSz="914400" rtl="0" eaLnBrk="1" latinLnBrk="0" hangingPunct="1">
-              <a:lnSpc>
-                <a:spcPct val="90000"/>
-              </a:lnSpc>
-              <a:spcBef>
-                <a:spcPts val="500"/>
-              </a:spcBef>
-              <a:buFont typeface="Arial" panose="020B0604020202020204" pitchFamily="34" charset="0"/>
-              <a:buChar char="•"/>
-              <a:defRPr sz="2400" kern="1200">
-                <a:solidFill>
-                  <a:schemeClr val="tx1"/>
-                </a:solidFill>
-                <a:latin typeface="+mn-lt"/>
-                <a:ea typeface="+mn-ea"/>
-                <a:cs typeface="+mn-cs"/>
-              </a:defRPr>
-            </a:lvl2pPr>
-            <a:lvl3pPr marL="1143000" indent="-228600" algn="l" defTabSz="914400" rtl="0" eaLnBrk="1" latinLnBrk="0" hangingPunct="1">
-              <a:lnSpc>
-                <a:spcPct val="90000"/>
-              </a:lnSpc>
-              <a:spcBef>
-                <a:spcPts val="500"/>
-              </a:spcBef>
-              <a:buFont typeface="Arial" panose="020B0604020202020204" pitchFamily="34" charset="0"/>
-              <a:buChar char="•"/>
-              <a:defRPr sz="2000" kern="1200">
-                <a:solidFill>
-                  <a:schemeClr val="tx1"/>
-                </a:solidFill>
-                <a:latin typeface="+mn-lt"/>
-                <a:ea typeface="+mn-ea"/>
-                <a:cs typeface="+mn-cs"/>
-              </a:defRPr>
-            </a:lvl3pPr>
-            <a:lvl4pPr marL="1600200" indent="-228600" algn="l" defTabSz="914400" rtl="0" eaLnBrk="1" latinLnBrk="0" hangingPunct="1">
-              <a:lnSpc>
-                <a:spcPct val="90000"/>
-              </a:lnSpc>
-              <a:spcBef>
-                <a:spcPts val="500"/>
-              </a:spcBef>
-              <a:buFont typeface="Arial" panose="020B0604020202020204" pitchFamily="34" charset="0"/>
-              <a:buChar char="•"/>
-              <a:defRPr sz="1800" kern="1200">
-                <a:solidFill>
-                  <a:schemeClr val="tx1"/>
-                </a:solidFill>
-                <a:latin typeface="+mn-lt"/>
-                <a:ea typeface="+mn-ea"/>
-                <a:cs typeface="+mn-cs"/>
-              </a:defRPr>
-            </a:lvl4pPr>
-            <a:lvl5pPr marL="2057400" indent="-228600" algn="l" defTabSz="914400" rtl="0" eaLnBrk="1" latinLnBrk="0" hangingPunct="1">
-              <a:lnSpc>
-                <a:spcPct val="90000"/>
-              </a:lnSpc>
-              <a:spcBef>
-                <a:spcPts val="500"/>
-              </a:spcBef>
-              <a:buFont typeface="Arial" panose="020B0604020202020204" pitchFamily="34" charset="0"/>
-              <a:buChar char="•"/>
-              <a:defRPr sz="1800" kern="1200">
-                <a:solidFill>
-                  <a:schemeClr val="tx1"/>
-                </a:solidFill>
-                <a:latin typeface="+mn-lt"/>
-                <a:ea typeface="+mn-ea"/>
-                <a:cs typeface="+mn-cs"/>
-              </a:defRPr>
-            </a:lvl5pPr>
-            <a:lvl6pPr marL="2514600" indent="-228600" algn="l" defTabSz="914400" rtl="0" eaLnBrk="1" latinLnBrk="0" hangingPunct="1">
-              <a:lnSpc>
-                <a:spcPct val="90000"/>
-              </a:lnSpc>
-              <a:spcBef>
-                <a:spcPts val="500"/>
-              </a:spcBef>
-              <a:buFont typeface="Arial" panose="020B0604020202020204" pitchFamily="34" charset="0"/>
-              <a:buChar char="•"/>
-              <a:defRPr sz="1800" kern="1200">
-                <a:solidFill>
-                  <a:schemeClr val="tx1"/>
-                </a:solidFill>
-                <a:latin typeface="+mn-lt"/>
-                <a:ea typeface="+mn-ea"/>
-                <a:cs typeface="+mn-cs"/>
-              </a:defRPr>
-            </a:lvl6pPr>
-            <a:lvl7pPr marL="2971800" indent="-228600" algn="l" defTabSz="914400" rtl="0" eaLnBrk="1" latinLnBrk="0" hangingPunct="1">
-              <a:lnSpc>
-                <a:spcPct val="90000"/>
-              </a:lnSpc>
-              <a:spcBef>
-                <a:spcPts val="500"/>
-              </a:spcBef>
-              <a:buFont typeface="Arial" panose="020B0604020202020204" pitchFamily="34" charset="0"/>
-              <a:buChar char="•"/>
-              <a:defRPr sz="1800" kern="1200">
-                <a:solidFill>
-                  <a:schemeClr val="tx1"/>
-                </a:solidFill>
-                <a:latin typeface="+mn-lt"/>
-                <a:ea typeface="+mn-ea"/>
-                <a:cs typeface="+mn-cs"/>
-              </a:defRPr>
-            </a:lvl7pPr>
-            <a:lvl8pPr marL="3429000" indent="-228600" algn="l" defTabSz="914400" rtl="0" eaLnBrk="1" latinLnBrk="0" hangingPunct="1">
-              <a:lnSpc>
-                <a:spcPct val="90000"/>
-              </a:lnSpc>
-              <a:spcBef>
-                <a:spcPts val="500"/>
-              </a:spcBef>
-              <a:buFont typeface="Arial" panose="020B0604020202020204" pitchFamily="34" charset="0"/>
-              <a:buChar char="•"/>
-              <a:defRPr sz="1800" kern="1200">
-                <a:solidFill>
-                  <a:schemeClr val="tx1"/>
-                </a:solidFill>
-                <a:latin typeface="+mn-lt"/>
-                <a:ea typeface="+mn-ea"/>
-                <a:cs typeface="+mn-cs"/>
-              </a:defRPr>
-            </a:lvl8pPr>
-            <a:lvl9pPr marL="3886200" indent="-228600" algn="l" defTabSz="914400" rtl="0" eaLnBrk="1" latinLnBrk="0" hangingPunct="1">
-              <a:lnSpc>
-                <a:spcPct val="90000"/>
-              </a:lnSpc>
-              <a:spcBef>
-                <a:spcPts val="500"/>
-              </a:spcBef>
-              <a:buFont typeface="Arial" panose="020B0604020202020204" pitchFamily="34" charset="0"/>
-              <a:buChar char="•"/>
-              <a:defRPr sz="1800" kern="1200">
-                <a:solidFill>
-                  <a:schemeClr val="tx1"/>
-                </a:solidFill>
-                <a:latin typeface="+mn-lt"/>
-                <a:ea typeface="+mn-ea"/>
-                <a:cs typeface="+mn-cs"/>
-              </a:defRPr>
-            </a:lvl9pPr>
-          </a:lstStyle>
-          <a:p>
-            <a:r>
-              <a:rPr lang="en-IN" sz="1400" b="1" dirty="0"/>
-              <a:t>Involved Users:</a:t>
-            </a:r>
-            <a:br>
-              <a:rPr lang="en-IN" sz="1400" dirty="0"/>
-            </a:br>
-            <a:r>
-              <a:rPr lang="en-IN" sz="1400" dirty="0"/>
-              <a:t>Student, Teacher</a:t>
-            </a:r>
-          </a:p>
-          <a:p>
-            <a:r>
-              <a:rPr lang="en-IN" sz="1400" b="1" dirty="0"/>
-              <a:t>Affected System Parts:</a:t>
-            </a:r>
-            <a:br>
-              <a:rPr lang="en-IN" sz="1400" dirty="0"/>
-            </a:br>
-            <a:r>
-              <a:rPr lang="en-IN" sz="1400" b="1" i="1" u="sng" dirty="0"/>
-              <a:t>1. In Backend API:</a:t>
-            </a:r>
-          </a:p>
-          <a:p>
-            <a:pPr>
-              <a:buFont typeface="Arial" panose="020B0604020202020204" pitchFamily="34" charset="0"/>
-              <a:buChar char="•"/>
-            </a:pPr>
-            <a:r>
-              <a:rPr lang="en-IN" sz="1400" dirty="0"/>
-              <a:t>Integration Adapter</a:t>
-            </a:r>
-          </a:p>
-          <a:p>
-            <a:pPr>
-              <a:buFont typeface="Arial" panose="020B0604020202020204" pitchFamily="34" charset="0"/>
-              <a:buChar char="•"/>
-            </a:pPr>
-            <a:r>
-              <a:rPr lang="en-IN" sz="1400" dirty="0"/>
-              <a:t>Registration Management</a:t>
-            </a:r>
-          </a:p>
-          <a:p>
-            <a:pPr>
-              <a:buFont typeface="Arial" panose="020B0604020202020204" pitchFamily="34" charset="0"/>
-              <a:buChar char="•"/>
-            </a:pPr>
-            <a:r>
-              <a:rPr lang="en-IN" sz="1400" dirty="0"/>
-              <a:t>Grading Management</a:t>
-            </a:r>
-          </a:p>
-          <a:p>
-            <a:pPr>
-              <a:buFont typeface="Arial" panose="020B0604020202020204" pitchFamily="34" charset="0"/>
-              <a:buChar char="•"/>
-            </a:pPr>
-            <a:r>
-              <a:rPr lang="en-IN" sz="1400" dirty="0"/>
-              <a:t>Result Viewing</a:t>
-            </a:r>
-          </a:p>
-          <a:p>
-            <a:pPr marL="0" indent="0">
-              <a:buNone/>
-            </a:pPr>
-            <a:r>
-              <a:rPr lang="en-IN" sz="1400" dirty="0"/>
-              <a:t>       </a:t>
-            </a:r>
-            <a:r>
-              <a:rPr lang="en-IN" sz="1400" b="1" i="1" u="sng" dirty="0"/>
-              <a:t>2. In External Systems:</a:t>
-            </a:r>
-          </a:p>
-          <a:p>
-            <a:pPr>
-              <a:buFont typeface="Arial" panose="020B0604020202020204" pitchFamily="34" charset="0"/>
-              <a:buChar char="•"/>
-            </a:pPr>
-            <a:r>
-              <a:rPr lang="en-IN" sz="1400" dirty="0"/>
-              <a:t>Student Information System (SIS)</a:t>
-            </a:r>
-          </a:p>
-          <a:p>
-            <a:pPr>
-              <a:buFont typeface="Arial" panose="020B0604020202020204" pitchFamily="34" charset="0"/>
-              <a:buChar char="•"/>
-            </a:pPr>
-            <a:r>
-              <a:rPr lang="en-IN" sz="1400" dirty="0"/>
-              <a:t>Timetable Service</a:t>
-            </a:r>
-          </a:p>
-          <a:p>
-            <a:r>
-              <a:rPr lang="en-IN" sz="1400" dirty="0"/>
-              <a:t>The current architecture allows failures in external systems to propagate into EXA, reducing overall system reliability and potentially blocking critical academic processes.</a:t>
-            </a:r>
-          </a:p>
-        </p:txBody>
-      </p:sp>
+          <p:cNvGraphicFramePr>
+            <a:graphicFrameLocks noGrp="1"/>
+          </p:cNvGraphicFramePr>
+          <p:nvPr>
+            <p:extLst>
+              <p:ext uri="{D42A27DB-BD31-4B8C-83A1-F6EECF244321}">
+                <p14:modId xmlns:p14="http://schemas.microsoft.com/office/powerpoint/2010/main" val="1804115678"/>
+              </p:ext>
+            </p:extLst>
+          </p:nvPr>
+        </p:nvGraphicFramePr>
+        <p:xfrm>
+          <a:off x="1135743" y="2430463"/>
+          <a:ext cx="10388600" cy="4059236"/>
+        </p:xfrm>
+        <a:graphic>
+          <a:graphicData uri="http://schemas.openxmlformats.org/drawingml/2006/table">
+            <a:tbl>
+              <a:tblPr/>
+              <a:tblGrid>
+                <a:gridCol w="2620195">
+                  <a:extLst>
+                    <a:ext uri="{9D8B030D-6E8A-4147-A177-3AD203B41FA5}">
+                      <a16:colId xmlns:a16="http://schemas.microsoft.com/office/drawing/2014/main" val="4142023511"/>
+                    </a:ext>
+                  </a:extLst>
+                </a:gridCol>
+                <a:gridCol w="7768405">
+                  <a:extLst>
+                    <a:ext uri="{9D8B030D-6E8A-4147-A177-3AD203B41FA5}">
+                      <a16:colId xmlns:a16="http://schemas.microsoft.com/office/drawing/2014/main" val="156645862"/>
+                    </a:ext>
+                  </a:extLst>
+                </a:gridCol>
+              </a:tblGrid>
+              <a:tr h="289945">
+                <a:tc>
+                  <a:txBody>
+                    <a:bodyPr/>
+                    <a:lstStyle/>
+                    <a:p>
+                      <a:r>
+                        <a:rPr lang="en-IN" sz="1400"/>
+                        <a:t>Field</a:t>
+                      </a:r>
+                    </a:p>
+                  </a:txBody>
+                  <a:tcPr marL="72486" marR="72486" marT="36243" marB="36243" anchor="ctr">
+                    <a:lnL>
+                      <a:noFill/>
+                    </a:lnL>
+                    <a:lnR>
+                      <a:noFill/>
+                    </a:lnR>
+                    <a:lnT>
+                      <a:noFill/>
+                    </a:lnT>
+                    <a:lnB>
+                      <a:noFill/>
+                    </a:lnB>
+                    <a:noFill/>
+                  </a:tcPr>
+                </a:tc>
+                <a:tc>
+                  <a:txBody>
+                    <a:bodyPr/>
+                    <a:lstStyle/>
+                    <a:p>
+                      <a:r>
+                        <a:rPr lang="en-IN" sz="1400"/>
+                        <a:t>Description</a:t>
+                      </a:r>
+                    </a:p>
+                  </a:txBody>
+                  <a:tcPr marL="72486" marR="72486" marT="36243" marB="36243" anchor="ctr">
+                    <a:lnL>
+                      <a:noFill/>
+                    </a:lnL>
+                    <a:lnR>
+                      <a:noFill/>
+                    </a:lnR>
+                    <a:lnT>
+                      <a:noFill/>
+                    </a:lnT>
+                    <a:lnB>
+                      <a:noFill/>
+                    </a:lnB>
+                    <a:noFill/>
+                  </a:tcPr>
+                </a:tc>
+                <a:extLst>
+                  <a:ext uri="{0D108BD9-81ED-4DB2-BD59-A6C34878D82A}">
+                    <a16:rowId xmlns:a16="http://schemas.microsoft.com/office/drawing/2014/main" val="3243619380"/>
+                  </a:ext>
+                </a:extLst>
+              </a:tr>
+              <a:tr h="289945">
+                <a:tc>
+                  <a:txBody>
+                    <a:bodyPr/>
+                    <a:lstStyle/>
+                    <a:p>
+                      <a:r>
+                        <a:rPr lang="en-IN" sz="1400" b="1"/>
+                        <a:t>Quality Attribute</a:t>
+                      </a:r>
+                      <a:endParaRPr lang="en-IN" sz="1400"/>
+                    </a:p>
+                  </a:txBody>
+                  <a:tcPr marL="72486" marR="72486" marT="36243" marB="36243" anchor="ctr">
+                    <a:lnL>
+                      <a:noFill/>
+                    </a:lnL>
+                    <a:lnR>
+                      <a:noFill/>
+                    </a:lnR>
+                    <a:lnT>
+                      <a:noFill/>
+                    </a:lnT>
+                    <a:lnB>
+                      <a:noFill/>
+                    </a:lnB>
+                    <a:noFill/>
+                  </a:tcPr>
+                </a:tc>
+                <a:tc>
+                  <a:txBody>
+                    <a:bodyPr/>
+                    <a:lstStyle/>
+                    <a:p>
+                      <a:r>
+                        <a:rPr lang="en-IN" sz="1400"/>
+                        <a:t>Reliability</a:t>
+                      </a:r>
+                    </a:p>
+                  </a:txBody>
+                  <a:tcPr marL="72486" marR="72486" marT="36243" marB="36243" anchor="ctr">
+                    <a:lnL>
+                      <a:noFill/>
+                    </a:lnL>
+                    <a:lnR>
+                      <a:noFill/>
+                    </a:lnR>
+                    <a:lnT>
+                      <a:noFill/>
+                    </a:lnT>
+                    <a:lnB>
+                      <a:noFill/>
+                    </a:lnB>
+                    <a:noFill/>
+                  </a:tcPr>
+                </a:tc>
+                <a:extLst>
+                  <a:ext uri="{0D108BD9-81ED-4DB2-BD59-A6C34878D82A}">
+                    <a16:rowId xmlns:a16="http://schemas.microsoft.com/office/drawing/2014/main" val="2088599293"/>
+                  </a:ext>
+                </a:extLst>
+              </a:tr>
+              <a:tr h="507405">
+                <a:tc>
+                  <a:txBody>
+                    <a:bodyPr/>
+                    <a:lstStyle/>
+                    <a:p>
+                      <a:r>
+                        <a:rPr lang="en-IN" sz="1400" b="1"/>
+                        <a:t>Source of Stimulus</a:t>
+                      </a:r>
+                      <a:endParaRPr lang="en-IN" sz="1400"/>
+                    </a:p>
+                  </a:txBody>
+                  <a:tcPr marL="72486" marR="72486" marT="36243" marB="36243" anchor="ctr">
+                    <a:lnL>
+                      <a:noFill/>
+                    </a:lnL>
+                    <a:lnR>
+                      <a:noFill/>
+                    </a:lnR>
+                    <a:lnT>
+                      <a:noFill/>
+                    </a:lnT>
+                    <a:lnB>
+                      <a:noFill/>
+                    </a:lnB>
+                    <a:noFill/>
+                  </a:tcPr>
+                </a:tc>
+                <a:tc>
+                  <a:txBody>
+                    <a:bodyPr/>
+                    <a:lstStyle/>
+                    <a:p>
+                      <a:r>
+                        <a:rPr lang="en-IN" sz="1400"/>
+                        <a:t>External system (Student Information System or Timetable Service)</a:t>
+                      </a:r>
+                    </a:p>
+                  </a:txBody>
+                  <a:tcPr marL="72486" marR="72486" marT="36243" marB="36243" anchor="ctr">
+                    <a:lnL>
+                      <a:noFill/>
+                    </a:lnL>
+                    <a:lnR>
+                      <a:noFill/>
+                    </a:lnR>
+                    <a:lnT>
+                      <a:noFill/>
+                    </a:lnT>
+                    <a:lnB>
+                      <a:noFill/>
+                    </a:lnB>
+                    <a:noFill/>
+                  </a:tcPr>
+                </a:tc>
+                <a:extLst>
+                  <a:ext uri="{0D108BD9-81ED-4DB2-BD59-A6C34878D82A}">
+                    <a16:rowId xmlns:a16="http://schemas.microsoft.com/office/drawing/2014/main" val="3800424000"/>
+                  </a:ext>
+                </a:extLst>
+              </a:tr>
+              <a:tr h="507405">
+                <a:tc>
+                  <a:txBody>
+                    <a:bodyPr/>
+                    <a:lstStyle/>
+                    <a:p>
+                      <a:r>
+                        <a:rPr lang="en-IN" sz="1400" b="1"/>
+                        <a:t>Stimulus</a:t>
+                      </a:r>
+                      <a:endParaRPr lang="en-IN" sz="1400"/>
+                    </a:p>
+                  </a:txBody>
+                  <a:tcPr marL="72486" marR="72486" marT="36243" marB="36243" anchor="ctr">
+                    <a:lnL>
+                      <a:noFill/>
+                    </a:lnL>
+                    <a:lnR>
+                      <a:noFill/>
+                    </a:lnR>
+                    <a:lnT>
+                      <a:noFill/>
+                    </a:lnT>
+                    <a:lnB>
+                      <a:noFill/>
+                    </a:lnB>
+                    <a:noFill/>
+                  </a:tcPr>
+                </a:tc>
+                <a:tc>
+                  <a:txBody>
+                    <a:bodyPr/>
+                    <a:lstStyle/>
+                    <a:p>
+                      <a:r>
+                        <a:rPr lang="en-IN" sz="1400"/>
+                        <a:t>An external system becomes unavailable or responds slowly</a:t>
+                      </a:r>
+                    </a:p>
+                  </a:txBody>
+                  <a:tcPr marL="72486" marR="72486" marT="36243" marB="36243" anchor="ctr">
+                    <a:lnL>
+                      <a:noFill/>
+                    </a:lnL>
+                    <a:lnR>
+                      <a:noFill/>
+                    </a:lnR>
+                    <a:lnT>
+                      <a:noFill/>
+                    </a:lnT>
+                    <a:lnB>
+                      <a:noFill/>
+                    </a:lnB>
+                    <a:noFill/>
+                  </a:tcPr>
+                </a:tc>
+                <a:extLst>
+                  <a:ext uri="{0D108BD9-81ED-4DB2-BD59-A6C34878D82A}">
+                    <a16:rowId xmlns:a16="http://schemas.microsoft.com/office/drawing/2014/main" val="1939123124"/>
+                  </a:ext>
+                </a:extLst>
+              </a:tr>
+              <a:tr h="289945">
+                <a:tc>
+                  <a:txBody>
+                    <a:bodyPr/>
+                    <a:lstStyle/>
+                    <a:p>
+                      <a:r>
+                        <a:rPr lang="en-IN" sz="1400" b="1"/>
+                        <a:t>Environment</a:t>
+                      </a:r>
+                      <a:endParaRPr lang="en-IN" sz="1400"/>
+                    </a:p>
+                  </a:txBody>
+                  <a:tcPr marL="72486" marR="72486" marT="36243" marB="36243" anchor="ctr">
+                    <a:lnL>
+                      <a:noFill/>
+                    </a:lnL>
+                    <a:lnR>
+                      <a:noFill/>
+                    </a:lnR>
+                    <a:lnT>
+                      <a:noFill/>
+                    </a:lnT>
+                    <a:lnB>
+                      <a:noFill/>
+                    </a:lnB>
+                    <a:noFill/>
+                  </a:tcPr>
+                </a:tc>
+                <a:tc>
+                  <a:txBody>
+                    <a:bodyPr/>
+                    <a:lstStyle/>
+                    <a:p>
+                      <a:r>
+                        <a:rPr lang="en-IN" sz="1400"/>
+                        <a:t>Normal operation, possibly during peak usage</a:t>
+                      </a:r>
+                    </a:p>
+                  </a:txBody>
+                  <a:tcPr marL="72486" marR="72486" marT="36243" marB="36243" anchor="ctr">
+                    <a:lnL>
+                      <a:noFill/>
+                    </a:lnL>
+                    <a:lnR>
+                      <a:noFill/>
+                    </a:lnR>
+                    <a:lnT>
+                      <a:noFill/>
+                    </a:lnT>
+                    <a:lnB>
+                      <a:noFill/>
+                    </a:lnB>
+                    <a:noFill/>
+                  </a:tcPr>
+                </a:tc>
+                <a:extLst>
+                  <a:ext uri="{0D108BD9-81ED-4DB2-BD59-A6C34878D82A}">
+                    <a16:rowId xmlns:a16="http://schemas.microsoft.com/office/drawing/2014/main" val="560919176"/>
+                  </a:ext>
+                </a:extLst>
+              </a:tr>
+              <a:tr h="289945">
+                <a:tc>
+                  <a:txBody>
+                    <a:bodyPr/>
+                    <a:lstStyle/>
+                    <a:p>
+                      <a:r>
+                        <a:rPr lang="en-IN" sz="1400" b="1"/>
+                        <a:t>Artifact</a:t>
+                      </a:r>
+                      <a:endParaRPr lang="en-IN" sz="1400"/>
+                    </a:p>
+                  </a:txBody>
+                  <a:tcPr marL="72486" marR="72486" marT="36243" marB="36243" anchor="ctr">
+                    <a:lnL>
+                      <a:noFill/>
+                    </a:lnL>
+                    <a:lnR>
+                      <a:noFill/>
+                    </a:lnR>
+                    <a:lnT>
+                      <a:noFill/>
+                    </a:lnT>
+                    <a:lnB>
+                      <a:noFill/>
+                    </a:lnB>
+                    <a:noFill/>
+                  </a:tcPr>
+                </a:tc>
+                <a:tc>
+                  <a:txBody>
+                    <a:bodyPr/>
+                    <a:lstStyle/>
+                    <a:p>
+                      <a:r>
+                        <a:rPr lang="en-IN" sz="1400"/>
+                        <a:t>Integration Adapter (Backend API)</a:t>
+                      </a:r>
+                    </a:p>
+                  </a:txBody>
+                  <a:tcPr marL="72486" marR="72486" marT="36243" marB="36243" anchor="ctr">
+                    <a:lnL>
+                      <a:noFill/>
+                    </a:lnL>
+                    <a:lnR>
+                      <a:noFill/>
+                    </a:lnR>
+                    <a:lnT>
+                      <a:noFill/>
+                    </a:lnT>
+                    <a:lnB>
+                      <a:noFill/>
+                    </a:lnB>
+                    <a:noFill/>
+                  </a:tcPr>
+                </a:tc>
+                <a:extLst>
+                  <a:ext uri="{0D108BD9-81ED-4DB2-BD59-A6C34878D82A}">
+                    <a16:rowId xmlns:a16="http://schemas.microsoft.com/office/drawing/2014/main" val="4189590913"/>
+                  </a:ext>
+                </a:extLst>
+              </a:tr>
+              <a:tr h="1159782">
+                <a:tc>
+                  <a:txBody>
+                    <a:bodyPr/>
+                    <a:lstStyle/>
+                    <a:p>
+                      <a:r>
+                        <a:rPr lang="en-IN" sz="1400" b="1"/>
+                        <a:t>Response</a:t>
+                      </a:r>
+                      <a:endParaRPr lang="en-IN" sz="1400"/>
+                    </a:p>
+                  </a:txBody>
+                  <a:tcPr marL="72486" marR="72486" marT="36243" marB="36243" anchor="ctr">
+                    <a:lnL>
+                      <a:noFill/>
+                    </a:lnL>
+                    <a:lnR>
+                      <a:noFill/>
+                    </a:lnR>
+                    <a:lnT>
+                      <a:noFill/>
+                    </a:lnT>
+                    <a:lnB>
+                      <a:noFill/>
+                    </a:lnB>
+                    <a:noFill/>
+                  </a:tcPr>
+                </a:tc>
+                <a:tc>
+                  <a:txBody>
+                    <a:bodyPr/>
+                    <a:lstStyle/>
+                    <a:p>
+                      <a:r>
+                        <a:rPr lang="en-IN" sz="1400"/>
+                        <a:t>The Integration Adapter detects the failure using timeouts, retries, or circuit breakers and prevents the failure from propagating to core business components. The system continues operating in a degraded but controlled mode</a:t>
+                      </a:r>
+                    </a:p>
+                  </a:txBody>
+                  <a:tcPr marL="72486" marR="72486" marT="36243" marB="36243" anchor="ctr">
+                    <a:lnL>
+                      <a:noFill/>
+                    </a:lnL>
+                    <a:lnR>
+                      <a:noFill/>
+                    </a:lnR>
+                    <a:lnT>
+                      <a:noFill/>
+                    </a:lnT>
+                    <a:lnB>
+                      <a:noFill/>
+                    </a:lnB>
+                    <a:noFill/>
+                  </a:tcPr>
+                </a:tc>
+                <a:extLst>
+                  <a:ext uri="{0D108BD9-81ED-4DB2-BD59-A6C34878D82A}">
+                    <a16:rowId xmlns:a16="http://schemas.microsoft.com/office/drawing/2014/main" val="1445647130"/>
+                  </a:ext>
+                </a:extLst>
+              </a:tr>
+              <a:tr h="724864">
+                <a:tc>
+                  <a:txBody>
+                    <a:bodyPr/>
+                    <a:lstStyle/>
+                    <a:p>
+                      <a:r>
+                        <a:rPr lang="en-IN" sz="1400" b="1"/>
+                        <a:t>Response Measure</a:t>
+                      </a:r>
+                      <a:endParaRPr lang="en-IN" sz="1400"/>
+                    </a:p>
+                  </a:txBody>
+                  <a:tcPr marL="72486" marR="72486" marT="36243" marB="36243" anchor="ctr">
+                    <a:lnL>
+                      <a:noFill/>
+                    </a:lnL>
+                    <a:lnR>
+                      <a:noFill/>
+                    </a:lnR>
+                    <a:lnT>
+                      <a:noFill/>
+                    </a:lnT>
+                    <a:lnB>
+                      <a:noFill/>
+                    </a:lnB>
+                    <a:noFill/>
+                  </a:tcPr>
+                </a:tc>
+                <a:tc>
+                  <a:txBody>
+                    <a:bodyPr/>
+                    <a:lstStyle/>
+                    <a:p>
+                      <a:r>
+                        <a:rPr lang="en-IN" sz="1400" dirty="0"/>
+                        <a:t>Core EXA functionality remains available and failures do not cascade beyond the Integration Adapter</a:t>
+                      </a:r>
+                    </a:p>
+                  </a:txBody>
+                  <a:tcPr marL="72486" marR="72486" marT="36243" marB="36243" anchor="ctr">
+                    <a:lnL>
+                      <a:noFill/>
+                    </a:lnL>
+                    <a:lnR>
+                      <a:noFill/>
+                    </a:lnR>
+                    <a:lnT>
+                      <a:noFill/>
+                    </a:lnT>
+                    <a:lnB>
+                      <a:noFill/>
+                    </a:lnB>
+                    <a:noFill/>
+                  </a:tcPr>
+                </a:tc>
+                <a:extLst>
+                  <a:ext uri="{0D108BD9-81ED-4DB2-BD59-A6C34878D82A}">
+                    <a16:rowId xmlns:a16="http://schemas.microsoft.com/office/drawing/2014/main" val="1643286551"/>
+                  </a:ext>
+                </a:extLst>
+              </a:tr>
+            </a:tbl>
+          </a:graphicData>
+        </a:graphic>
+      </p:graphicFrame>
     </p:spTree>
     <p:extLst>
       <p:ext uri="{BB962C8B-B14F-4D97-AF65-F5344CB8AC3E}">
-        <p14:creationId xmlns:p14="http://schemas.microsoft.com/office/powerpoint/2010/main" val="1850926752"/>
+        <p14:creationId xmlns:p14="http://schemas.microsoft.com/office/powerpoint/2010/main" val="534078243"/>
       </p:ext>
     </p:extLst>
   </p:cSld>
@@ -9263,13 +9546,20 @@
             <p:ph type="title"/>
           </p:nvPr>
         </p:nvSpPr>
-        <p:spPr/>
-        <p:txBody>
-          <a:bodyPr/>
+        <p:spPr>
+          <a:xfrm>
+            <a:off x="-1791305" y="450104"/>
+            <a:ext cx="10353762" cy="970450"/>
+          </a:xfrm>
+        </p:spPr>
+        <p:txBody>
+          <a:bodyPr>
+            <a:normAutofit/>
+          </a:bodyPr>
           <a:lstStyle/>
           <a:p>
             <a:r>
-              <a:rPr lang="en-US" dirty="0"/>
+              <a:rPr lang="en-US" sz="3200" dirty="0"/>
               <a:t>SCALABILITY PROBLEM</a:t>
             </a:r>
           </a:p>
@@ -9293,8 +9583,8 @@
         </p:nvSpPr>
         <p:spPr>
           <a:xfrm>
-            <a:off x="838200" y="1576301"/>
-            <a:ext cx="5822092" cy="4916574"/>
+            <a:off x="838200" y="1380680"/>
+            <a:ext cx="7226300" cy="1192299"/>
           </a:xfrm>
         </p:spPr>
         <p:txBody>
@@ -9324,91 +9614,6 @@
             <a:r>
               <a:rPr lang="en-IN" sz="1400" dirty="0"/>
               <a:t>This leads to sudden spikes in load on the Backend API, particularly on registration-related components and database access.</a:t>
-            </a:r>
-          </a:p>
-          <a:p>
-            <a:r>
-              <a:rPr lang="en-IN" sz="1400" b="1" dirty="0"/>
-              <a:t>Involved Users:</a:t>
-            </a:r>
-            <a:br>
-              <a:rPr lang="en-IN" sz="1400" dirty="0"/>
-            </a:br>
-            <a:r>
-              <a:rPr lang="en-IN" sz="1400" dirty="0"/>
-              <a:t>Student</a:t>
-            </a:r>
-          </a:p>
-          <a:p>
-            <a:r>
-              <a:rPr lang="en-IN" sz="1400" b="1" dirty="0"/>
-              <a:t>Affected System Parts:</a:t>
-            </a:r>
-            <a:br>
-              <a:rPr lang="en-IN" sz="1400" dirty="0"/>
-            </a:br>
-            <a:r>
-              <a:rPr lang="en-IN" sz="1400" b="1" i="1" u="sng" dirty="0"/>
-              <a:t>1. In Backend API:</a:t>
-            </a:r>
-          </a:p>
-          <a:p>
-            <a:pPr>
-              <a:buFont typeface="Arial" panose="020B0604020202020204" pitchFamily="34" charset="0"/>
-              <a:buChar char="•"/>
-            </a:pPr>
-            <a:r>
-              <a:rPr lang="en-IN" sz="1400" dirty="0"/>
-              <a:t>Registration Management</a:t>
-            </a:r>
-          </a:p>
-          <a:p>
-            <a:pPr>
-              <a:buFont typeface="Arial" panose="020B0604020202020204" pitchFamily="34" charset="0"/>
-              <a:buChar char="•"/>
-            </a:pPr>
-            <a:r>
-              <a:rPr lang="en-IN" sz="1400" dirty="0"/>
-              <a:t>Persistence Adapter</a:t>
-            </a:r>
-          </a:p>
-          <a:p>
-            <a:pPr>
-              <a:buFont typeface="Arial" panose="020B0604020202020204" pitchFamily="34" charset="0"/>
-              <a:buChar char="•"/>
-            </a:pPr>
-            <a:r>
-              <a:rPr lang="en-IN" sz="1400" dirty="0"/>
-              <a:t>Database</a:t>
-            </a:r>
-          </a:p>
-          <a:p>
-            <a:pPr marL="0" indent="0">
-              <a:buNone/>
-            </a:pPr>
-            <a:r>
-              <a:rPr lang="en-IN" sz="1400" dirty="0"/>
-              <a:t>        </a:t>
-            </a:r>
-            <a:r>
-              <a:rPr lang="en-IN" sz="1400" b="1" i="1" u="sng" dirty="0"/>
-              <a:t>2 .In Infrastructure:</a:t>
-            </a:r>
-          </a:p>
-          <a:p>
-            <a:pPr>
-              <a:buFont typeface="Arial" panose="020B0604020202020204" pitchFamily="34" charset="0"/>
-              <a:buChar char="•"/>
-            </a:pPr>
-            <a:r>
-              <a:rPr lang="en-IN" sz="1400" dirty="0"/>
-              <a:t>Backend API container</a:t>
-            </a:r>
-          </a:p>
-          <a:p>
-            <a:r>
-              <a:rPr lang="en-IN" sz="1400" dirty="0"/>
-              <a:t>The current architecture risks performance degradation or request failures under high concurrent load if backend components cannot scale quickly enough.</a:t>
             </a:r>
           </a:p>
         </p:txBody>
@@ -9435,8 +9640,8 @@
         </p:blipFill>
         <p:spPr>
           <a:xfrm>
-            <a:off x="7037613" y="365125"/>
-            <a:ext cx="4871357" cy="2863811"/>
+            <a:off x="8153400" y="365126"/>
+            <a:ext cx="3755570" cy="2207853"/>
           </a:xfrm>
           <a:prstGeom prst="rect">
             <a:avLst/>
@@ -9465,14 +9670,557 @@
         </p:blipFill>
         <p:spPr>
           <a:xfrm>
-            <a:off x="7037612" y="3429000"/>
-            <a:ext cx="4871358" cy="2493671"/>
+            <a:off x="8153400" y="2728726"/>
+            <a:ext cx="3755570" cy="1922494"/>
           </a:xfrm>
           <a:prstGeom prst="rect">
             <a:avLst/>
           </a:prstGeom>
         </p:spPr>
       </p:pic>
+      <p:graphicFrame>
+        <p:nvGraphicFramePr>
+          <p:cNvPr id="6" name="Table 5">
+            <a:extLst>
+              <a:ext uri="{FF2B5EF4-FFF2-40B4-BE49-F238E27FC236}">
+                <a16:creationId xmlns:a16="http://schemas.microsoft.com/office/drawing/2014/main" id="{9AC26A06-43AB-6CAC-411E-02ACD94B8D69}"/>
+              </a:ext>
+            </a:extLst>
+          </p:cNvPr>
+          <p:cNvGraphicFramePr>
+            <a:graphicFrameLocks noGrp="1"/>
+          </p:cNvGraphicFramePr>
+          <p:nvPr>
+            <p:extLst>
+              <p:ext uri="{D42A27DB-BD31-4B8C-83A1-F6EECF244321}">
+                <p14:modId xmlns:p14="http://schemas.microsoft.com/office/powerpoint/2010/main" val="887941306"/>
+              </p:ext>
+            </p:extLst>
+          </p:nvPr>
+        </p:nvGraphicFramePr>
+        <p:xfrm>
+          <a:off x="838200" y="2728726"/>
+          <a:ext cx="8207572" cy="4059236"/>
+        </p:xfrm>
+        <a:graphic>
+          <a:graphicData uri="http://schemas.openxmlformats.org/drawingml/2006/table">
+            <a:tbl>
+              <a:tblPr/>
+              <a:tblGrid>
+                <a:gridCol w="1957486">
+                  <a:extLst>
+                    <a:ext uri="{9D8B030D-6E8A-4147-A177-3AD203B41FA5}">
+                      <a16:colId xmlns:a16="http://schemas.microsoft.com/office/drawing/2014/main" val="3441313519"/>
+                    </a:ext>
+                  </a:extLst>
+                </a:gridCol>
+                <a:gridCol w="6250086">
+                  <a:extLst>
+                    <a:ext uri="{9D8B030D-6E8A-4147-A177-3AD203B41FA5}">
+                      <a16:colId xmlns:a16="http://schemas.microsoft.com/office/drawing/2014/main" val="3408472008"/>
+                    </a:ext>
+                  </a:extLst>
+                </a:gridCol>
+              </a:tblGrid>
+              <a:tr h="289945">
+                <a:tc>
+                  <a:txBody>
+                    <a:bodyPr/>
+                    <a:lstStyle/>
+                    <a:p>
+                      <a:r>
+                        <a:rPr lang="en-IN" sz="1400"/>
+                        <a:t>Field</a:t>
+                      </a:r>
+                    </a:p>
+                  </a:txBody>
+                  <a:tcPr marL="72486" marR="72486" marT="36243" marB="36243" anchor="ctr">
+                    <a:lnL>
+                      <a:noFill/>
+                    </a:lnL>
+                    <a:lnR>
+                      <a:noFill/>
+                    </a:lnR>
+                    <a:lnT>
+                      <a:noFill/>
+                    </a:lnT>
+                    <a:lnB>
+                      <a:noFill/>
+                    </a:lnB>
+                    <a:noFill/>
+                  </a:tcPr>
+                </a:tc>
+                <a:tc>
+                  <a:txBody>
+                    <a:bodyPr/>
+                    <a:lstStyle/>
+                    <a:p>
+                      <a:r>
+                        <a:rPr lang="en-IN" sz="1400" dirty="0"/>
+                        <a:t>Description</a:t>
+                      </a:r>
+                    </a:p>
+                  </a:txBody>
+                  <a:tcPr marL="72486" marR="72486" marT="36243" marB="36243" anchor="ctr">
+                    <a:lnL>
+                      <a:noFill/>
+                    </a:lnL>
+                    <a:lnR>
+                      <a:noFill/>
+                    </a:lnR>
+                    <a:lnT>
+                      <a:noFill/>
+                    </a:lnT>
+                    <a:lnB>
+                      <a:noFill/>
+                    </a:lnB>
+                    <a:noFill/>
+                  </a:tcPr>
+                </a:tc>
+                <a:extLst>
+                  <a:ext uri="{0D108BD9-81ED-4DB2-BD59-A6C34878D82A}">
+                    <a16:rowId xmlns:a16="http://schemas.microsoft.com/office/drawing/2014/main" val="1541138862"/>
+                  </a:ext>
+                </a:extLst>
+              </a:tr>
+              <a:tr h="289945">
+                <a:tc>
+                  <a:txBody>
+                    <a:bodyPr/>
+                    <a:lstStyle/>
+                    <a:p>
+                      <a:r>
+                        <a:rPr lang="en-IN" sz="1400" b="1"/>
+                        <a:t>Quality Attribute</a:t>
+                      </a:r>
+                      <a:endParaRPr lang="en-IN" sz="1400"/>
+                    </a:p>
+                  </a:txBody>
+                  <a:tcPr marL="72486" marR="72486" marT="36243" marB="36243" anchor="ctr">
+                    <a:lnL>
+                      <a:noFill/>
+                    </a:lnL>
+                    <a:lnR>
+                      <a:noFill/>
+                    </a:lnR>
+                    <a:lnT>
+                      <a:noFill/>
+                    </a:lnT>
+                    <a:lnB>
+                      <a:noFill/>
+                    </a:lnB>
+                    <a:noFill/>
+                  </a:tcPr>
+                </a:tc>
+                <a:tc>
+                  <a:txBody>
+                    <a:bodyPr/>
+                    <a:lstStyle/>
+                    <a:p>
+                      <a:r>
+                        <a:rPr lang="en-IN" sz="1400"/>
+                        <a:t>Scalability</a:t>
+                      </a:r>
+                    </a:p>
+                  </a:txBody>
+                  <a:tcPr marL="72486" marR="72486" marT="36243" marB="36243" anchor="ctr">
+                    <a:lnL>
+                      <a:noFill/>
+                    </a:lnL>
+                    <a:lnR>
+                      <a:noFill/>
+                    </a:lnR>
+                    <a:lnT>
+                      <a:noFill/>
+                    </a:lnT>
+                    <a:lnB>
+                      <a:noFill/>
+                    </a:lnB>
+                    <a:noFill/>
+                  </a:tcPr>
+                </a:tc>
+                <a:extLst>
+                  <a:ext uri="{0D108BD9-81ED-4DB2-BD59-A6C34878D82A}">
+                    <a16:rowId xmlns:a16="http://schemas.microsoft.com/office/drawing/2014/main" val="3424056702"/>
+                  </a:ext>
+                </a:extLst>
+              </a:tr>
+              <a:tr h="289945">
+                <a:tc>
+                  <a:txBody>
+                    <a:bodyPr/>
+                    <a:lstStyle/>
+                    <a:p>
+                      <a:r>
+                        <a:rPr lang="en-IN" sz="1400" b="1"/>
+                        <a:t>Source of Stimulus</a:t>
+                      </a:r>
+                      <a:endParaRPr lang="en-IN" sz="1400"/>
+                    </a:p>
+                  </a:txBody>
+                  <a:tcPr marL="72486" marR="72486" marT="36243" marB="36243" anchor="ctr">
+                    <a:lnL>
+                      <a:noFill/>
+                    </a:lnL>
+                    <a:lnR>
+                      <a:noFill/>
+                    </a:lnR>
+                    <a:lnT>
+                      <a:noFill/>
+                    </a:lnT>
+                    <a:lnB>
+                      <a:noFill/>
+                    </a:lnB>
+                    <a:noFill/>
+                  </a:tcPr>
+                </a:tc>
+                <a:tc>
+                  <a:txBody>
+                    <a:bodyPr/>
+                    <a:lstStyle/>
+                    <a:p>
+                      <a:r>
+                        <a:rPr lang="en-IN" sz="1400"/>
+                        <a:t>Students</a:t>
+                      </a:r>
+                    </a:p>
+                  </a:txBody>
+                  <a:tcPr marL="72486" marR="72486" marT="36243" marB="36243" anchor="ctr">
+                    <a:lnL>
+                      <a:noFill/>
+                    </a:lnL>
+                    <a:lnR>
+                      <a:noFill/>
+                    </a:lnR>
+                    <a:lnT>
+                      <a:noFill/>
+                    </a:lnT>
+                    <a:lnB>
+                      <a:noFill/>
+                    </a:lnB>
+                    <a:noFill/>
+                  </a:tcPr>
+                </a:tc>
+                <a:extLst>
+                  <a:ext uri="{0D108BD9-81ED-4DB2-BD59-A6C34878D82A}">
+                    <a16:rowId xmlns:a16="http://schemas.microsoft.com/office/drawing/2014/main" val="2175101912"/>
+                  </a:ext>
+                </a:extLst>
+              </a:tr>
+              <a:tr h="507405">
+                <a:tc>
+                  <a:txBody>
+                    <a:bodyPr/>
+                    <a:lstStyle/>
+                    <a:p>
+                      <a:r>
+                        <a:rPr lang="en-IN" sz="1400" b="1"/>
+                        <a:t>Stimulus</a:t>
+                      </a:r>
+                      <a:endParaRPr lang="en-IN" sz="1400"/>
+                    </a:p>
+                  </a:txBody>
+                  <a:tcPr marL="72486" marR="72486" marT="36243" marB="36243" anchor="ctr">
+                    <a:lnL>
+                      <a:noFill/>
+                    </a:lnL>
+                    <a:lnR>
+                      <a:noFill/>
+                    </a:lnR>
+                    <a:lnT>
+                      <a:noFill/>
+                    </a:lnT>
+                    <a:lnB>
+                      <a:noFill/>
+                    </a:lnB>
+                    <a:noFill/>
+                  </a:tcPr>
+                </a:tc>
+                <a:tc>
+                  <a:txBody>
+                    <a:bodyPr/>
+                    <a:lstStyle/>
+                    <a:p>
+                      <a:r>
+                        <a:rPr lang="en-IN" sz="1400"/>
+                        <a:t>A large number of concurrent requests arrive at the system</a:t>
+                      </a:r>
+                    </a:p>
+                  </a:txBody>
+                  <a:tcPr marL="72486" marR="72486" marT="36243" marB="36243" anchor="ctr">
+                    <a:lnL>
+                      <a:noFill/>
+                    </a:lnL>
+                    <a:lnR>
+                      <a:noFill/>
+                    </a:lnR>
+                    <a:lnT>
+                      <a:noFill/>
+                    </a:lnT>
+                    <a:lnB>
+                      <a:noFill/>
+                    </a:lnB>
+                    <a:noFill/>
+                  </a:tcPr>
+                </a:tc>
+                <a:extLst>
+                  <a:ext uri="{0D108BD9-81ED-4DB2-BD59-A6C34878D82A}">
+                    <a16:rowId xmlns:a16="http://schemas.microsoft.com/office/drawing/2014/main" val="1508562039"/>
+                  </a:ext>
+                </a:extLst>
+              </a:tr>
+              <a:tr h="289945">
+                <a:tc>
+                  <a:txBody>
+                    <a:bodyPr/>
+                    <a:lstStyle/>
+                    <a:p>
+                      <a:r>
+                        <a:rPr lang="en-IN" sz="1400" b="1"/>
+                        <a:t>Environment</a:t>
+                      </a:r>
+                      <a:endParaRPr lang="en-IN" sz="1400"/>
+                    </a:p>
+                  </a:txBody>
+                  <a:tcPr marL="72486" marR="72486" marT="36243" marB="36243" anchor="ctr">
+                    <a:lnL>
+                      <a:noFill/>
+                    </a:lnL>
+                    <a:lnR>
+                      <a:noFill/>
+                    </a:lnR>
+                    <a:lnT>
+                      <a:noFill/>
+                    </a:lnT>
+                    <a:lnB>
+                      <a:noFill/>
+                    </a:lnB>
+                    <a:noFill/>
+                  </a:tcPr>
+                </a:tc>
+                <a:tc>
+                  <a:txBody>
+                    <a:bodyPr/>
+                    <a:lstStyle/>
+                    <a:p>
+                      <a:r>
+                        <a:rPr lang="en-IN" sz="1400"/>
+                        <a:t>Peak usage periods (e.g. exam registration opening)</a:t>
+                      </a:r>
+                    </a:p>
+                  </a:txBody>
+                  <a:tcPr marL="72486" marR="72486" marT="36243" marB="36243" anchor="ctr">
+                    <a:lnL>
+                      <a:noFill/>
+                    </a:lnL>
+                    <a:lnR>
+                      <a:noFill/>
+                    </a:lnR>
+                    <a:lnT>
+                      <a:noFill/>
+                    </a:lnT>
+                    <a:lnB>
+                      <a:noFill/>
+                    </a:lnB>
+                    <a:noFill/>
+                  </a:tcPr>
+                </a:tc>
+                <a:extLst>
+                  <a:ext uri="{0D108BD9-81ED-4DB2-BD59-A6C34878D82A}">
+                    <a16:rowId xmlns:a16="http://schemas.microsoft.com/office/drawing/2014/main" val="1453488838"/>
+                  </a:ext>
+                </a:extLst>
+              </a:tr>
+              <a:tr h="507405">
+                <a:tc>
+                  <a:txBody>
+                    <a:bodyPr/>
+                    <a:lstStyle/>
+                    <a:p>
+                      <a:r>
+                        <a:rPr lang="en-IN" sz="1400" b="1"/>
+                        <a:t>Artifact</a:t>
+                      </a:r>
+                      <a:endParaRPr lang="en-IN" sz="1400"/>
+                    </a:p>
+                  </a:txBody>
+                  <a:tcPr marL="72486" marR="72486" marT="36243" marB="36243" anchor="ctr">
+                    <a:lnL>
+                      <a:noFill/>
+                    </a:lnL>
+                    <a:lnR>
+                      <a:noFill/>
+                    </a:lnR>
+                    <a:lnT>
+                      <a:noFill/>
+                    </a:lnT>
+                    <a:lnB>
+                      <a:noFill/>
+                    </a:lnB>
+                    <a:noFill/>
+                  </a:tcPr>
+                </a:tc>
+                <a:tc>
+                  <a:txBody>
+                    <a:bodyPr/>
+                    <a:lstStyle/>
+                    <a:p>
+                      <a:r>
+                        <a:rPr lang="en-IN" sz="1400"/>
+                        <a:t>Backend API container, especially Registration Management</a:t>
+                      </a:r>
+                    </a:p>
+                  </a:txBody>
+                  <a:tcPr marL="72486" marR="72486" marT="36243" marB="36243" anchor="ctr">
+                    <a:lnL>
+                      <a:noFill/>
+                    </a:lnL>
+                    <a:lnR>
+                      <a:noFill/>
+                    </a:lnR>
+                    <a:lnT>
+                      <a:noFill/>
+                    </a:lnT>
+                    <a:lnB>
+                      <a:noFill/>
+                    </a:lnB>
+                    <a:noFill/>
+                  </a:tcPr>
+                </a:tc>
+                <a:extLst>
+                  <a:ext uri="{0D108BD9-81ED-4DB2-BD59-A6C34878D82A}">
+                    <a16:rowId xmlns:a16="http://schemas.microsoft.com/office/drawing/2014/main" val="1347179215"/>
+                  </a:ext>
+                </a:extLst>
+              </a:tr>
+              <a:tr h="1159782">
+                <a:tc>
+                  <a:txBody>
+                    <a:bodyPr/>
+                    <a:lstStyle/>
+                    <a:p>
+                      <a:r>
+                        <a:rPr lang="en-IN" sz="1400" b="1"/>
+                        <a:t>Response</a:t>
+                      </a:r>
+                      <a:endParaRPr lang="en-IN" sz="1400"/>
+                    </a:p>
+                  </a:txBody>
+                  <a:tcPr marL="72486" marR="72486" marT="36243" marB="36243" anchor="ctr">
+                    <a:lnL>
+                      <a:noFill/>
+                    </a:lnL>
+                    <a:lnR>
+                      <a:noFill/>
+                    </a:lnR>
+                    <a:lnT>
+                      <a:noFill/>
+                    </a:lnT>
+                    <a:lnB>
+                      <a:noFill/>
+                    </a:lnB>
+                    <a:noFill/>
+                  </a:tcPr>
+                </a:tc>
+                <a:tc>
+                  <a:txBody>
+                    <a:bodyPr/>
+                    <a:lstStyle/>
+                    <a:p>
+                      <a:r>
+                        <a:rPr lang="en-IN" sz="1400" dirty="0"/>
+                        <a:t>The Backend API scales horizontally by running multiple stateless instances behind a load balancer. Requests are distributed across instances and database access is optimized using connection pooling</a:t>
+                      </a:r>
+                    </a:p>
+                  </a:txBody>
+                  <a:tcPr marL="72486" marR="72486" marT="36243" marB="36243" anchor="ctr">
+                    <a:lnL>
+                      <a:noFill/>
+                    </a:lnL>
+                    <a:lnR>
+                      <a:noFill/>
+                    </a:lnR>
+                    <a:lnT>
+                      <a:noFill/>
+                    </a:lnT>
+                    <a:lnB>
+                      <a:noFill/>
+                    </a:lnB>
+                    <a:noFill/>
+                  </a:tcPr>
+                </a:tc>
+                <a:extLst>
+                  <a:ext uri="{0D108BD9-81ED-4DB2-BD59-A6C34878D82A}">
+                    <a16:rowId xmlns:a16="http://schemas.microsoft.com/office/drawing/2014/main" val="272562500"/>
+                  </a:ext>
+                </a:extLst>
+              </a:tr>
+              <a:tr h="724864">
+                <a:tc>
+                  <a:txBody>
+                    <a:bodyPr/>
+                    <a:lstStyle/>
+                    <a:p>
+                      <a:r>
+                        <a:rPr lang="en-IN" sz="1400" b="1"/>
+                        <a:t>Response Measure</a:t>
+                      </a:r>
+                      <a:endParaRPr lang="en-IN" sz="1400"/>
+                    </a:p>
+                  </a:txBody>
+                  <a:tcPr marL="72486" marR="72486" marT="36243" marB="36243" anchor="ctr">
+                    <a:lnL>
+                      <a:noFill/>
+                    </a:lnL>
+                    <a:lnR>
+                      <a:noFill/>
+                    </a:lnR>
+                    <a:lnT>
+                      <a:noFill/>
+                    </a:lnT>
+                    <a:lnB>
+                      <a:noFill/>
+                    </a:lnB>
+                    <a:noFill/>
+                  </a:tcPr>
+                </a:tc>
+                <a:tc>
+                  <a:txBody>
+                    <a:bodyPr/>
+                    <a:lstStyle/>
+                    <a:p>
+                      <a:r>
+                        <a:rPr lang="en-IN" sz="1400" dirty="0"/>
+                        <a:t>The system handles large bursts of concurrent requests without request failures or unacceptable response-time degradation</a:t>
+                      </a:r>
+                    </a:p>
+                  </a:txBody>
+                  <a:tcPr marL="72486" marR="72486" marT="36243" marB="36243" anchor="ctr">
+                    <a:lnL>
+                      <a:noFill/>
+                    </a:lnL>
+                    <a:lnR>
+                      <a:noFill/>
+                    </a:lnR>
+                    <a:lnT>
+                      <a:noFill/>
+                    </a:lnT>
+                    <a:lnB>
+                      <a:noFill/>
+                    </a:lnB>
+                    <a:noFill/>
+                  </a:tcPr>
+                </a:tc>
+                <a:extLst>
+                  <a:ext uri="{0D108BD9-81ED-4DB2-BD59-A6C34878D82A}">
+                    <a16:rowId xmlns:a16="http://schemas.microsoft.com/office/drawing/2014/main" val="1136433596"/>
+                  </a:ext>
+                </a:extLst>
+              </a:tr>
+            </a:tbl>
+          </a:graphicData>
+        </a:graphic>
+      </p:graphicFrame>
     </p:spTree>
     <p:extLst>
       <p:ext uri="{BB962C8B-B14F-4D97-AF65-F5344CB8AC3E}">

</xml_diff>